<commit_message>
docs(talks): add a speaker script to the ARD deck
Write a timed, spoken script for each slide and use it as the deck's
speaker notes so it shows in Presenter View.

Co-Authored-By: Claude Opus 5.5 <noreply@anthropic.com>
Claude-Session: https://claude.ai/code/session_01A6yJd4TLSLFA7VqN9oV9Uo
</commit_message>
<xml_diff>
--- a/talks/ard/ARD-AAIF-Chennai.pptx
+++ b/talks/ard/ARD-AAIF-Chennai.pptx
@@ -131,20 +131,20 @@
   <p:extLst>
     <p:ext uri="{521415D9-36F7-43E2-AB2F-B90AF26B5E84}">
       <p14:sectionLst xmlns:p14="http://schemas.microsoft.com/office/powerpoint/2010/main">
-        <p14:section name="Introduction" id="{ba5b13da-0480-542f-00ee-aded55422056}">
+        <p14:section name="Introduction" id="{bcd6f083-92b5-886a-a711-4761f7ac7ba5}">
           <p14:sldIdLst>
             <p14:sldId id="256"/>
             <p14:sldId id="257"/>
           </p14:sldIdLst>
         </p14:section>
-        <p14:section name="Why discovery" id="{97c24ec6-ca29-2e3e-a367-ded6d6a35784}">
+        <p14:section name="Why discovery" id="{4d38a27f-6b24-669f-f760-7891aec927d8}">
           <p14:sldIdLst>
             <p14:sldId id="258"/>
             <p14:sldId id="259"/>
             <p14:sldId id="260"/>
           </p14:sldIdLst>
         </p14:section>
-        <p14:section name="What ARD is" id="{f3ba84c6-36de-1b7b-379d-b8b328612bd6}">
+        <p14:section name="What ARD is" id="{bae3ac7a-27b4-4c26-78f0-3d4e498539e6}">
           <p14:sldIdLst>
             <p14:sldId id="261"/>
             <p14:sldId id="262"/>
@@ -156,7 +156,7 @@
             <p14:sldId id="268"/>
           </p14:sldIdLst>
         </p14:section>
-        <p14:section name="My implementation" id="{2345baa3-2dc3-c761-88ce-3392fc0b84e9}">
+        <p14:section name="My implementation" id="{56e6ee09-d70d-1db0-990f-06900da6b9bf}">
           <p14:sldIdLst>
             <p14:sldId id="269"/>
             <p14:sldId id="270"/>
@@ -166,7 +166,7 @@
             <p14:sldId id="274"/>
           </p14:sldIdLst>
         </p14:section>
-        <p14:section name="Use cases" id="{8c8acde0-6519-ed1c-e856-601effe251f6}">
+        <p14:section name="Use cases" id="{a44ed9e1-0c66-f0c1-5326-7463d6acbbd2}">
           <p14:sldIdLst>
             <p14:sldId id="275"/>
             <p14:sldId id="276"/>
@@ -174,7 +174,7 @@
             <p14:sldId id="278"/>
           </p14:sldIdLst>
         </p14:section>
-        <p14:section name="Wrap-up" id="{6cd39bb4-06d3-696c-c76b-85df3b72de2b}">
+        <p14:section name="Wrap-up" id="{1095600c-15eb-99c5-a794-fed7bf8fdbbc}">
           <p14:sldIdLst>
             <p14:sldId id="279"/>
             <p14:sldId id="280"/>
@@ -1020,9 +1020,10 @@
           <a:p>
             <a:r>
               <a:rPr lang="en-US" dirty="0"/>
-              <a:t>Hi everyone, I'm Shaan. Today's talk is about Agentic Resource Discovery, or ARD: an open spec for how agents find the right tool, skill or agent at the moment they need it.
-The card on the right is the whole idea in one picture: a plain-language request goes in, and ranked resources come out. An A2A agent, an MCP server, a skill, each with a relevance score. The agent didn't have any of them installed beforehand.
-I'll cover why we need this, what the spec says, how I implemented it in an open-source project called Observal, and what it unlocks.</a:t>
+              <a:t>1. Title · 0:30
+Hi everyone, I'm Shaan, and today I want to talk about Agentic Resource Discovery, or ARD.
+[Point to the search card] This is the whole idea in one picture. You type what you need, "find me a flight booking agent", and you get back ranked resources: an A2A agent, an MCP server, a skill, each with a relevance score.
+The interesting part is that the agent had none of these installed beforehand. It found them.</a:t>
             </a:r>
             <a:endParaRPr lang="en-US" dirty="0"/>
           </a:p>
@@ -1110,9 +1111,11 @@
           <a:p>
             <a:r>
               <a:rPr lang="en-US" dirty="0"/>
-              <a:t>How does a registry find your entry? ARD has a static layer: you publish entries, and registries crawl them, like web pages.
-There are five mechanisms. The two highlighted ones are the ones a consumer MUST check: a manifest at /.well-known/ard.json, which is just a JSON document with an entries array, and a link tag with rel=ard. You can also embed the entry as JSON-LD on the page that describes your resource, add an Agentmap line to robots.txt, or publish DNS service-binding records that point at your entries or at a search endpoint.
-One practical note: the predecessor spec used /.well-known/ai-catalog.json. Consumers may still check it but don't have to, so publish ard.json.</a:t>
+              <a:t>10. Five ways to publish · 1:00
+How do registries find your entry? There's a static layer that works a lot like publishing web pages.
+There are five mechanisms. [Top two rows] These two are the ones consumers must check: a manifest at /.well-known/ard.json, which is just JSON with an entries array, and a link tag with rel="ard" in your HTML.
+[Other rows] You can also embed the entry as JSON-LD on the resource's own page, add an Agentmap line to robots.txt, or publish DNS records that point at your entries or at a search endpoint.
+One tip: older articles mention ai-catalog.json. That's the predecessor. Publish ard.json.</a:t>
             </a:r>
             <a:endParaRPr lang="en-US" dirty="0"/>
           </a:p>
@@ -1200,9 +1203,11 @@
           <a:p>
             <a:r>
               <a:rPr lang="en-US" dirty="0"/>
-              <a:t>The dynamic layer is registries. A registry ingests entries: web crawling is required, and it can also scan git, npm or OCI registries. Then it serves search.
-Every registry must expose the same HTTP REST API, so any client can talk to any registry. POST /search is mandatory: natural-language text plus optional structured filters, returning ranked results with a 0–100 relevance score. Explore returns facet counts, List gives deterministic browsing for portals, and a registry can also wrap search as an MCP tool or A2A skill so it fits naturally into an orchestrator.
-On the right is a real request shape: the text, a filter restricting results to A2A agent cards, a federation mode, which is the next slide, and a page size.</a:t>
+              <a:t>11. Registries and one REST search API · 1:00
+The dynamic layer is registries.
+[Top flow] Publishers put entries out. Registries ingest them: web crawling is required, and scanning git, npm or OCI is optional. They build an index, and clients query it.
+[Endpoints] The key rule is that every registry exposes the same REST API, so a client written once works against any registry. POST /search is mandatory. Explore gives facet counts, List gives deterministic browsing, and a registry can also wrap search as an MCP tool or an A2A skill.
+[Code] A request is simple: some text, optional filters (here, only A2A agents), a federation mode and a page size. Federation is next.</a:t>
             </a:r>
             <a:endParaRPr lang="en-US" dirty="0"/>
           </a:p>
@@ -1290,9 +1295,10 @@
           <a:p>
             <a:r>
               <a:rPr lang="en-US" dirty="0"/>
-              <a:t>Because every registry speaks the same REST API, federation is just HTTP. The client chooses how. auto, the default, means the registry queries its upstreams and merges everything into one result set. referrals means it returns its own results plus pointers to other registries the client may query. none means local only.
-The spec's own example: someone asks an orchestrator to book a flight to Tokyo and file the expense report. The orchestrator searches the enterprise registry in referrals mode. It finds the internal expense agent with score 97, plus referrals to a public finder and a travel finder. The orchestrator follows the travel referral to find a flight booking agent, then invokes each capability with its own protocol.
-This is the DNS-like part: one resolver experience across private and public catalogues.</a:t>
+              <a:t>12. Federation · 1:15
+Because everyone speaks the same API, federation is just HTTP, and the client picks the mode. [Left] auto, the default, means the registry asks its upstreams and merges everything. referrals means it returns its own results plus pointers to other registries. none means local only.
+[Diagram] This is the spec's own example. Someone says: book me a flight to Tokyo and file the expense report. The orchestrator searches the company registry in referrals mode. It gets the internal expense agent with a score of 97, plus two referrals. It follows the travel referral to find the flight agent. Then it calls each one through its own protocol.
+It's a bit like DNS: one lookup experience across private and public catalogues.</a:t>
             </a:r>
             <a:endParaRPr lang="en-US" dirty="0"/>
           </a:p>
@@ -1380,9 +1386,12 @@
           <a:p>
             <a:r>
               <a:rPr lang="en-US" dirty="0"/>
-              <a:t>One design decision I really like: relevance and trust are kept apart. The score in a search result is purely how well the entry matches your request, and the spec says in capital letters that it MUST NOT be interpreted as trust, compliance or safety.
-Trust lives in an optional trustManifest. ARD only requires one thing of it: the identity must match the publisher domain in the URN. Beyond that it can carry attestations, such as SOC 2 audits, SARIF scan results, SLSA provenance and SCITT transparency receipts, under whatever trust framework you use: SPIFFE, DIDs, your enterprise PKI. Registries are expected to verify it according to the declared framework, and can then filter or rank on it.
-Keeping these apart means a highly relevant but unverified resource never looks trustworthy just because it ranked first.</a:t>
+              <a:t>13. Relevance and trust are kept apart · 1:00
+One design choice I really like is that relevance and trust are kept apart.
+[Left] The score, 0 to 100, means only how well an entry matches your request. The spec says in capital letters that it MUST NOT be read as a trust, compliance or safety rating.
+[Right] Trust lives in the trust manifest. ARD requires one thing of it: the identity must match the publisher domain in the URN. On top of that it can carry attestations, such as SOC 2 audits, security scans or build provenance, under whatever framework you use: SPIFFE, DIDs, your company PKI. Registries verify it and can filter on it.
+Why it matters: a top-ranked result should never look trustworthy just because it ranked first.
+That's the spec. Now let me show you what it took to implement it.</a:t>
             </a:r>
             <a:endParaRPr lang="en-US" dirty="0"/>
           </a:p>
@@ -1470,10 +1479,11 @@
           <a:p>
             <a:r>
               <a:rPr lang="en-US" dirty="0"/>
-              <a:t>Now my part. Observal is an open-source registry and observability platform for AI coding agents. An agent there bundles MCP servers, skills, hooks, prompts and sandboxes. The model was install-first: you build an agent, it gets approved, you pull it into Claude Code or Kiro or Cursor, and then you start your session.
-That has exactly the gap from the start of this talk. Mid-task, the assistant has no idea the organisation already approved a security-review skill, so it rebuilds one or says it can't.
-ARD fitted cleanly because ARD deliberately doesn't define installation, review or telemetry, and Observal already had all three. So the principle I wrote into the project's first architecture decision record was: ARD says what exists; Observal says how to use it safely.
-The PR, #1744, came to 23 commits, 90 files, and about 10.8 thousand lines, 4.3 thousand of them tests.</a:t>
+              <a:t>14. Observal had a registry · 1:00
+Observal is an open-source registry and observability platform for AI coding agents. An agent there bundles MCP servers, skills, hooks, prompts and sandboxes. The model was install-first: build an agent, get it approved, pull it into Claude Code or Cursor or Kiro, then start working.
+[Orange icon] That has exactly the gap from earlier: mid-task, the assistant can't see approved resources it wasn't given.
+ARD fit cleanly because it deliberately doesn't do installation, review or telemetry, and Observal already had all three. [Card] So the principle I wrote into the project's first ADR was: ARD says what exists; Observal says how to use it safely.
+[Numbers] The pull request came to 23 commits and 90 files, about ten thousand lines, more than four thousand of them tests.</a:t>
             </a:r>
             <a:endParaRPr lang="en-US" dirty="0"/>
           </a:p>
@@ -1561,10 +1571,12 @@
           <a:p>
             <a:r>
               <a:rPr lang="en-US" dirty="0"/>
-              <a:t>The most important decision: I didn't touch the existing tables. Agents, MCP servers, skills, hooks, prompts and sandboxes all stay the source of truth for installing, reviewing and ownership.
-Instead, one adapter per kind projects each approved version into a neutral shape and writes it into a new read model, discovery_entries. The adapters also derive representative queries from the metadata, flagged as derived so they're never presented as the publisher's own claim.
-Everything ARD-facing reads from that table: the well-known manifest, search and list, permanent versioned artifacts with SHA-256 digests, and Observal's own CLI, web page and agent skill.
-The projection is one idempotent function, triggered three ways: a database session hook after any lifecycle change, a safety-net cron four times a day, and a background backfill on first boot. No existing API contract changed.</a:t>
+              <a:t>15. A projection, not a rewrite · 1:00
+The most important decision was that I didn't touch the existing tables.
+[Left] Agents, MCP servers, skills and the rest stay the source of truth for install, review and ownership.
+[Middle] One adapter per kind turns each approved version into a neutral entry and writes it to a new read model called discovery_entries. The adapters also derive representative queries from metadata, flagged as derived so they're never passed off as the publisher's own words.
+[Right] Everything ARD-facing reads from that table: the manifest, search, versioned artifacts with digests, and Observal's CLI, web page and agent skill.
+Keeping it fresh is one idempotent function, triggered after every change, by a safety-net job four times a day, and on first boot. No existing API changed.</a:t>
             </a:r>
             <a:endParaRPr lang="en-US" dirty="0"/>
           </a:p>
@@ -1652,8 +1664,9 @@
           <a:p>
             <a:r>
               <a:rPr lang="en-US" dirty="0"/>
-              <a:t>Every resource got exactly one permanent URN: urn:air, the deployment's domain, the kind as namespace, and the resource's UUID. Two details: I used the UUID, not the human-readable slug, because slugs change on rename and ownership transfer, and ARD wants a stable handle. And the publisher domain is pinned the first time a real domain is configured, so identifiers don't silently change if the deployment moves.
-Then the endpoints. Four come from the spec: the well-known manifest (we also serve the older ai-catalog path), search, list, and explore, which honestly answers 501 until facets ship. Two are mine: fetching one complete entry by URN, since the spec has no such operation and our CLI needed one, and permanent artifact URLs that serve the exact bytes of a version with a digest, so the same version always returns the same content.</a:t>
+              <a:t>16. Six endpoints · 0:45
+Every resource got one permanent URN. [Chips] Two details here. I used the internal UUID, not the readable name, because names change on rename or transfer and a URN mustn't. And the publisher domain is pinned once, so identifiers don't change if the deployment moves.
+[Table] Four endpoints come from the spec: the manifest, search, list, and explore, which honestly returns 501 until facets ship. Two are mine: fetching one full entry by URN, because the spec has no operation for that, and permanent artifact URLs that always return the exact same bytes for a version, with a digest.</a:t>
             </a:r>
             <a:endParaRPr lang="en-US" dirty="0"/>
           </a:p>
@@ -1741,9 +1754,10 @@
           <a:p>
             <a:r>
               <a:rPr lang="en-US" dirty="0"/>
-              <a:t>For search I deliberately avoided new infrastructure. Postgres does what it's good at: visibility, structured filters and a trigram-indexed prefilter, handing back at most five thousand candidates. Then a deterministic Python ranker scores each query word against four fields, with a name match counting most and the description least. Ranking in Python means it behaves identically in SQLite tests and Postgres production, and it can explain itself: every result says which words matched.
-I didn't want to guess whether that's good enough, so there's a benchmark in CI: 26 realistic resources and 47 requests written the way developers actually ask. Recall at 5 is 0.96 for the ranker and 0.94 end to end; MRR is 0.93 and 0.92. The grey bars are floors the build enforces, and the rule is they only move up.
-The misses are pure synonyms, like PRs versus pull requests. That's where semantic retrieval would help, and the spec explicitly allows registries to use embeddings behind the same API.</a:t>
+              <a:t>17. Postgres narrows, Python ranks, CI checks · 1:00
+For search, I avoided new infrastructure. [Step 1] Postgres narrows: visibility rules, filters and a trigram-indexed text match, giving at most five thousand candidates. [Step 2] Python ranks: each query word is scored against the name, the representative queries, the capabilities and the description, in that order of weight. [Step 3] And every result explains itself with the words that matched.
+[Chart] I didn't want to guess whether that's good enough, so there's a benchmark in CI: 47 requests written the way developers actually ask. Recall at 5 is 0.96 for the ranker and 0.94 end to end. The grey bars are floors: drop below them and the build fails, and the rule is that floors only go up.
+The misses are synonyms, like "PRs" versus "pull requests". That's where semantic search would come in next.</a:t>
             </a:r>
             <a:endParaRPr lang="en-US" dirty="0"/>
           </a:p>
@@ -1831,11 +1845,12 @@
           <a:p>
             <a:r>
               <a:rPr lang="en-US" dirty="0"/>
-              <a:t>Discovery could easily become a back door around a registry's governance, so I built in four guardrails.
-One: score means relevance only, exactly as the spec says. Approval, harness compatibility and availability are separate fields, and policy is a filter before ranking, never a hidden weight.
-Two: discovery never shows more than the registry already would. Drafts and rejected items only reach their owners, and anonymous search is off unless an admin turns on the public registry.
-Three: search text can contain sensitive things, such as incident details or unreleased product names. I honour the spec's default federation mode, auto, literally, but bounded by an admin allowlist that starts empty. So queries never leave the deployment unless someone decides they should.
-Four: text resources like approved skills and prompts load straight into the session. Anything that changes a developer's setup, or can write or delete, still asks first.</a:t>
+              <a:t>18. Guardrails · 1:00
+Discovery could easily become a back door around a registry's rules, so I built in four guardrails.
+[Top left] Score means relevance only, as the spec says. Approval and harness support are separate fields, and policy filters run before ranking.
+[Top right] Discovery never shows more than the registry already would. Drafts and rejected items only reach their owners.
+[Bottom left] Search text stays home. People type sensitive things into search, such as incident details or unreleased product names, so federation only reaches upstreams an admin allowlists, and that list starts empty.
+[Bottom right] Read freely, write with consent. Approved text loads straight away; anything that changes your setup asks first.</a:t>
             </a:r>
             <a:endParaRPr lang="en-US" dirty="0"/>
           </a:p>
@@ -1923,12 +1938,13 @@
           <a:p>
             <a:r>
               <a:rPr lang="en-US" dirty="0"/>
-              <a:t>Five lessons I'd pass on to anyone implementing a young spec.
-One: pin it. I vendored the JSON Schema, JSON-LD context, CDDL grammar, OpenAPI file and the official conformance tool, unmodified, at one commit, and run conformance in CI. Updating the spec is then a deliberate, reviewed change, not a surprise.
-Two: write the decisions down. The ADR fixed ten decisions up front, like the identifier scheme and the federation default, so reviewers argued about decisions, not code.
+              <a:t>19. What I learned · 1:15
+Five lessons from implementing a spec that was still moving.
+One: pin it. I vendored the schemas and the official conformance tool at one commit and run them in CI, so updating the spec is a reviewed change, not a surprise.
+Two: write decisions down. An ADR with ten decisions meant reviewers debated choices, not code.
 Three: project, don't rewrite. Nothing existing broke.
-Four: the spec moved while I was building. The well-known path changed from ai-catalog.json to ard.json, the URN prefix from urn:ai to urn:air, and the MCP media type gained '-card'. So accept the old spellings on input, keep the original, and always emit the canonical form.
-Five: be honest. The spec says every registry must crawl entry sources. I haven't built that yet, so Observal is an ARD publisher and search endpoint, not yet a full registry, and the ADR says so.</a:t>
+Four: the spec changed while I was building. The well-known path, the URN prefix and the MCP media type all got new names. So accept the old spellings on input and always emit the new ones.
+Five: be honest about conformance. The spec says registries must crawl, and I haven't built crawling yet, so Observal is a publisher and search endpoint, not a full registry, and the docs say so.</a:t>
             </a:r>
             <a:endParaRPr lang="en-US" dirty="0"/>
           </a:p>
@@ -2016,8 +2032,9 @@
           <a:p>
             <a:r>
               <a:rPr lang="en-US" dirty="0"/>
-              <a:t>A quick word about me: I'm an open-source contributor, and over the last couple of months I implemented ARD in Observal, an open-source registry and observability platform for AI coding agents. So this talk is half spec and half field notes.
-Five parts: why agents need discovery at all; what ARD actually specifies; how I implemented it, including what went wrong and what I'd do again; the use cases it unlocks; and how you can try it on your own project this week.</a:t>
+              <a:t>2. Agenda · 0:45
+A quick intro: I'm an open-source contributor, and over the last couple of months I implemented ARD in Observal, an open-source registry and observability platform for AI coding agents. So this talk is half spec, half field notes.
+Five parts: why agents need discovery at all, what ARD actually specifies, how I implemented it and what I learned, what it unlocks, and how you can try it on your own project this week.</a:t>
             </a:r>
             <a:endParaRPr lang="en-US" dirty="0"/>
           </a:p>
@@ -2105,9 +2122,10 @@
           <a:p>
             <a:r>
               <a:rPr lang="en-US" dirty="0"/>
-              <a:t>Now the use cases, starting with the one that motivated all of this: the agent searches before it reinvents.
-Observal ships an agent skill to every harness it supports, and I rewrote it so that at the start of real work, such as a review, writing tests or docs, or querying a database, the assistant runs observal discover search with the task. It gets ranked candidates with the words that matched, can inspect the best one, and then use it. For a skill, use fetches the exact approved version from its permanent URL and loads it straight into the session.
-The output here is simplified, and the resources are examples. Two behaviours matter: an empty result is a valid answer, and the skill tells the agent to retry once with different words before concluding nothing exists.</a:t>
+              <a:t>20. Agents search before they reinvent · 1:00
+So what does this unlock? The first use case is the one that started all of this: agents search before they reinvent.
+[Terminal] Observal ships an agent skill to every coding harness it supports. I rewrote it so that at the start of real work, such as a review, writing tests or querying a database, the assistant searches first. It gets ranked candidates with the matching words, can inspect the best one, then use it. For a skill, the exact approved version is loaded straight into the session, and the use is recorded.
+[Note] The output here is simplified and the resource names are examples. An empty result is a valid answer: the agent retries once with different words, then gets on with the job.</a:t>
             </a:r>
             <a:endParaRPr lang="en-US" dirty="0"/>
           </a:p>
@@ -2195,11 +2213,10 @@
           <a:p>
             <a:r>
               <a:rPr lang="en-US" dirty="0"/>
-              <a:t>What happens on use depends on what the resource touches, and this is where Observal's governance does the work ARD leaves out.
-Skills and prompts are just text, so they're available now: loaded into the current context.
-MCP servers, agents and sandboxes change your harness configuration. For those, use writes nothing; it hands back the normal install command, which asks before touching config and takes effect next session.
-Hooks are never activated implicitly. And unapproved resources, or ones your harness doesn't support, are refused unless you explicitly override.
-Under the hood each harness has verified runtime facts recorded and tested, such as how MCP servers are installed and whether hooks can inject context, so these decisions are based on data, not assumptions.</a:t>
+              <a:t>21. Text loads now; setup changes ask first · 0:45
+What happens on "use" depends on what the resource touches. This is where Observal's governance does the work ARD leaves out.
+[Orange] Skills and prompts are just text, so they load now. [Violet] MCP servers, agents and sandboxes change your configuration, so nothing is written automatically. You get the normal install command, which asks first and applies after a restart. [Lilac] Hooks are never activated implicitly.
+[Bottom] And unapproved resources, or ones your harness doesn't support, are refused unless you explicitly override.</a:t>
             </a:r>
             <a:endParaRPr lang="en-US" dirty="0"/>
           </a:p>
@@ -2287,9 +2304,10 @@
           <a:p>
             <a:r>
               <a:rPr lang="en-US" dirty="0"/>
-              <a:t>Next: because every use goes through one place, we know what a session actually relied on.
-Each use, whether through discover or a normal install, appends one line to a local capability lock: the URN, exact version and digest, harness, folder and time. When the session's telemetry is uploaded, the uses that fall inside that session's window are attached to it. So in the dashboard you can see which approved resources a session used, with no new tracking channel.
-And then the loop closes. If a combination worked, say a security skill, a checklist prompt and the GitHub MCP server, agent init --from-capabilities turns it into a draft agent pinned to those exact versions. Ad-hoc discovery becomes a curated, reviewable asset for the next person.</a:t>
+              <a:t>22. Every use is recorded · 1:00
+Because every use goes through one place, we know what a session actually relied on.
+[Walk left to right] Each use writes one local line: which resource, its exact version and digest, which harness, which folder, and when. When the session's telemetry is uploaded, those uses are attached to it. So the dashboard shows which approved resources a session used, with no new tracking.
+[Command] Then the loop closes. If a combination worked, say a security skill, a checklist and the GitHub MCP server, this command turns it into a draft agent pinned to those exact versions. Ad-hoc discovery becomes a reviewed, reusable asset for the next person.</a:t>
             </a:r>
             <a:endParaRPr lang="en-US" dirty="0"/>
           </a:p>
@@ -2377,11 +2395,12 @@
           <a:p>
             <a:r>
               <a:rPr lang="en-US" dirty="0"/>
-              <a:t>Zooming out from Observal, here's what ARD enables across the ecosystem.
-If you build an MCP server, skill or agent, you publish one ard.json and any ARD registry can find you. No marketplace submission per platform.
-Companies can run an internal registry that answers with approved resources first and refers out to public registries for the rest, which is the federation example from earlier.
-Coding agents can find tools at runtime instead of at config time; GitHub's agent finder and Hugging Face's Discover Tool are already doing it.
-And governed catalogues, like the one I built in Observal, can add approval, visibility and telemetry on top while still speaking the open standard. That's the point Guha made: open ecosystems, not walled catalogues.</a:t>
+              <a:t>23. Findable everywhere · 1:00
+Zooming out from Observal, here's what ARD enables for everyone.
+[Card 1] If you build an MCP server, skill or agent, you publish one ard.json and any ARD registry can find you. No separate submission to every marketplace.
+[Card 2] Companies can run an internal registry that answers with approved resources first and refers out to public ones for the rest. That's the federation example from earlier.
+[Card 3] Coding agents can find tools at runtime instead of at config time. GitHub and Hugging Face already do it.
+[Card 4] And governed catalogues like the one I built can add approval and telemetry on top while still speaking the open standard. Open ecosystems, not walled catalogues.</a:t>
             </a:r>
             <a:endParaRPr lang="en-US" dirty="0"/>
           </a:p>
@@ -2469,10 +2488,11 @@
           <a:p>
             <a:r>
               <a:rPr lang="en-US" dirty="0"/>
-              <a:t>If you take one thing home: you can publish an ARD entry for your own project this week. It's a small JSON file.
-Step one, put an ard.json at /.well-known on your domain, with an entries array. Here's a made-up Chennai weather MCP server: the four required fields in coral, and please write good representative queries, because that's what search runs on.
-Step two, validate it with the official conformance tool from the ard-spec repository; publisher mode fetches your well-known file and checks it.
-Step three, join in. The spec is open on GitHub: issues for normative changes, pull requests welcome for examples, tooling and reference implementations. It's version 0.91, so feedback now really shapes it.</a:t>
+              <a:t>24. Try it this week · 1:00
+If you take one thing home: you can publish an ARD entry for your own project this week. It's one small file.
+[Code] Step one: put an ard.json under /.well-known on your domain. Here's a made-up Chennai weather MCP server. It has the four required fields, and please write good representative queries, because that's what search runs on.
+[Top right] Step two: validate it with the official conformance tool from the ard-spec repo. Publisher mode fetches your file and checks it.
+[Bottom right] Step three: join in. The spec is at version 0.91, so feedback now actually shapes it. Issues for spec changes; pull requests welcome for examples, tools and implementations.</a:t>
             </a:r>
             <a:endParaRPr lang="en-US" dirty="0"/>
           </a:p>
@@ -2560,8 +2580,9 @@
           <a:p>
             <a:r>
               <a:rPr lang="en-US" dirty="0"/>
-              <a:t>To wrap up: agents shouldn't be limited to what someone wired up in advance. ARD gives them a search layer: a small entry, a domain-anchored name, one REST API and federation across registries, with trust kept separate from relevance. I showed how I implemented it in an open-source registry, and what that unlocks.
-Thank you. Happy to take questions, and the spec and the Observal repository are linked here.</a:t>
+              <a:t>25. Thank you · Q&amp;A
+To wrap up: agents shouldn't be limited to what someone wired up in advance. ARD gives them a search layer: a small entry, a permanent domain-anchored name, one REST API, federation across registries, and trust kept separate from relevance. And I've shown you what it took to build that into a real open-source registry.
+Thank you. I'm happy to take questions.</a:t>
             </a:r>
             <a:endParaRPr lang="en-US" dirty="0"/>
           </a:p>
@@ -2649,9 +2670,11 @@
           <a:p>
             <a:r>
               <a:rPr lang="en-US" dirty="0"/>
-              <a:t>Here's the problem. Today an agent can only use the tools someone connected to it ahead of time: the MCP servers in its config file, the skills in its folder.
-Meanwhile there are thousands of MCP servers, A2A agents and skills out there, including ones inside your own company. The grey squares are all real capabilities. The agent can't see them, so it either rebuilds something that already exists or tells you it can't help.
-The ARD announcement put it nicely: the web was there, but it was dark, until search engines came along.</a:t>
+              <a:t>3. Agents only use what someone wired up in advance · 1:00
+Quick show of hands: how many of you have more than five MCP servers configured right now? More than twenty? [Pause]
+Today an agent can only use what someone wired up in advance: the MCP servers in its config, the skills in its folder. [Point to the orange squares] That's these three.
+But there are thousands of MCP servers, A2A agents and skills out there, including inside your own company. All these grey squares. The agent can't see them, so it either rebuilds something that already exists or tells you it can't help.
+The capability was there. It just wasn't findable.</a:t>
             </a:r>
             <a:endParaRPr lang="en-US" dirty="0"/>
           </a:p>
@@ -2739,8 +2762,11 @@
           <a:p>
             <a:r>
               <a:rPr lang="en-US" dirty="0"/>
-              <a:t>The obvious fix is to connect everything. But most agents choose tools by putting every tool's description into the context window, every turn. With five tools that's fine. With five thousand, the descriptions crowd out the actual task, cost tokens, and make selection worse.
-ARD's answer, in section 3.2 of the spec, is to move selection outside the model. A dedicated search service indexes thousands of resources, and the agent only loads the few that match the current task. It's information retrieval rather than prompt stuffing.</a:t>
+              <a:t>4. Loading every tool into the prompt doesn't scale · 1:00
+The obvious fix is to connect everything. That breaks fast.
+[Left side] Most agents pick tools by putting every tool's description into the context window, on every turn. With five tools that's fine. With five thousand, the descriptions crowd out your actual task, burn tokens, and the model chooses worse.
+[Right side] ARD's answer is to move selection out of the model. A search service indexes thousands of resources, and the agent loads only the few that match this task. Plenty of room left in the context.
+It's the same shift the web went through, which brings me to this quote.</a:t>
             </a:r>
             <a:endParaRPr lang="en-US" dirty="0"/>
           </a:p>
@@ -2828,8 +2854,9 @@
           <a:p>
             <a:r>
               <a:rPr lang="en-US" dirty="0"/>
-              <a:t>This line is from R.V. Guha's post introducing ARD. Guha created RSS and schema.org, so he's seen this movie before. Early on, the web was organised in hand-curated directories, and it took search engines to make it usable.
-Agentic resources are in the directory era right now: curated lists, marketplaces, config files. ARD is an attempt to give them a search layer.</a:t>
+              <a:t>5. "Search engines lit the web up." · 0:30
+That's R.V. Guha, introducing ARD in June. Guha helped create RSS and schema.org, so he's seen this pattern before.
+Early on, the web lived in hand-curated directories, and search engines made it usable. Agentic resources are in that directory era right now: curated lists, marketplaces, config files. ARD is a search layer for them.</a:t>
             </a:r>
             <a:endParaRPr lang="en-US" dirty="0"/>
           </a:p>
@@ -2917,9 +2944,11 @@
           <a:p>
             <a:r>
               <a:rPr lang="en-US" dirty="0"/>
-              <a:t>So what is ARD? It's an open specification announced on 17 June 2026. The current version is 0.91, still marked as a Proposal, Apache-licensed. The authors are Junjie Bu from Google, R.V. Guha, and Shaun Smith from Hugging Face, and it was developed with a long list of companies: Cisco, Databricks, GitHub, GoDaddy, Google, Hugging Face, Microsoft, Nvidia, Salesforce, ServiceNow, Snowflake.
-There are already two reference implementations. GitHub's agent finder lets Copilot discover MCP servers, skills and agents at runtime, and Hugging Face's Discover Tool does semantic search across thousands of skills, apps and MCP servers.
-It's an open spec on GitHub, and normative changes start as issues, so anyone here can take part.</a:t>
+              <a:t>6. ARD is an open spec · 1:00
+So what is ARD, concretely? It's an open specification, announced on 17 June this year. The current version is 0.91, still marked as a Proposal, and it's Apache-licensed.
+The authors are Junjie Bu from Google, R.V. Guha, and Shaun Smith from Hugging Face. [Gesture to the chips] It's developed with a long list of companies: Cisco, Databricks, GitHub, Google, Microsoft, Nvidia, Salesforce and more.
+It's not just a document. There are already two reference implementations: GitHub's agent finder, which lets Copilot discover tools at runtime, and Hugging Face's Discover Tool.
+And it's open on GitHub. Spec changes start as issues, so anyone in this room can take part.</a:t>
             </a:r>
             <a:endParaRPr lang="en-US" dirty="0"/>
           </a:p>
@@ -3007,9 +3036,11 @@
           <a:p>
             <a:r>
               <a:rPr lang="en-US" dirty="0"/>
-              <a:t>Where does ARD sit? Before invocation. The agent asks ARD what exists for the task, gets back ranked candidates, and then calls the chosen one through that resource's own protocol: MCP for an MCP server, A2A for an agent, and so on.
-ARD doesn't replace MCP, A2A or Skills. It's an envelope around them, and the spec is explicit about what it leaves to others: authentication is delegated to the resource's protocol, and distribution, whether OCI, npm or git, is infrastructure.
-For an AAIF audience that's a nice fit: MCP and AGENTS.md describe how agents talk to tools; ARD is how they find those tools in the first place.</a:t>
+              <a:t>7. ARD runs before invocation · 1:00
+Where does ARD fit? Before invocation.
+[Top] The agent asks: what exists for this task? [Middle] ARD answers that: it describes, publishes, searches and federates. [Bottom] Then the agent calls the chosen resource through that resource's own protocol: MCP for an MCP server, A2A for an agent, and so on.
+So ARD doesn't replace MCP, A2A or Skills. It's an envelope around them. [Right] The spec is explicit about what it leaves to others: authentication belongs to the resource's protocol, distribution to OCI or npm, invocation to MCP or A2A.
+For this community, a simple way to put it: MCP is how agents talk to tools; ARD is how they find them.</a:t>
             </a:r>
             <a:endParaRPr lang="en-US" dirty="0"/>
           </a:p>
@@ -3097,10 +3128,11 @@
           <a:p>
             <a:r>
               <a:rPr lang="en-US" dirty="0"/>
-              <a:t>The unit ARD works with is the entry: one small JSON-LD document per resource. This one is straight from the spec, a weather MCP server.
-Four things are required, shown in coral: an identifier, a display name, a type, which is a media type like application/mcp-server-card+json, and either a URL to the artifact or the artifact inline as data.
-The interesting one is representativeQueries, in violet: two to five natural-language requests this resource can serve. That's the signal a registry builds its index from. It's only a SHOULD, but without it your entry is a valid catalogue listing that search simply can't find.
-Everything else is optional. And because it's JSON-LD, you can bring your own vocabulary through @context, and those terms become filter dimensions without anyone changing the spec.</a:t>
+              <a:t>8. One small JSON-LD entry · 1:15
+The basic unit is the entry: one small JSON-LD document per resource. This one comes straight from the spec, a weather MCP server.
+[Coral keys] Four fields are required: an identifier, a display name, a type, which is a media type like mcp-server-card+json, and a url pointing at the artifact. Or you can put the artifact inline as data.
+[Violet key] The one I want you to remember is representativeQueries: two to five plain-language requests this resource can handle. That's what search indexes. It's only a SHOULD, but leave it out and your entry is valid and nobody finds it.
+[Grey keys] Everything else is optional. And because it's JSON-LD, you can add your own vocabulary through @context, and those terms become filters without anyone changing the spec.</a:t>
             </a:r>
             <a:endParaRPr lang="en-US" dirty="0"/>
           </a:p>
@@ -3188,8 +3220,10 @@
           <a:p>
             <a:r>
               <a:rPr lang="en-US" dirty="0"/>
-              <a:t>Every entry has a URN identifier: urn:air, then the publisher's domain, an optional namespace, and the resource name. A solo developer's skill on GitHub can be urn:air:github.com:alice-dev:pptx-creator.
-Why a URN and not just a URL? Three reasons from Appendix C. It's stable: the URL says where the resource lives today, the URN names it permanently. It's verifiable: the publisher segment must match the identity in the entry's trust manifest, which is ARD's defence against namespace squatting. You can't publish urn:air:google.com anything without an attestation from google.com. And it's globally unique for free, because DNS already guarantees unique domains, so federated catalogues merge without collisions and without a central naming authority.</a:t>
+              <a:t>9. The identifier names the resource · 1:15
+Every entry has an identifier that starts with urn:air.
+[Walk the chips left to right] "urn" says this is a name, not an address. "air" is ARD's namespace. Early drafts used urn:ai, but URN rules need more than two characters, so it became air. Then comes the publisher, which must be a real domain, an optional namespace, and the resource name.
+Why not just use the URL? Three reasons. [Cards] Stable: hosting moves, the name doesn't. Verifiable: the publisher domain has to match the identity in the entry's trust manifest, so nobody can publish urn:air:google.com-anything without proof from google.com. And globally unique for free: DNS already makes domains unique, so catalogues from different registries merge without collisions, and nobody has to run a naming committee.</a:t>
             </a:r>
             <a:endParaRPr lang="en-US" dirty="0"/>
           </a:p>

</xml_diff>

<commit_message>
docs(talks): label the context-window slide in the ARD deck
Name the task and each tool description, mark the window as full, and
show the free space left after a search so the comparison reads at a
glance. Update the speaker script to walk through the labels.

Co-Authored-By: Claude Opus 5.5 <noreply@anthropic.com>
Claude-Session: https://claude.ai/code/session_01A6yJd4TLSLFA7VqN9oV9Uo
</commit_message>
<xml_diff>
--- a/talks/ard/ARD-AAIF-Chennai.pptx
+++ b/talks/ard/ARD-AAIF-Chennai.pptx
@@ -131,20 +131,20 @@
   <p:extLst>
     <p:ext uri="{521415D9-36F7-43E2-AB2F-B90AF26B5E84}">
       <p14:sectionLst xmlns:p14="http://schemas.microsoft.com/office/powerpoint/2010/main">
-        <p14:section name="Introduction" id="{bcd6f083-92b5-886a-a711-4761f7ac7ba5}">
+        <p14:section name="Introduction" id="{b712118f-3b78-91a2-8146-aa8de8a1043f}">
           <p14:sldIdLst>
             <p14:sldId id="256"/>
             <p14:sldId id="257"/>
           </p14:sldIdLst>
         </p14:section>
-        <p14:section name="Why discovery" id="{4d38a27f-6b24-669f-f760-7891aec927d8}">
+        <p14:section name="Why discovery" id="{4f1310d1-576a-6635-a207-5570e3589945}">
           <p14:sldIdLst>
             <p14:sldId id="258"/>
             <p14:sldId id="259"/>
             <p14:sldId id="260"/>
           </p14:sldIdLst>
         </p14:section>
-        <p14:section name="What ARD is" id="{bae3ac7a-27b4-4c26-78f0-3d4e498539e6}">
+        <p14:section name="What ARD is" id="{512bd263-5f6d-e3e9-477d-fdd2a14bc56a}">
           <p14:sldIdLst>
             <p14:sldId id="261"/>
             <p14:sldId id="262"/>
@@ -156,7 +156,7 @@
             <p14:sldId id="268"/>
           </p14:sldIdLst>
         </p14:section>
-        <p14:section name="My implementation" id="{56e6ee09-d70d-1db0-990f-06900da6b9bf}">
+        <p14:section name="My implementation" id="{f5911bd0-5f51-ec36-9aab-e6f9a0a12047}">
           <p14:sldIdLst>
             <p14:sldId id="269"/>
             <p14:sldId id="270"/>
@@ -166,7 +166,7 @@
             <p14:sldId id="274"/>
           </p14:sldIdLst>
         </p14:section>
-        <p14:section name="Use cases" id="{a44ed9e1-0c66-f0c1-5326-7463d6acbbd2}">
+        <p14:section name="Use cases" id="{1ea41880-d953-bd0f-814d-cd69afe96518}">
           <p14:sldIdLst>
             <p14:sldId id="275"/>
             <p14:sldId id="276"/>
@@ -174,7 +174,7 @@
             <p14:sldId id="278"/>
           </p14:sldIdLst>
         </p14:section>
-        <p14:section name="Wrap-up" id="{1095600c-15eb-99c5-a794-fed7bf8fdbbc}">
+        <p14:section name="Wrap-up" id="{aa04ef0e-4e72-b44e-2993-d9565a02a685}">
           <p14:sldIdLst>
             <p14:sldId id="279"/>
             <p14:sldId id="280"/>
@@ -2764,8 +2764,8 @@
               <a:rPr lang="en-US" dirty="0"/>
               <a:t>4. Loading every tool into the prompt doesn't scale · 1:00
 The obvious fix is to connect everything. That breaks fast.
-[Left side] Most agents pick tools by putting every tool's description into the context window, on every turn. With five tools that's fine. With five thousand, the descriptions crowd out your actual task, burn tokens, and the model chooses worse.
-[Right side] ARD's answer is to move selection out of the model. A search service indexes thousands of resources, and the agent loads only the few that match this task. Plenty of room left in the context.
+[Left box] This box is the model's context window. The orange row is your task: book a flight to Tokyo. Every purple row is a tool description: GitHub, Slack, Jira, Postgres, and thousands more. Most agents put every connected tool's description in here, on every turn. With five tools that's fine. With five thousand, the window is full before your task gets a look in: it burns tokens, slows things down, and the model chooses worse.
+[Right side] ARD moves the choosing out of the model. Your task goes to a search service that indexes thousands of resources, and only the top three matches come back into the context: a travel agent, a flight-status server, a trip-planning skill. [Point to the dashed box] Everything else stays free for the actual work.
 It's the same shift the web went through, which brings me to this quote.</a:t>
             </a:r>
             <a:endParaRPr lang="en-US" dirty="0"/>
@@ -23180,7 +23180,7 @@
                   <a:schemeClr val="tx1"/>
                 </a:solidFill>
               </a:rPr>
-              <a:t>Today: everything goes into context</a:t>
+              <a:t>Today: every tool, every turn</a:t>
             </a:r>
             <a:endParaRPr lang="en-US" sz="1800" dirty="0"/>
           </a:p>
@@ -23195,11 +23195,11 @@
         <p:spPr>
           <a:xfrm>
             <a:off x="548640" y="2468880"/>
-            <a:ext cx="5120640" cy="2971800"/>
+            <a:ext cx="5394960" cy="3108960"/>
           </a:xfrm>
           <a:prstGeom prst="roundRect">
             <a:avLst>
-              <a:gd name="adj" fmla="val 2462"/>
+              <a:gd name="adj" fmla="val 2353"/>
             </a:avLst>
           </a:prstGeom>
           <a:solidFill>
@@ -23215,14 +23215,108 @@
       </p:sp>
       <p:sp>
         <p:nvSpPr>
-          <p:cNvPr id="6" name="Task bar left"/>
-          <p:cNvSpPr/>
-          <p:nvPr/>
-        </p:nvSpPr>
-        <p:spPr>
-          <a:xfrm>
-            <a:off x="777240" y="2651760"/>
-            <a:ext cx="4663440" cy="219456"/>
+          <p:cNvPr id="6" name="Text 4"/>
+          <p:cNvSpPr txBox="1"/>
+          <p:nvPr/>
+        </p:nvSpPr>
+        <p:spPr>
+          <a:xfrm>
+            <a:off x="777240" y="2587752"/>
+            <a:ext cx="2103120" cy="256032"/>
+          </a:xfrm>
+          <a:prstGeom prst="rect">
+            <a:avLst/>
+          </a:prstGeom>
+          <a:noFill/>
+          <a:ln/>
+        </p:spPr>
+        <p:txBody>
+          <a:bodyPr wrap="square" lIns="0" tIns="0" rIns="0" bIns="0" rtlCol="0" anchor="ctr"/>
+          <a:lstStyle/>
+          <a:p>
+            <a:pPr indent="0" marL="0">
+              <a:buNone/>
+            </a:pPr>
+            <a:r>
+              <a:rPr lang="en-US" sz="1100" b="1" spc="100" kern="0" dirty="0">
+                <a:solidFill>
+                  <a:schemeClr val="accent6"/>
+                </a:solidFill>
+              </a:rPr>
+              <a:t>CONTEXT WINDOW</a:t>
+            </a:r>
+            <a:endParaRPr lang="en-US" sz="1100" dirty="0"/>
+          </a:p>
+        </p:txBody>
+      </p:sp>
+      <p:sp>
+        <p:nvSpPr>
+          <p:cNvPr id="7" name="Full chip"/>
+          <p:cNvSpPr/>
+          <p:nvPr/>
+        </p:nvSpPr>
+        <p:spPr>
+          <a:xfrm>
+            <a:off x="4937760" y="2578608"/>
+            <a:ext cx="777240" cy="274320"/>
+          </a:xfrm>
+          <a:prstGeom prst="roundRect">
+            <a:avLst>
+              <a:gd name="adj" fmla="val 50000"/>
+            </a:avLst>
+          </a:prstGeom>
+          <a:solidFill>
+            <a:schemeClr val="accent2"/>
+          </a:solidFill>
+          <a:ln/>
+        </p:spPr>
+      </p:sp>
+      <p:sp>
+        <p:nvSpPr>
+          <p:cNvPr id="8" name="Text 6"/>
+          <p:cNvSpPr txBox="1"/>
+          <p:nvPr/>
+        </p:nvSpPr>
+        <p:spPr>
+          <a:xfrm>
+            <a:off x="4937760" y="2578608"/>
+            <a:ext cx="777240" cy="274320"/>
+          </a:xfrm>
+          <a:prstGeom prst="rect">
+            <a:avLst/>
+          </a:prstGeom>
+          <a:noFill/>
+          <a:ln/>
+        </p:spPr>
+        <p:txBody>
+          <a:bodyPr wrap="square" lIns="0" tIns="0" rIns="0" bIns="0" rtlCol="0" anchor="ctr"/>
+          <a:lstStyle/>
+          <a:p>
+            <a:pPr algn="ctr" indent="0" marL="0">
+              <a:buNone/>
+            </a:pPr>
+            <a:r>
+              <a:rPr lang="en-US" sz="1200" b="1" dirty="0">
+                <a:solidFill>
+                  <a:schemeClr val="bg1"/>
+                </a:solidFill>
+              </a:rPr>
+              <a:t>Full</a:t>
+            </a:r>
+            <a:endParaRPr lang="en-US" sz="1200" dirty="0"/>
+          </a:p>
+        </p:txBody>
+      </p:sp>
+      <p:sp>
+        <p:nvSpPr>
+          <p:cNvPr id="9" name="Task bar left"/>
+          <p:cNvSpPr/>
+          <p:nvPr/>
+        </p:nvSpPr>
+        <p:spPr>
+          <a:xfrm>
+            <a:off x="777240" y="2971800"/>
+            <a:ext cx="4937760" cy="274320"/>
           </a:xfrm>
           <a:prstGeom prst="roundRect">
             <a:avLst>
@@ -23237,330 +23331,510 @@
       </p:sp>
       <p:sp>
         <p:nvSpPr>
-          <p:cNvPr id="7" name="Description 1"/>
-          <p:cNvSpPr/>
-          <p:nvPr/>
-        </p:nvSpPr>
-        <p:spPr>
-          <a:xfrm>
-            <a:off x="777240" y="2962656"/>
-            <a:ext cx="4663440" cy="201168"/>
+          <p:cNvPr id="10" name="Text 8"/>
+          <p:cNvSpPr txBox="1"/>
+          <p:nvPr/>
+        </p:nvSpPr>
+        <p:spPr>
+          <a:xfrm>
+            <a:off x="905256" y="2971800"/>
+            <a:ext cx="4754880" cy="274320"/>
+          </a:xfrm>
+          <a:prstGeom prst="rect">
+            <a:avLst/>
+          </a:prstGeom>
+          <a:noFill/>
+          <a:ln/>
+        </p:spPr>
+        <p:txBody>
+          <a:bodyPr wrap="square" lIns="0" tIns="0" rIns="0" bIns="0" rtlCol="0" anchor="ctr"/>
+          <a:lstStyle/>
+          <a:p>
+            <a:pPr indent="0" marL="0">
+              <a:buNone/>
+            </a:pPr>
+            <a:r>
+              <a:rPr lang="en-US" sz="1200" b="1" dirty="0">
+                <a:solidFill>
+                  <a:schemeClr val="tx1"/>
+                </a:solidFill>
+              </a:rPr>
+              <a:t>Task: flight to Tokyo</a:t>
+            </a:r>
+            <a:endParaRPr lang="en-US" sz="1200" dirty="0"/>
+          </a:p>
+        </p:txBody>
+      </p:sp>
+      <p:sp>
+        <p:nvSpPr>
+          <p:cNvPr id="11" name="Tool description 1"/>
+          <p:cNvSpPr/>
+          <p:nvPr/>
+        </p:nvSpPr>
+        <p:spPr>
+          <a:xfrm>
+            <a:off x="777240" y="3383280"/>
+            <a:ext cx="4937760" cy="274320"/>
           </a:xfrm>
           <a:prstGeom prst="roundRect">
             <a:avLst>
-              <a:gd name="adj" fmla="val 18182"/>
+              <a:gd name="adj" fmla="val 16667"/>
             </a:avLst>
           </a:prstGeom>
           <a:solidFill>
-            <a:schemeClr val="accent3">
-              <a:alpha val="80000"/>
-            </a:schemeClr>
+            <a:schemeClr val="accent3"/>
           </a:solidFill>
           <a:ln/>
         </p:spPr>
       </p:sp>
       <p:sp>
         <p:nvSpPr>
-          <p:cNvPr id="8" name="Description 2"/>
-          <p:cNvSpPr/>
-          <p:nvPr/>
-        </p:nvSpPr>
-        <p:spPr>
-          <a:xfrm>
-            <a:off x="777240" y="3236976"/>
-            <a:ext cx="4114800" cy="201168"/>
+          <p:cNvPr id="12" name="Text 10"/>
+          <p:cNvSpPr txBox="1"/>
+          <p:nvPr/>
+        </p:nvSpPr>
+        <p:spPr>
+          <a:xfrm>
+            <a:off x="905256" y="3383280"/>
+            <a:ext cx="4754880" cy="274320"/>
+          </a:xfrm>
+          <a:prstGeom prst="rect">
+            <a:avLst/>
+          </a:prstGeom>
+          <a:noFill/>
+          <a:ln/>
+        </p:spPr>
+        <p:txBody>
+          <a:bodyPr wrap="square" lIns="0" tIns="0" rIns="0" bIns="0" rtlCol="0" anchor="ctr"/>
+          <a:lstStyle/>
+          <a:p>
+            <a:pPr indent="0" marL="0">
+              <a:buNone/>
+            </a:pPr>
+            <a:r>
+              <a:rPr lang="en-US" sz="1200" dirty="0">
+                <a:solidFill>
+                  <a:schemeClr val="tx1"/>
+                </a:solidFill>
+              </a:rPr>
+              <a:t>github MCP server</a:t>
+            </a:r>
+            <a:endParaRPr lang="en-US" sz="1200" dirty="0"/>
+          </a:p>
+        </p:txBody>
+      </p:sp>
+      <p:sp>
+        <p:nvSpPr>
+          <p:cNvPr id="13" name="Tool description 2"/>
+          <p:cNvSpPr/>
+          <p:nvPr/>
+        </p:nvSpPr>
+        <p:spPr>
+          <a:xfrm>
+            <a:off x="777240" y="3694176"/>
+            <a:ext cx="4206240" cy="274320"/>
           </a:xfrm>
           <a:prstGeom prst="roundRect">
             <a:avLst>
-              <a:gd name="adj" fmla="val 18182"/>
+              <a:gd name="adj" fmla="val 16667"/>
             </a:avLst>
           </a:prstGeom>
           <a:solidFill>
-            <a:schemeClr val="accent3">
-              <a:alpha val="80000"/>
-            </a:schemeClr>
+            <a:schemeClr val="accent3"/>
           </a:solidFill>
           <a:ln/>
         </p:spPr>
       </p:sp>
       <p:sp>
         <p:nvSpPr>
-          <p:cNvPr id="9" name="Description 3"/>
-          <p:cNvSpPr/>
-          <p:nvPr/>
-        </p:nvSpPr>
-        <p:spPr>
-          <a:xfrm>
-            <a:off x="777240" y="3511296"/>
-            <a:ext cx="3566160" cy="201168"/>
+          <p:cNvPr id="14" name="Text 12"/>
+          <p:cNvSpPr txBox="1"/>
+          <p:nvPr/>
+        </p:nvSpPr>
+        <p:spPr>
+          <a:xfrm>
+            <a:off x="905256" y="3694176"/>
+            <a:ext cx="4023360" cy="274320"/>
+          </a:xfrm>
+          <a:prstGeom prst="rect">
+            <a:avLst/>
+          </a:prstGeom>
+          <a:noFill/>
+          <a:ln/>
+        </p:spPr>
+        <p:txBody>
+          <a:bodyPr wrap="square" lIns="0" tIns="0" rIns="0" bIns="0" rtlCol="0" anchor="ctr"/>
+          <a:lstStyle/>
+          <a:p>
+            <a:pPr indent="0" marL="0">
+              <a:buNone/>
+            </a:pPr>
+            <a:r>
+              <a:rPr lang="en-US" sz="1200" dirty="0">
+                <a:solidFill>
+                  <a:schemeClr val="tx1"/>
+                </a:solidFill>
+              </a:rPr>
+              <a:t>slack MCP server</a:t>
+            </a:r>
+            <a:endParaRPr lang="en-US" sz="1200" dirty="0"/>
+          </a:p>
+        </p:txBody>
+      </p:sp>
+      <p:sp>
+        <p:nvSpPr>
+          <p:cNvPr id="15" name="Tool description 3"/>
+          <p:cNvSpPr/>
+          <p:nvPr/>
+        </p:nvSpPr>
+        <p:spPr>
+          <a:xfrm>
+            <a:off x="777240" y="4005072"/>
+            <a:ext cx="4572000" cy="274320"/>
           </a:xfrm>
           <a:prstGeom prst="roundRect">
             <a:avLst>
-              <a:gd name="adj" fmla="val 18182"/>
+              <a:gd name="adj" fmla="val 16667"/>
             </a:avLst>
           </a:prstGeom>
           <a:solidFill>
-            <a:schemeClr val="accent3">
-              <a:alpha val="80000"/>
-            </a:schemeClr>
+            <a:schemeClr val="accent3"/>
           </a:solidFill>
           <a:ln/>
         </p:spPr>
       </p:sp>
       <p:sp>
         <p:nvSpPr>
-          <p:cNvPr id="10" name="Description 4"/>
-          <p:cNvSpPr/>
-          <p:nvPr/>
-        </p:nvSpPr>
-        <p:spPr>
-          <a:xfrm>
-            <a:off x="777240" y="3785616"/>
-            <a:ext cx="4663440" cy="201168"/>
+          <p:cNvPr id="16" name="Text 14"/>
+          <p:cNvSpPr txBox="1"/>
+          <p:nvPr/>
+        </p:nvSpPr>
+        <p:spPr>
+          <a:xfrm>
+            <a:off x="905256" y="4005072"/>
+            <a:ext cx="4389120" cy="274320"/>
+          </a:xfrm>
+          <a:prstGeom prst="rect">
+            <a:avLst/>
+          </a:prstGeom>
+          <a:noFill/>
+          <a:ln/>
+        </p:spPr>
+        <p:txBody>
+          <a:bodyPr wrap="square" lIns="0" tIns="0" rIns="0" bIns="0" rtlCol="0" anchor="ctr"/>
+          <a:lstStyle/>
+          <a:p>
+            <a:pPr indent="0" marL="0">
+              <a:buNone/>
+            </a:pPr>
+            <a:r>
+              <a:rPr lang="en-US" sz="1200" dirty="0">
+                <a:solidFill>
+                  <a:schemeClr val="tx1"/>
+                </a:solidFill>
+              </a:rPr>
+              <a:t>jira MCP server</a:t>
+            </a:r>
+            <a:endParaRPr lang="en-US" sz="1200" dirty="0"/>
+          </a:p>
+        </p:txBody>
+      </p:sp>
+      <p:sp>
+        <p:nvSpPr>
+          <p:cNvPr id="17" name="Tool description 4"/>
+          <p:cNvSpPr/>
+          <p:nvPr/>
+        </p:nvSpPr>
+        <p:spPr>
+          <a:xfrm>
+            <a:off x="777240" y="4315968"/>
+            <a:ext cx="3840480" cy="274320"/>
           </a:xfrm>
           <a:prstGeom prst="roundRect">
             <a:avLst>
-              <a:gd name="adj" fmla="val 18182"/>
+              <a:gd name="adj" fmla="val 16667"/>
             </a:avLst>
           </a:prstGeom>
           <a:solidFill>
-            <a:schemeClr val="accent3">
-              <a:alpha val="80000"/>
-            </a:schemeClr>
+            <a:schemeClr val="accent3"/>
           </a:solidFill>
           <a:ln/>
         </p:spPr>
       </p:sp>
       <p:sp>
         <p:nvSpPr>
-          <p:cNvPr id="11" name="Description 5"/>
-          <p:cNvSpPr/>
-          <p:nvPr/>
-        </p:nvSpPr>
-        <p:spPr>
-          <a:xfrm>
-            <a:off x="777240" y="4059936"/>
-            <a:ext cx="4114800" cy="201168"/>
+          <p:cNvPr id="18" name="Text 16"/>
+          <p:cNvSpPr txBox="1"/>
+          <p:nvPr/>
+        </p:nvSpPr>
+        <p:spPr>
+          <a:xfrm>
+            <a:off x="905256" y="4315968"/>
+            <a:ext cx="3657600" cy="274320"/>
+          </a:xfrm>
+          <a:prstGeom prst="rect">
+            <a:avLst/>
+          </a:prstGeom>
+          <a:noFill/>
+          <a:ln/>
+        </p:spPr>
+        <p:txBody>
+          <a:bodyPr wrap="square" lIns="0" tIns="0" rIns="0" bIns="0" rtlCol="0" anchor="ctr"/>
+          <a:lstStyle/>
+          <a:p>
+            <a:pPr indent="0" marL="0">
+              <a:buNone/>
+            </a:pPr>
+            <a:r>
+              <a:rPr lang="en-US" sz="1200" dirty="0">
+                <a:solidFill>
+                  <a:schemeClr val="tx1"/>
+                </a:solidFill>
+              </a:rPr>
+              <a:t>postgres MCP server</a:t>
+            </a:r>
+            <a:endParaRPr lang="en-US" sz="1200" dirty="0"/>
+          </a:p>
+        </p:txBody>
+      </p:sp>
+      <p:sp>
+        <p:nvSpPr>
+          <p:cNvPr id="19" name="Tool description 5"/>
+          <p:cNvSpPr/>
+          <p:nvPr/>
+        </p:nvSpPr>
+        <p:spPr>
+          <a:xfrm>
+            <a:off x="777240" y="4626864"/>
+            <a:ext cx="4389120" cy="274320"/>
           </a:xfrm>
           <a:prstGeom prst="roundRect">
             <a:avLst>
-              <a:gd name="adj" fmla="val 18182"/>
+              <a:gd name="adj" fmla="val 16667"/>
             </a:avLst>
           </a:prstGeom>
           <a:solidFill>
-            <a:schemeClr val="accent3">
-              <a:alpha val="80000"/>
-            </a:schemeClr>
+            <a:schemeClr val="accent3"/>
           </a:solidFill>
           <a:ln/>
         </p:spPr>
       </p:sp>
       <p:sp>
         <p:nvSpPr>
-          <p:cNvPr id="12" name="Description 6"/>
-          <p:cNvSpPr/>
-          <p:nvPr/>
-        </p:nvSpPr>
-        <p:spPr>
-          <a:xfrm>
-            <a:off x="777240" y="4334256"/>
-            <a:ext cx="3566160" cy="201168"/>
+          <p:cNvPr id="20" name="Text 18"/>
+          <p:cNvSpPr txBox="1"/>
+          <p:nvPr/>
+        </p:nvSpPr>
+        <p:spPr>
+          <a:xfrm>
+            <a:off x="905256" y="4626864"/>
+            <a:ext cx="4206240" cy="274320"/>
+          </a:xfrm>
+          <a:prstGeom prst="rect">
+            <a:avLst/>
+          </a:prstGeom>
+          <a:noFill/>
+          <a:ln/>
+        </p:spPr>
+        <p:txBody>
+          <a:bodyPr wrap="square" lIns="0" tIns="0" rIns="0" bIns="0" rtlCol="0" anchor="ctr"/>
+          <a:lstStyle/>
+          <a:p>
+            <a:pPr indent="0" marL="0">
+              <a:buNone/>
+            </a:pPr>
+            <a:r>
+              <a:rPr lang="en-US" sz="1200" dirty="0">
+                <a:solidFill>
+                  <a:schemeClr val="tx1"/>
+                </a:solidFill>
+              </a:rPr>
+              <a:t>figma MCP server</a:t>
+            </a:r>
+            <a:endParaRPr lang="en-US" sz="1200" dirty="0"/>
+          </a:p>
+        </p:txBody>
+      </p:sp>
+      <p:sp>
+        <p:nvSpPr>
+          <p:cNvPr id="21" name="Tool description 6"/>
+          <p:cNvSpPr/>
+          <p:nvPr/>
+        </p:nvSpPr>
+        <p:spPr>
+          <a:xfrm>
+            <a:off x="777240" y="4937760"/>
+            <a:ext cx="4023360" cy="274320"/>
           </a:xfrm>
           <a:prstGeom prst="roundRect">
             <a:avLst>
-              <a:gd name="adj" fmla="val 18182"/>
+              <a:gd name="adj" fmla="val 16667"/>
             </a:avLst>
           </a:prstGeom>
           <a:solidFill>
-            <a:schemeClr val="accent3">
-              <a:alpha val="80000"/>
-            </a:schemeClr>
+            <a:schemeClr val="accent3"/>
           </a:solidFill>
           <a:ln/>
         </p:spPr>
       </p:sp>
       <p:sp>
         <p:nvSpPr>
-          <p:cNvPr id="13" name="Description 7"/>
-          <p:cNvSpPr/>
-          <p:nvPr/>
-        </p:nvSpPr>
-        <p:spPr>
-          <a:xfrm>
-            <a:off x="777240" y="4608576"/>
-            <a:ext cx="4663440" cy="201168"/>
+          <p:cNvPr id="22" name="Text 20"/>
+          <p:cNvSpPr txBox="1"/>
+          <p:nvPr/>
+        </p:nvSpPr>
+        <p:spPr>
+          <a:xfrm>
+            <a:off x="905256" y="4937760"/>
+            <a:ext cx="3840480" cy="274320"/>
+          </a:xfrm>
+          <a:prstGeom prst="rect">
+            <a:avLst/>
+          </a:prstGeom>
+          <a:noFill/>
+          <a:ln/>
+        </p:spPr>
+        <p:txBody>
+          <a:bodyPr wrap="square" lIns="0" tIns="0" rIns="0" bIns="0" rtlCol="0" anchor="ctr"/>
+          <a:lstStyle/>
+          <a:p>
+            <a:pPr indent="0" marL="0">
+              <a:buNone/>
+            </a:pPr>
+            <a:r>
+              <a:rPr lang="en-US" sz="1200" dirty="0">
+                <a:solidFill>
+                  <a:schemeClr val="tx1"/>
+                </a:solidFill>
+              </a:rPr>
+              <a:t>calendar MCP server</a:t>
+            </a:r>
+            <a:endParaRPr lang="en-US" sz="1200" dirty="0"/>
+          </a:p>
+        </p:txBody>
+      </p:sp>
+      <p:sp>
+        <p:nvSpPr>
+          <p:cNvPr id="23" name="Text 21"/>
+          <p:cNvSpPr txBox="1"/>
+          <p:nvPr/>
+        </p:nvSpPr>
+        <p:spPr>
+          <a:xfrm>
+            <a:off x="905256" y="5230368"/>
+            <a:ext cx="4754880" cy="274320"/>
+          </a:xfrm>
+          <a:prstGeom prst="rect">
+            <a:avLst/>
+          </a:prstGeom>
+          <a:noFill/>
+          <a:ln/>
+        </p:spPr>
+        <p:txBody>
+          <a:bodyPr wrap="square" lIns="0" tIns="0" rIns="0" bIns="0" rtlCol="0" anchor="ctr"/>
+          <a:lstStyle/>
+          <a:p>
+            <a:pPr indent="0" marL="0">
+              <a:buNone/>
+            </a:pPr>
+            <a:r>
+              <a:rPr lang="en-US" sz="1200" i="1" dirty="0">
+                <a:solidFill>
+                  <a:schemeClr val="accent6"/>
+                </a:solidFill>
+              </a:rPr>
+              <a:t>… and 4,990 more tool descriptions</a:t>
+            </a:r>
+            <a:endParaRPr lang="en-US" sz="1200" dirty="0"/>
+          </a:p>
+        </p:txBody>
+      </p:sp>
+      <p:sp>
+        <p:nvSpPr>
+          <p:cNvPr id="24" name="Text 22"/>
+          <p:cNvSpPr txBox="1"/>
+          <p:nvPr/>
+        </p:nvSpPr>
+        <p:spPr>
+          <a:xfrm>
+            <a:off x="548640" y="5715000"/>
+            <a:ext cx="5394960" cy="548640"/>
+          </a:xfrm>
+          <a:prstGeom prst="rect">
+            <a:avLst/>
+          </a:prstGeom>
+          <a:noFill/>
+          <a:ln/>
+        </p:spPr>
+        <p:txBody>
+          <a:bodyPr wrap="square" lIns="0" tIns="0" rIns="0" bIns="0" rtlCol="0" anchor="t"/>
+          <a:lstStyle/>
+          <a:p>
+            <a:pPr indent="0" marL="0">
+              <a:buNone/>
+            </a:pPr>
+            <a:r>
+              <a:rPr lang="en-US" sz="1500" dirty="0">
+                <a:solidFill>
+                  <a:schemeClr val="tx2"/>
+                </a:solidFill>
+              </a:rPr>
+              <a:t>Thousands of descriptions on every turn: costly, slow, and the task gets crowded out.</a:t>
+            </a:r>
+            <a:endParaRPr lang="en-US" sz="1500" dirty="0"/>
+          </a:p>
+        </p:txBody>
+      </p:sp>
+      <p:sp>
+        <p:nvSpPr>
+          <p:cNvPr id="25" name="Text 23"/>
+          <p:cNvSpPr txBox="1"/>
+          <p:nvPr/>
+        </p:nvSpPr>
+        <p:spPr>
+          <a:xfrm>
+            <a:off x="6245352" y="1965960"/>
+            <a:ext cx="5394960" cy="365760"/>
+          </a:xfrm>
+          <a:prstGeom prst="rect">
+            <a:avLst/>
+          </a:prstGeom>
+          <a:noFill/>
+          <a:ln/>
+        </p:spPr>
+        <p:txBody>
+          <a:bodyPr wrap="square" lIns="0" tIns="0" rIns="0" bIns="0" rtlCol="0" anchor="t"/>
+          <a:lstStyle/>
+          <a:p>
+            <a:pPr indent="0" marL="0">
+              <a:buNone/>
+            </a:pPr>
+            <a:r>
+              <a:rPr lang="en-US" sz="1800" b="1" dirty="0">
+                <a:solidFill>
+                  <a:schemeClr val="tx1"/>
+                </a:solidFill>
+              </a:rPr>
+              <a:t>With ARD: search first, load the best few</a:t>
+            </a:r>
+            <a:endParaRPr lang="en-US" sz="1800" dirty="0"/>
+          </a:p>
+        </p:txBody>
+      </p:sp>
+      <p:sp>
+        <p:nvSpPr>
+          <p:cNvPr id="26" name="Search service"/>
+          <p:cNvSpPr/>
+          <p:nvPr/>
+        </p:nvSpPr>
+        <p:spPr>
+          <a:xfrm>
+            <a:off x="6245352" y="2468880"/>
+            <a:ext cx="2331720" cy="3108960"/>
           </a:xfrm>
           <a:prstGeom prst="roundRect">
             <a:avLst>
-              <a:gd name="adj" fmla="val 18182"/>
-            </a:avLst>
-          </a:prstGeom>
-          <a:solidFill>
-            <a:schemeClr val="accent3">
-              <a:alpha val="80000"/>
-            </a:schemeClr>
-          </a:solidFill>
-          <a:ln/>
-        </p:spPr>
-      </p:sp>
-      <p:sp>
-        <p:nvSpPr>
-          <p:cNvPr id="14" name="Description 8"/>
-          <p:cNvSpPr/>
-          <p:nvPr/>
-        </p:nvSpPr>
-        <p:spPr>
-          <a:xfrm>
-            <a:off x="777240" y="4882896"/>
-            <a:ext cx="4114800" cy="201168"/>
-          </a:xfrm>
-          <a:prstGeom prst="roundRect">
-            <a:avLst>
-              <a:gd name="adj" fmla="val 18182"/>
-            </a:avLst>
-          </a:prstGeom>
-          <a:solidFill>
-            <a:schemeClr val="accent3">
-              <a:alpha val="80000"/>
-            </a:schemeClr>
-          </a:solidFill>
-          <a:ln/>
-        </p:spPr>
-      </p:sp>
-      <p:sp>
-        <p:nvSpPr>
-          <p:cNvPr id="15" name="Description 9"/>
-          <p:cNvSpPr/>
-          <p:nvPr/>
-        </p:nvSpPr>
-        <p:spPr>
-          <a:xfrm>
-            <a:off x="777240" y="5157216"/>
-            <a:ext cx="3566160" cy="201168"/>
-          </a:xfrm>
-          <a:prstGeom prst="roundRect">
-            <a:avLst>
-              <a:gd name="adj" fmla="val 18182"/>
-            </a:avLst>
-          </a:prstGeom>
-          <a:solidFill>
-            <a:schemeClr val="accent3">
-              <a:alpha val="80000"/>
-            </a:schemeClr>
-          </a:solidFill>
-          <a:ln/>
-        </p:spPr>
-      </p:sp>
-      <p:sp>
-        <p:nvSpPr>
-          <p:cNvPr id="16" name="Description 10"/>
-          <p:cNvSpPr/>
-          <p:nvPr/>
-        </p:nvSpPr>
-        <p:spPr>
-          <a:xfrm>
-            <a:off x="777240" y="5431536"/>
-            <a:ext cx="4663440" cy="201168"/>
-          </a:xfrm>
-          <a:prstGeom prst="roundRect">
-            <a:avLst>
-              <a:gd name="adj" fmla="val 18182"/>
-            </a:avLst>
-          </a:prstGeom>
-          <a:solidFill>
-            <a:schemeClr val="accent3">
-              <a:alpha val="35000"/>
-            </a:schemeClr>
-          </a:solidFill>
-          <a:ln/>
-        </p:spPr>
-      </p:sp>
-      <p:sp>
-        <p:nvSpPr>
-          <p:cNvPr id="17" name="Text 15"/>
-          <p:cNvSpPr txBox="1"/>
-          <p:nvPr/>
-        </p:nvSpPr>
-        <p:spPr>
-          <a:xfrm>
-            <a:off x="548640" y="5669280"/>
-            <a:ext cx="5212080" cy="548640"/>
-          </a:xfrm>
-          <a:prstGeom prst="rect">
-            <a:avLst/>
-          </a:prstGeom>
-          <a:noFill/>
-          <a:ln/>
-        </p:spPr>
-        <p:txBody>
-          <a:bodyPr wrap="square" lIns="0" tIns="0" rIns="0" bIns="0" rtlCol="0" anchor="t"/>
-          <a:lstStyle/>
-          <a:p>
-            <a:pPr indent="0" marL="0">
-              <a:buNone/>
-            </a:pPr>
-            <a:r>
-              <a:rPr lang="en-US" sz="1400" dirty="0">
-                <a:solidFill>
-                  <a:schemeClr val="accent6"/>
-                </a:solidFill>
-              </a:rPr>
-              <a:t>Every connected tool’s description, on every turn. The task gets crowded out.</a:t>
-            </a:r>
-            <a:endParaRPr lang="en-US" sz="1400" dirty="0"/>
-          </a:p>
-        </p:txBody>
-      </p:sp>
-      <p:sp>
-        <p:nvSpPr>
-          <p:cNvPr id="18" name="Text 16"/>
-          <p:cNvSpPr txBox="1"/>
-          <p:nvPr/>
-        </p:nvSpPr>
-        <p:spPr>
-          <a:xfrm>
-            <a:off x="6263640" y="1965960"/>
-            <a:ext cx="5394960" cy="365760"/>
-          </a:xfrm>
-          <a:prstGeom prst="rect">
-            <a:avLst/>
-          </a:prstGeom>
-          <a:noFill/>
-          <a:ln/>
-        </p:spPr>
-        <p:txBody>
-          <a:bodyPr wrap="square" lIns="0" tIns="0" rIns="0" bIns="0" rtlCol="0" anchor="t"/>
-          <a:lstStyle/>
-          <a:p>
-            <a:pPr indent="0" marL="0">
-              <a:buNone/>
-            </a:pPr>
-            <a:r>
-              <a:rPr lang="en-US" sz="1800" b="1" dirty="0">
-                <a:solidFill>
-                  <a:schemeClr val="tx1"/>
-                </a:solidFill>
-              </a:rPr>
-              <a:t>With ARD: search first, load the best few</a:t>
-            </a:r>
-            <a:endParaRPr lang="en-US" sz="1800" dirty="0"/>
-          </a:p>
-        </p:txBody>
-      </p:sp>
-      <p:sp>
-        <p:nvSpPr>
-          <p:cNvPr id="19" name="Search service"/>
-          <p:cNvSpPr/>
-          <p:nvPr/>
-        </p:nvSpPr>
-        <p:spPr>
-          <a:xfrm>
-            <a:off x="6263640" y="2468880"/>
-            <a:ext cx="2240280" cy="2971800"/>
-          </a:xfrm>
-          <a:prstGeom prst="roundRect">
-            <a:avLst>
-              <a:gd name="adj" fmla="val 5714"/>
+              <a:gd name="adj" fmla="val 5490"/>
             </a:avLst>
           </a:prstGeom>
           <a:solidFill>
@@ -23571,14 +23845,14 @@
       </p:sp>
       <p:sp>
         <p:nvSpPr>
-          <p:cNvPr id="20" name="Search service circle"/>
-          <p:cNvSpPr/>
-          <p:nvPr/>
-        </p:nvSpPr>
-        <p:spPr>
-          <a:xfrm>
-            <a:off x="6903720" y="2788920"/>
-            <a:ext cx="914400" cy="914400"/>
+          <p:cNvPr id="27" name="Search service circle"/>
+          <p:cNvSpPr/>
+          <p:nvPr/>
+        </p:nvSpPr>
+        <p:spPr>
+          <a:xfrm>
+            <a:off x="6999732" y="2788920"/>
+            <a:ext cx="822960" cy="822960"/>
           </a:xfrm>
           <a:prstGeom prst="ellipse">
             <a:avLst/>
@@ -23591,7 +23865,7 @@
       </p:sp>
       <p:pic>
         <p:nvPicPr>
-          <p:cNvPr id="21" name="Search service icon" descr="preencoded.png">    </p:cNvPr>
+          <p:cNvPr id="28" name="Search service icon" descr="preencoded.png">    </p:cNvPr>
           <p:cNvPicPr>
             <a:picLocks noChangeAspect="1"/>
           </p:cNvPicPr>
@@ -23605,8 +23879,8 @@
         </p:blipFill>
         <p:spPr>
           <a:xfrm>
-            <a:off x="7132320" y="3017520"/>
-            <a:ext cx="457200" cy="457200"/>
+            <a:off x="7205472" y="2994660"/>
+            <a:ext cx="411480" cy="411480"/>
           </a:xfrm>
           <a:prstGeom prst="rect">
             <a:avLst/>
@@ -23615,14 +23889,14 @@
       </p:pic>
       <p:sp>
         <p:nvSpPr>
-          <p:cNvPr id="22" name="Text 19"/>
-          <p:cNvSpPr txBox="1"/>
-          <p:nvPr/>
-        </p:nvSpPr>
-        <p:spPr>
-          <a:xfrm>
-            <a:off x="6355080" y="3886200"/>
-            <a:ext cx="2057400" cy="365760"/>
+          <p:cNvPr id="29" name="Text 26"/>
+          <p:cNvSpPr txBox="1"/>
+          <p:nvPr/>
+        </p:nvSpPr>
+        <p:spPr>
+          <a:xfrm>
+            <a:off x="6336792" y="3749040"/>
+            <a:ext cx="2148840" cy="365760"/>
           </a:xfrm>
           <a:prstGeom prst="rect">
             <a:avLst/>
@@ -23651,14 +23925,14 @@
       </p:sp>
       <p:sp>
         <p:nvSpPr>
-          <p:cNvPr id="23" name="Text 20"/>
-          <p:cNvSpPr txBox="1"/>
-          <p:nvPr/>
-        </p:nvSpPr>
-        <p:spPr>
-          <a:xfrm>
-            <a:off x="6400800" y="4297680"/>
-            <a:ext cx="1965960" cy="685800"/>
+          <p:cNvPr id="30" name="Text 27"/>
+          <p:cNvSpPr txBox="1"/>
+          <p:nvPr/>
+        </p:nvSpPr>
+        <p:spPr>
+          <a:xfrm>
+            <a:off x="6400800" y="4160520"/>
+            <a:ext cx="2011680" cy="685800"/>
           </a:xfrm>
           <a:prstGeom prst="rect">
             <a:avLst/>
@@ -23687,14 +23961,50 @@
       </p:sp>
       <p:sp>
         <p:nvSpPr>
-          <p:cNvPr id="24" name="Search to context"/>
-          <p:cNvSpPr/>
-          <p:nvPr/>
-        </p:nvSpPr>
-        <p:spPr>
-          <a:xfrm>
-            <a:off x="8595360" y="3950208"/>
-            <a:ext cx="502920" cy="0"/>
+          <p:cNvPr id="31" name="Text 28"/>
+          <p:cNvSpPr txBox="1"/>
+          <p:nvPr/>
+        </p:nvSpPr>
+        <p:spPr>
+          <a:xfrm>
+            <a:off x="8577072" y="3639312"/>
+            <a:ext cx="594360" cy="274320"/>
+          </a:xfrm>
+          <a:prstGeom prst="rect">
+            <a:avLst/>
+          </a:prstGeom>
+          <a:noFill/>
+          <a:ln/>
+        </p:spPr>
+        <p:txBody>
+          <a:bodyPr wrap="square" lIns="0" tIns="0" rIns="0" bIns="0" rtlCol="0" anchor="t"/>
+          <a:lstStyle/>
+          <a:p>
+            <a:pPr algn="ctr" indent="0" marL="0">
+              <a:buNone/>
+            </a:pPr>
+            <a:r>
+              <a:rPr lang="en-US" sz="1100" b="1" dirty="0">
+                <a:solidFill>
+                  <a:schemeClr val="accent6"/>
+                </a:solidFill>
+              </a:rPr>
+              <a:t>top 3</a:t>
+            </a:r>
+            <a:endParaRPr lang="en-US" sz="1100" dirty="0"/>
+          </a:p>
+        </p:txBody>
+      </p:sp>
+      <p:sp>
+        <p:nvSpPr>
+          <p:cNvPr id="32" name="Search to context"/>
+          <p:cNvSpPr/>
+          <p:nvPr/>
+        </p:nvSpPr>
+        <p:spPr>
+          <a:xfrm>
+            <a:off x="8641080" y="4023360"/>
+            <a:ext cx="457200" cy="0"/>
           </a:xfrm>
           <a:prstGeom prst="line">
             <a:avLst/>
@@ -23711,18 +24021,18 @@
       </p:sp>
       <p:sp>
         <p:nvSpPr>
-          <p:cNvPr id="25" name="Context window with ARD"/>
-          <p:cNvSpPr/>
-          <p:nvPr/>
-        </p:nvSpPr>
-        <p:spPr>
-          <a:xfrm>
-            <a:off x="9189720" y="2468880"/>
-            <a:ext cx="2450592" cy="2971800"/>
+          <p:cNvPr id="33" name="Context window with ARD"/>
+          <p:cNvSpPr/>
+          <p:nvPr/>
+        </p:nvSpPr>
+        <p:spPr>
+          <a:xfrm>
+            <a:off x="9171432" y="2468880"/>
+            <a:ext cx="2468880" cy="3108960"/>
           </a:xfrm>
           <a:prstGeom prst="roundRect">
             <a:avLst>
-              <a:gd name="adj" fmla="val 2985"/>
+              <a:gd name="adj" fmla="val 2963"/>
             </a:avLst>
           </a:prstGeom>
           <a:solidFill>
@@ -23738,14 +24048,50 @@
       </p:sp>
       <p:sp>
         <p:nvSpPr>
-          <p:cNvPr id="26" name="Task bar right"/>
-          <p:cNvSpPr/>
-          <p:nvPr/>
-        </p:nvSpPr>
-        <p:spPr>
-          <a:xfrm>
-            <a:off x="9372600" y="2651760"/>
-            <a:ext cx="2084832" cy="219456"/>
+          <p:cNvPr id="34" name="Text 31"/>
+          <p:cNvSpPr txBox="1"/>
+          <p:nvPr/>
+        </p:nvSpPr>
+        <p:spPr>
+          <a:xfrm>
+            <a:off x="9354312" y="2587752"/>
+            <a:ext cx="2103120" cy="256032"/>
+          </a:xfrm>
+          <a:prstGeom prst="rect">
+            <a:avLst/>
+          </a:prstGeom>
+          <a:noFill/>
+          <a:ln/>
+        </p:spPr>
+        <p:txBody>
+          <a:bodyPr wrap="square" lIns="0" tIns="0" rIns="0" bIns="0" rtlCol="0" anchor="ctr"/>
+          <a:lstStyle/>
+          <a:p>
+            <a:pPr indent="0" marL="0">
+              <a:buNone/>
+            </a:pPr>
+            <a:r>
+              <a:rPr lang="en-US" sz="1100" b="1" spc="100" kern="0" dirty="0">
+                <a:solidFill>
+                  <a:schemeClr val="accent6"/>
+                </a:solidFill>
+              </a:rPr>
+              <a:t>CONTEXT WINDOW</a:t>
+            </a:r>
+            <a:endParaRPr lang="en-US" sz="1100" dirty="0"/>
+          </a:p>
+        </p:txBody>
+      </p:sp>
+      <p:sp>
+        <p:nvSpPr>
+          <p:cNvPr id="35" name="Task bar right"/>
+          <p:cNvSpPr/>
+          <p:nvPr/>
+        </p:nvSpPr>
+        <p:spPr>
+          <a:xfrm>
+            <a:off x="9354312" y="2971800"/>
+            <a:ext cx="2103120" cy="274320"/>
           </a:xfrm>
           <a:prstGeom prst="roundRect">
             <a:avLst>
@@ -23760,18 +24106,54 @@
       </p:sp>
       <p:sp>
         <p:nvSpPr>
-          <p:cNvPr id="27" name="Top result 1"/>
-          <p:cNvSpPr/>
-          <p:nvPr/>
-        </p:nvSpPr>
-        <p:spPr>
-          <a:xfrm>
-            <a:off x="9372600" y="2962656"/>
-            <a:ext cx="2084832" cy="201168"/>
+          <p:cNvPr id="36" name="Text 33"/>
+          <p:cNvSpPr txBox="1"/>
+          <p:nvPr/>
+        </p:nvSpPr>
+        <p:spPr>
+          <a:xfrm>
+            <a:off x="9482328" y="2971800"/>
+            <a:ext cx="1920240" cy="274320"/>
+          </a:xfrm>
+          <a:prstGeom prst="rect">
+            <a:avLst/>
+          </a:prstGeom>
+          <a:noFill/>
+          <a:ln/>
+        </p:spPr>
+        <p:txBody>
+          <a:bodyPr wrap="square" lIns="0" tIns="0" rIns="0" bIns="0" rtlCol="0" anchor="ctr"/>
+          <a:lstStyle/>
+          <a:p>
+            <a:pPr indent="0" marL="0">
+              <a:buNone/>
+            </a:pPr>
+            <a:r>
+              <a:rPr lang="en-US" sz="1200" b="1" dirty="0">
+                <a:solidFill>
+                  <a:schemeClr val="tx1"/>
+                </a:solidFill>
+              </a:rPr>
+              <a:t>Task: flight to Tokyo</a:t>
+            </a:r>
+            <a:endParaRPr lang="en-US" sz="1200" dirty="0"/>
+          </a:p>
+        </p:txBody>
+      </p:sp>
+      <p:sp>
+        <p:nvSpPr>
+          <p:cNvPr id="37" name="Top result 1"/>
+          <p:cNvSpPr/>
+          <p:nvPr/>
+        </p:nvSpPr>
+        <p:spPr>
+          <a:xfrm>
+            <a:off x="9354312" y="3383280"/>
+            <a:ext cx="2103120" cy="274320"/>
           </a:xfrm>
           <a:prstGeom prst="roundRect">
             <a:avLst>
-              <a:gd name="adj" fmla="val 18182"/>
+              <a:gd name="adj" fmla="val 16667"/>
             </a:avLst>
           </a:prstGeom>
           <a:solidFill>
@@ -23782,18 +24164,54 @@
       </p:sp>
       <p:sp>
         <p:nvSpPr>
-          <p:cNvPr id="28" name="Top result 2"/>
-          <p:cNvSpPr/>
-          <p:nvPr/>
-        </p:nvSpPr>
-        <p:spPr>
-          <a:xfrm>
-            <a:off x="9372600" y="3236976"/>
-            <a:ext cx="1719072" cy="201168"/>
+          <p:cNvPr id="38" name="Text 35"/>
+          <p:cNvSpPr txBox="1"/>
+          <p:nvPr/>
+        </p:nvSpPr>
+        <p:spPr>
+          <a:xfrm>
+            <a:off x="9482328" y="3383280"/>
+            <a:ext cx="1920240" cy="274320"/>
+          </a:xfrm>
+          <a:prstGeom prst="rect">
+            <a:avLst/>
+          </a:prstGeom>
+          <a:noFill/>
+          <a:ln/>
+        </p:spPr>
+        <p:txBody>
+          <a:bodyPr wrap="square" lIns="0" tIns="0" rIns="0" bIns="0" rtlCol="0" anchor="ctr"/>
+          <a:lstStyle/>
+          <a:p>
+            <a:pPr indent="0" marL="0">
+              <a:buNone/>
+            </a:pPr>
+            <a:r>
+              <a:rPr lang="en-US" sz="1200" dirty="0">
+                <a:solidFill>
+                  <a:schemeClr val="tx1"/>
+                </a:solidFill>
+              </a:rPr>
+              <a:t>Travel Booker · A2A</a:t>
+            </a:r>
+            <a:endParaRPr lang="en-US" sz="1200" dirty="0"/>
+          </a:p>
+        </p:txBody>
+      </p:sp>
+      <p:sp>
+        <p:nvSpPr>
+          <p:cNvPr id="39" name="Top result 2"/>
+          <p:cNvSpPr/>
+          <p:nvPr/>
+        </p:nvSpPr>
+        <p:spPr>
+          <a:xfrm>
+            <a:off x="9354312" y="3694176"/>
+            <a:ext cx="2103120" cy="274320"/>
           </a:xfrm>
           <a:prstGeom prst="roundRect">
             <a:avLst>
-              <a:gd name="adj" fmla="val 18182"/>
+              <a:gd name="adj" fmla="val 16667"/>
             </a:avLst>
           </a:prstGeom>
           <a:solidFill>
@@ -23804,18 +24222,54 @@
       </p:sp>
       <p:sp>
         <p:nvSpPr>
-          <p:cNvPr id="29" name="Top result 3"/>
-          <p:cNvSpPr/>
-          <p:nvPr/>
-        </p:nvSpPr>
-        <p:spPr>
-          <a:xfrm>
-            <a:off x="9372600" y="3511296"/>
-            <a:ext cx="1353312" cy="201168"/>
+          <p:cNvPr id="40" name="Text 37"/>
+          <p:cNvSpPr txBox="1"/>
+          <p:nvPr/>
+        </p:nvSpPr>
+        <p:spPr>
+          <a:xfrm>
+            <a:off x="9482328" y="3694176"/>
+            <a:ext cx="1920240" cy="274320"/>
+          </a:xfrm>
+          <a:prstGeom prst="rect">
+            <a:avLst/>
+          </a:prstGeom>
+          <a:noFill/>
+          <a:ln/>
+        </p:spPr>
+        <p:txBody>
+          <a:bodyPr wrap="square" lIns="0" tIns="0" rIns="0" bIns="0" rtlCol="0" anchor="ctr"/>
+          <a:lstStyle/>
+          <a:p>
+            <a:pPr indent="0" marL="0">
+              <a:buNone/>
+            </a:pPr>
+            <a:r>
+              <a:rPr lang="en-US" sz="1200" dirty="0">
+                <a:solidFill>
+                  <a:schemeClr val="tx1"/>
+                </a:solidFill>
+              </a:rPr>
+              <a:t>Flight Status · MCP</a:t>
+            </a:r>
+            <a:endParaRPr lang="en-US" sz="1200" dirty="0"/>
+          </a:p>
+        </p:txBody>
+      </p:sp>
+      <p:sp>
+        <p:nvSpPr>
+          <p:cNvPr id="41" name="Top result 3"/>
+          <p:cNvSpPr/>
+          <p:nvPr/>
+        </p:nvSpPr>
+        <p:spPr>
+          <a:xfrm>
+            <a:off x="9354312" y="4005072"/>
+            <a:ext cx="2103120" cy="274320"/>
           </a:xfrm>
           <a:prstGeom prst="roundRect">
             <a:avLst>
-              <a:gd name="adj" fmla="val 18182"/>
+              <a:gd name="adj" fmla="val 16667"/>
             </a:avLst>
           </a:prstGeom>
           <a:solidFill>
@@ -23826,13 +24280,112 @@
       </p:sp>
       <p:sp>
         <p:nvSpPr>
-          <p:cNvPr id="30" name="Text 27"/>
-          <p:cNvSpPr txBox="1"/>
-          <p:nvPr/>
-        </p:nvSpPr>
-        <p:spPr>
-          <a:xfrm>
-            <a:off x="6263640" y="5669280"/>
+          <p:cNvPr id="42" name="Text 39"/>
+          <p:cNvSpPr txBox="1"/>
+          <p:nvPr/>
+        </p:nvSpPr>
+        <p:spPr>
+          <a:xfrm>
+            <a:off x="9482328" y="4005072"/>
+            <a:ext cx="1920240" cy="274320"/>
+          </a:xfrm>
+          <a:prstGeom prst="rect">
+            <a:avLst/>
+          </a:prstGeom>
+          <a:noFill/>
+          <a:ln/>
+        </p:spPr>
+        <p:txBody>
+          <a:bodyPr wrap="square" lIns="0" tIns="0" rIns="0" bIns="0" rtlCol="0" anchor="ctr"/>
+          <a:lstStyle/>
+          <a:p>
+            <a:pPr indent="0" marL="0">
+              <a:buNone/>
+            </a:pPr>
+            <a:r>
+              <a:rPr lang="en-US" sz="1200" dirty="0">
+                <a:solidFill>
+                  <a:schemeClr val="tx1"/>
+                </a:solidFill>
+              </a:rPr>
+              <a:t>trip-planner · skill</a:t>
+            </a:r>
+            <a:endParaRPr lang="en-US" sz="1200" dirty="0"/>
+          </a:p>
+        </p:txBody>
+      </p:sp>
+      <p:sp>
+        <p:nvSpPr>
+          <p:cNvPr id="43" name="Free space"/>
+          <p:cNvSpPr/>
+          <p:nvPr/>
+        </p:nvSpPr>
+        <p:spPr>
+          <a:xfrm>
+            <a:off x="9354312" y="4434840"/>
+            <a:ext cx="2103120" cy="1005840"/>
+          </a:xfrm>
+          <a:prstGeom prst="roundRect">
+            <a:avLst>
+              <a:gd name="adj" fmla="val 7273"/>
+            </a:avLst>
+          </a:prstGeom>
+          <a:solidFill>
+            <a:schemeClr val="bg1"/>
+          </a:solidFill>
+          <a:ln w="15875">
+            <a:solidFill>
+              <a:srgbClr val="B6B0D0"/>
+            </a:solidFill>
+            <a:prstDash val="dash"/>
+          </a:ln>
+        </p:spPr>
+      </p:sp>
+      <p:sp>
+        <p:nvSpPr>
+          <p:cNvPr id="44" name="Text 41"/>
+          <p:cNvSpPr txBox="1"/>
+          <p:nvPr/>
+        </p:nvSpPr>
+        <p:spPr>
+          <a:xfrm>
+            <a:off x="9354312" y="4434840"/>
+            <a:ext cx="2103120" cy="1005840"/>
+          </a:xfrm>
+          <a:prstGeom prst="rect">
+            <a:avLst/>
+          </a:prstGeom>
+          <a:noFill/>
+          <a:ln/>
+        </p:spPr>
+        <p:txBody>
+          <a:bodyPr wrap="square" lIns="0" tIns="0" rIns="0" bIns="0" rtlCol="0" anchor="ctr"/>
+          <a:lstStyle/>
+          <a:p>
+            <a:pPr algn="ctr" indent="0" marL="0">
+              <a:buNone/>
+            </a:pPr>
+            <a:r>
+              <a:rPr lang="en-US" sz="1200" dirty="0">
+                <a:solidFill>
+                  <a:schemeClr val="accent6"/>
+                </a:solidFill>
+              </a:rPr>
+              <a:t>Free for the actual work</a:t>
+            </a:r>
+            <a:endParaRPr lang="en-US" sz="1200" dirty="0"/>
+          </a:p>
+        </p:txBody>
+      </p:sp>
+      <p:sp>
+        <p:nvSpPr>
+          <p:cNvPr id="45" name="Text 42"/>
+          <p:cNvSpPr txBox="1"/>
+          <p:nvPr/>
+        </p:nvSpPr>
+        <p:spPr>
+          <a:xfrm>
+            <a:off x="6245352" y="5715000"/>
             <a:ext cx="5394960" cy="548640"/>
           </a:xfrm>
           <a:prstGeom prst="rect">
@@ -23849,14 +24402,14 @@
               <a:buNone/>
             </a:pPr>
             <a:r>
-              <a:rPr lang="en-US" sz="1400" dirty="0">
-                <a:solidFill>
-                  <a:schemeClr val="accent6"/>
-                </a:solidFill>
-              </a:rPr>
-              <a:t>Only the top results for this task. Lots of room left.</a:t>
-            </a:r>
-            <a:endParaRPr lang="en-US" sz="1400" dirty="0"/>
+              <a:rPr lang="en-US" sz="1500" dirty="0">
+                <a:solidFill>
+                  <a:schemeClr val="tx2"/>
+                </a:solidFill>
+              </a:rPr>
+              <a:t>Only the few that match this task, chosen outside the model.</a:t>
+            </a:r>
+            <a:endParaRPr lang="en-US" sz="1500" dirty="0"/>
           </a:p>
         </p:txBody>
       </p:sp>

</xml_diff>

<commit_message>
docs(talks): clarify why ARD identifiers are URNs, not URLs
Rewrite the slide 9 script around name versus address, an HTTPS-style
proof of the publisher domain, and Java-style domain namespacing.

Co-Authored-By: Claude Opus 5.5 <noreply@anthropic.com>
Claude-Session: https://claude.ai/code/session_01A6yJd4TLSLFA7VqN9oV9Uo
</commit_message>
<xml_diff>
--- a/talks/ard/ARD-AAIF-Chennai.pptx
+++ b/talks/ard/ARD-AAIF-Chennai.pptx
@@ -131,20 +131,20 @@
   <p:extLst>
     <p:ext uri="{521415D9-36F7-43E2-AB2F-B90AF26B5E84}">
       <p14:sectionLst xmlns:p14="http://schemas.microsoft.com/office/powerpoint/2010/main">
-        <p14:section name="Introduction" id="{b712118f-3b78-91a2-8146-aa8de8a1043f}">
+        <p14:section name="Introduction" id="{6f8e50b1-428b-25fe-7148-8e130f2ac821}">
           <p14:sldIdLst>
             <p14:sldId id="256"/>
             <p14:sldId id="257"/>
           </p14:sldIdLst>
         </p14:section>
-        <p14:section name="Why discovery" id="{4f1310d1-576a-6635-a207-5570e3589945}">
+        <p14:section name="Why discovery" id="{b409ba4f-4997-2b44-2f6e-058657d09733}">
           <p14:sldIdLst>
             <p14:sldId id="258"/>
             <p14:sldId id="259"/>
             <p14:sldId id="260"/>
           </p14:sldIdLst>
         </p14:section>
-        <p14:section name="What ARD is" id="{512bd263-5f6d-e3e9-477d-fdd2a14bc56a}">
+        <p14:section name="What ARD is" id="{500e86c5-58b0-ad2a-adac-7a35889d931c}">
           <p14:sldIdLst>
             <p14:sldId id="261"/>
             <p14:sldId id="262"/>
@@ -156,7 +156,7 @@
             <p14:sldId id="268"/>
           </p14:sldIdLst>
         </p14:section>
-        <p14:section name="My implementation" id="{f5911bd0-5f51-ec36-9aab-e6f9a0a12047}">
+        <p14:section name="My implementation" id="{96dc014b-f9b5-9ad8-d731-27c570d210d3}">
           <p14:sldIdLst>
             <p14:sldId id="269"/>
             <p14:sldId id="270"/>
@@ -166,7 +166,7 @@
             <p14:sldId id="274"/>
           </p14:sldIdLst>
         </p14:section>
-        <p14:section name="Use cases" id="{1ea41880-d953-bd0f-814d-cd69afe96518}">
+        <p14:section name="Use cases" id="{e6605647-c922-dfd3-8663-184a2df16106}">
           <p14:sldIdLst>
             <p14:sldId id="275"/>
             <p14:sldId id="276"/>
@@ -174,7 +174,7 @@
             <p14:sldId id="278"/>
           </p14:sldIdLst>
         </p14:section>
-        <p14:section name="Wrap-up" id="{aa04ef0e-4e72-b44e-2993-d9565a02a685}">
+        <p14:section name="Wrap-up" id="{a13bd9ff-c642-dd3c-1549-f6356d261914}">
           <p14:sldIdLst>
             <p14:sldId id="279"/>
             <p14:sldId id="280"/>
@@ -3223,7 +3223,10 @@
               <a:t>9. The identifier names the resource · 1:15
 Every entry has an identifier that starts with urn:air.
 [Walk the chips left to right] "urn" says this is a name, not an address. "air" is ARD's namespace. Early drafts used urn:ai, but URN rules need more than two characters, so it became air. Then comes the publisher, which must be a real domain, an optional namespace, and the resource name.
-Why not just use the URL? Three reasons. [Cards] Stable: hosting moves, the name doesn't. Verifiable: the publisher domain has to match the identity in the entry's trust manifest, so nobody can publish urn:air:google.com-anything without proof from google.com. And globally unique for free: DNS already makes domains unique, so catalogues from different registries merge without collisions, and nobody has to run a naming committee.</a:t>
+Why not just use the URL as the ID? Because a URL answers "where is it right now?", and an identifier needs to answer "what is it, and who stands behind it?" Three reasons.
+[Card 1] Stable. Think of a person's name versus their home address. If Acme moves its weather server to a new host, a URL-based ID would break every registry and every saved config. With a URN, the name stays the same and only the url field changes.
+[Card 2] Verifiable. Anyone can publish a JSON file claiming to be Google's official Gmail agent. ARD ties the name to a domain: an entry named urn:air:google.com-anything must carry proof issued by google.com in its trust manifest. Same idea as HTTPS: you only get a certificate for google.com if you control google.com. No proof, and a registry that checks rejects it.
+[Card 3] Unique without a referee. When registries merge results, two publishers will both call something "weather". Instead of a central body handing out names, ARD reuses DNS: only one organisation owns acme.com, so everything under urn:air:acme.com is theirs. If you've written Java, it's the same trick as com.acme package names.</a:t>
             </a:r>
             <a:endParaRPr lang="en-US" dirty="0"/>
           </a:p>

</xml_diff>

<commit_message>
docs(talks): describe teamspace-scoped ARD discovery in the deck
Discovery now only shows a signed-in user their own listings and their
teams' listings, so say that on the guardrails slide and in the script,
and note the manifest is only populated when an admin opts in.

Co-Authored-By: Claude Opus 5.5 <noreply@anthropic.com>
Claude-Session: https://claude.ai/code/session_01A6yJd4TLSLFA7VqN9oV9Uo
</commit_message>
<xml_diff>
--- a/talks/ard/ARD-AAIF-Chennai.pptx
+++ b/talks/ard/ARD-AAIF-Chennai.pptx
@@ -132,20 +132,20 @@
   <p:extLst>
     <p:ext uri="{521415D9-36F7-43E2-AB2F-B90AF26B5E84}">
       <p14:sectionLst xmlns:p14="http://schemas.microsoft.com/office/powerpoint/2010/main">
-        <p14:section name="Introduction" id="{47a56404-b0f8-7d0b-514f-89e0d5a9f56d}">
+        <p14:section name="Introduction" id="{69f8bc50-78f2-9502-2037-a2d7d0ac4d36}">
           <p14:sldIdLst>
             <p14:sldId id="256"/>
             <p14:sldId id="257"/>
           </p14:sldIdLst>
         </p14:section>
-        <p14:section name="Why discovery" id="{13adc8f5-8931-1bc7-36e5-ecf9763ec539}">
+        <p14:section name="Why discovery" id="{bf649128-0058-8918-e22e-d1d496908560}">
           <p14:sldIdLst>
             <p14:sldId id="258"/>
             <p14:sldId id="259"/>
             <p14:sldId id="260"/>
           </p14:sldIdLst>
         </p14:section>
-        <p14:section name="What ARD is" id="{4fc58d69-4383-5106-d3ff-933a3716b175}">
+        <p14:section name="What ARD is" id="{f21693c2-c41c-bc54-191f-ab3c30f032df}">
           <p14:sldIdLst>
             <p14:sldId id="261"/>
             <p14:sldId id="262"/>
@@ -158,7 +158,7 @@
             <p14:sldId id="269"/>
           </p14:sldIdLst>
         </p14:section>
-        <p14:section name="My implementation" id="{53281f7d-c5d6-d3d6-59ed-869708ee8fc1}">
+        <p14:section name="My implementation" id="{064c2d56-4547-6e52-c120-21ea2a270d2c}">
           <p14:sldIdLst>
             <p14:sldId id="270"/>
             <p14:sldId id="271"/>
@@ -168,7 +168,7 @@
             <p14:sldId id="275"/>
           </p14:sldIdLst>
         </p14:section>
-        <p14:section name="Use cases" id="{dd97cce8-6501-a226-612a-930b8015131f}">
+        <p14:section name="Use cases" id="{735f9f6e-7578-b9b1-f198-e3a7706fe889}">
           <p14:sldIdLst>
             <p14:sldId id="276"/>
             <p14:sldId id="277"/>
@@ -176,7 +176,7 @@
             <p14:sldId id="279"/>
           </p14:sldIdLst>
         </p14:section>
-        <p14:section name="Wrap-up" id="{137f577a-e7cb-803c-8c6f-71088941f16a}">
+        <p14:section name="Wrap-up" id="{d4866a53-6e17-8c43-04dc-da2c60bacbf0}">
           <p14:sldIdLst>
             <p14:sldId id="280"/>
             <p14:sldId id="281"/>
@@ -1944,7 +1944,7 @@
               <a:t>19. Guardrails · 1:00
 Discovery could easily become a back door around a registry's rules, so I built in four guardrails.
 [Top left] Score means relevance only, as the spec says. Approval and harness support are separate fields, and policy filters run before ranking.
-[Top right] Discovery never shows more than the registry already would. Drafts and rejected items only reach their owners.
+[Top right] Discovery is scoped to you. A signed-in user only discovers their own listings and the teamspaces they belong to, not everyone else's public listings, and drafts only reach their owners. My first version mirrored the registry's browse rules; I tightened it in a follow-up because search is a much stronger way to surface things than browsing. Anonymous search is off unless an admin turns it on.
 [Bottom left] Search text stays home. People type sensitive things into search, such as incident details or unreleased product names, so federation only reaches upstreams an admin allowlists, and that list starts empty.
 [Bottom right] Read freely, write with consent. Approved text loads straight away; anything that changes your setup asks first.</a:t>
             </a:r>
@@ -13577,7 +13577,7 @@
                             <a:schemeClr val="tx1"/>
                           </a:solidFill>
                         </a:rPr>
-                        <a:t>Manifest of public, approved entries</a:t>
+                        <a:t>Public, approved entries, only if an admin opts in</a:t>
                       </a:r>
                       <a:endParaRPr lang="en-US" sz="1400" dirty="0"/>
                     </a:p>
@@ -15540,7 +15540,7 @@
       </p:sp>
       <p:sp>
         <p:nvSpPr>
-          <p:cNvPr id="9" name="Never shows more than the registry card"/>
+          <p:cNvPr id="9" name="Scoped to you and your teams card"/>
           <p:cNvSpPr/>
           <p:nvPr/>
         </p:nvSpPr>
@@ -15562,7 +15562,7 @@
       </p:sp>
       <p:sp>
         <p:nvSpPr>
-          <p:cNvPr id="10" name="Never shows more than the registry circle"/>
+          <p:cNvPr id="10" name="Scoped to you and your teams circle"/>
           <p:cNvSpPr/>
           <p:nvPr/>
         </p:nvSpPr>
@@ -15582,7 +15582,7 @@
       </p:sp>
       <p:pic>
         <p:nvPicPr>
-          <p:cNvPr id="11" name="Never shows more than the registry icon" descr="preencoded.png">    </p:cNvPr>
+          <p:cNvPr id="11" name="Scoped to you and your teams icon" descr="preencoded.png">    </p:cNvPr>
           <p:cNvPicPr>
             <a:picLocks noChangeAspect="1"/>
           </p:cNvPicPr>
@@ -15634,7 +15634,7 @@
                   <a:schemeClr val="tx1"/>
                 </a:solidFill>
               </a:rPr>
-              <a:t>Never shows more than the registry</a:t>
+              <a:t>Scoped to you and your teams</a:t>
             </a:r>
             <a:endParaRPr lang="en-US" sz="1800" dirty="0"/>
           </a:p>
@@ -15670,7 +15670,7 @@
                   <a:schemeClr val="tx2"/>
                 </a:solidFill>
               </a:rPr>
-              <a:t>Drafts and rejections reach only their owners. Anonymous search is off unless an admin enables it.</a:t>
+              <a:t>You only discover your own listings and those of teams you’re in. Drafts reach only owners; anonymous search is off.</a:t>
             </a:r>
             <a:endParaRPr lang="en-US" sz="1500" dirty="0"/>
           </a:p>

</xml_diff>

<commit_message>
docs(talks): add a what's-next slide on ARD SEO to the deck
Introduce the planned author insights (health check, near misses,
rank explanations, query preview) with a real near-miss from the search
benchmark, update the agenda, and add the matching script section.

Co-Authored-By: Claude Opus 5.5 <noreply@anthropic.com>
Claude-Session: https://claude.ai/code/session_01A6yJd4TLSLFA7VqN9oV9Uo
</commit_message>
<xml_diff>
--- a/talks/ard/ARD-AAIF-Chennai.pptx
+++ b/talks/ard/ARD-AAIF-Chennai.pptx
@@ -28,9 +28,10 @@
     <p:sldId id="276" r:id="rId22"/>
     <p:sldId id="277" r:id="rId23"/>
     <p:sldId id="278" r:id="rId24"/>
+    <p:sldId id="279" r:id="rId25"/>
   </p:sldIdLst>
   <p:notesMasterIdLst>
-    <p:notesMasterId r:id="rId25"/>
+    <p:notesMasterId r:id="rId26"/>
   </p:notesMasterIdLst>
   <p:sldSz cx="12192000" cy="6858000"/>
   <p:notesSz cx="6858000" cy="12192000"/>
@@ -129,19 +130,19 @@
   <p:extLst>
     <p:ext uri="{521415D9-36F7-43E2-AB2F-B90AF26B5E84}">
       <p14:sectionLst xmlns:p14="http://schemas.microsoft.com/office/powerpoint/2010/main">
-        <p14:section name="Introduction" id="{acdd9b71-4aec-a8df-2f5b-53e1607946fc}">
+        <p14:section name="Introduction" id="{0f18c7e0-89ee-1d30-9bb4-c3503c586853}">
           <p14:sldIdLst>
             <p14:sldId id="256"/>
             <p14:sldId id="257"/>
           </p14:sldIdLst>
         </p14:section>
-        <p14:section name="Why discovery" id="{dc1525ba-7464-1034-5a98-208400429ca8}">
+        <p14:section name="Why discovery" id="{9704573d-79d4-91e6-2406-7f0f04479b2b}">
           <p14:sldIdLst>
             <p14:sldId id="258"/>
             <p14:sldId id="259"/>
           </p14:sldIdLst>
         </p14:section>
-        <p14:section name="What ARD is" id="{e5f23546-d241-5ed0-e9b3-b5333f35f040}">
+        <p14:section name="What ARD is" id="{ce179908-b868-1e1c-b4d1-8bb63c18f467}">
           <p14:sldIdLst>
             <p14:sldId id="260"/>
             <p14:sldId id="261"/>
@@ -153,7 +154,7 @@
             <p14:sldId id="267"/>
           </p14:sldIdLst>
         </p14:section>
-        <p14:section name="My implementation" id="{b659e430-e86b-d3ac-e695-ae5d65077708}">
+        <p14:section name="My implementation" id="{f1315a88-2562-42ad-7efd-ad9a57669683}">
           <p14:sldIdLst>
             <p14:sldId id="268"/>
             <p14:sldId id="269"/>
@@ -162,7 +163,7 @@
             <p14:sldId id="272"/>
           </p14:sldIdLst>
         </p14:section>
-        <p14:section name="Use cases" id="{0fe2c0d3-3b17-037e-4eb1-67497ba57ee7}">
+        <p14:section name="Use cases" id="{2a5f708c-6d20-a889-2c14-c579be0fff24}">
           <p14:sldIdLst>
             <p14:sldId id="273"/>
             <p14:sldId id="274"/>
@@ -170,10 +171,11 @@
             <p14:sldId id="276"/>
           </p14:sldIdLst>
         </p14:section>
-        <p14:section name="Wrap-up" id="{da18bd6c-f842-1a02-0dff-c64eced671a5}">
+        <p14:section name="Wrap-up" id="{88ee324e-b3cf-b52f-f6c6-bb386c49102f}">
           <p14:sldIdLst>
             <p14:sldId id="277"/>
             <p14:sldId id="278"/>
+            <p14:sldId id="279"/>
           </p14:sldIdLst>
         </p14:section>
       </p14:sectionLst>
@@ -1593,7 +1595,7 @@
               <a:rPr lang="en-US" dirty="0"/>
               <a:t>2. Agenda · 0:45
 A quick intro: I'm an open-source contributor, and over the last couple of months I implemented ARD in Observal, an open-source registry and observability platform for AI coding agents. So this talk is half spec, half field notes.
-Five parts: why agents need discovery at all, what ARD actually specifies, how I implemented it, what it unlocks, and how you can try it on your own project this week.</a:t>
+Five parts: why agents need discovery at all, what ARD actually specifies, how I implemented it, what it unlocks, and what I'm building next, plus how you can try it on your own project this week.</a:t>
             </a:r>
             <a:endParaRPr lang="en-US" dirty="0"/>
           </a:p>
@@ -1865,11 +1867,12 @@
           <a:p>
             <a:r>
               <a:rPr lang="en-US" dirty="0"/>
-              <a:t>22. Try it this week · 1:00
-If you take one thing home: you can publish an ARD entry for your own project this week. It's one small file.
-[Code] Step one: put an ard.json under /.well-known on your domain. Here's a made-up Chennai weather MCP server. It has the four required fields, and please write good representative queries, because that's what search runs on.
-[Top right] Step two: validate it with the official conformance tool from the ard-spec repo. Publisher mode fetches your file and checks it.
-[Bottom right] Step three: join in. The spec is at version 0.91, so feedback now actually shapes it. Issues for spec changes; pull requests welcome for examples, tools and implementations.</a:t>
+              <a:t>22. Next: ARD SEO · 1:00
+That's what exists today. Here's what I'm building next, which I'm calling ARD SEO. If ranking decides whether people find your component, authors deserve to know how to rank well.
+[Left card] This is a mock-up of the author's view for one component. First, a discovery checklist against the signals the ranker actually uses: is it approved, does it have enough example queries (the spec says two to five), and has it declared which harnesses it supports? Undeclared harnesses matter more than you'd think: when someone filters by harness, resources that don't declare one are left out.
+[Near miss] Then near misses, and this one is real, from the project's own search benchmark. Someone searches "find an auth bypass in the payments PR". Our Security Review skill comes third with 21, behind two unrelated skills whose names end in "Author", because "auth" is the start of "Author". The report shows the missing words: bypass, payments. Add one example query using them, and the same search ranks it first with 80.
+[Right] So authors will get four things: a health check, near misses, a word-by-word "why you rank there" against the result above them, and a way to test a query before publishing.
+[Bottom] And it stays fair. It's the same formula for everyone, the score stays relevance-only, and stuffing keywords doesn't help, because each query word only counts once. Near misses will be built from aggregated searches within the teams that can see the component, never who searched.</a:t>
             </a:r>
             <a:endParaRPr lang="en-US" dirty="0"/>
           </a:p>
@@ -1957,9 +1960,11 @@
           <a:p>
             <a:r>
               <a:rPr lang="en-US" dirty="0"/>
-              <a:t>23. Thank you · Q&amp;A
-To wrap up: agents shouldn't be limited to what someone wired up in advance. ARD gives them a search layer: a small entry, a permanent domain-anchored name, one REST API, federation across registries, and trust kept separate from relevance. And I've shown you what it took to build that into a real open-source registry.
-Thank you. I'm happy to take questions.</a:t>
+              <a:t>23. Try it this week · 1:00
+If you take one thing home: you can publish an ARD entry for your own project this week. It's one small file.
+[Code] Step one: put an ard.json under /.well-known on your domain. Here's a made-up Chennai weather MCP server. It has the four required fields, and please write good representative queries, because that's what search runs on.
+[Top right] Step two: validate it with the official conformance tool from the ard-spec repo. Publisher mode fetches your file and checks it.
+[Bottom right] Step three: join in. The spec is at version 0.91, so feedback now actually shapes it. Issues for spec changes; pull requests welcome for examples, tools and implementations.</a:t>
             </a:r>
             <a:endParaRPr lang="en-US" dirty="0"/>
           </a:p>
@@ -1983,6 +1988,96 @@
             <a:fld id="{F7021451-1387-4CA6-816F-3879F97B5CBC}" type="slidenum">
               <a:rPr lang="en-US"/>
               <a:t>23</a:t>
+            </a:fld>
+            <a:endParaRPr lang="en-US"/>
+          </a:p>
+        </p:txBody>
+      </p:sp>
+    </p:spTree>
+    <p:extLst>
+      <p:ext uri="{BB962C8B-B14F-4D97-AF65-F5344CB8AC3E}">
+        <p14:creationId xmlns:p14="http://schemas.microsoft.com/office/powerpoint/2010/main" val="1024086991"/>
+      </p:ext>
+    </p:extLst>
+  </p:cSld>
+  <p:clrMapOvr>
+    <a:masterClrMapping/>
+  </p:clrMapOvr>
+</p:notes>
+</file>
+
+<file path=ppt/notesSlides/notesSlide24.xml><?xml version="1.0" encoding="utf-8"?>
+<p:notes xmlns:a="http://schemas.openxmlformats.org/drawingml/2006/main" xmlns:r="http://schemas.openxmlformats.org/officeDocument/2006/relationships" xmlns:p="http://schemas.openxmlformats.org/presentationml/2006/main">
+  <p:cSld>
+    <p:spTree>
+      <p:nvGrpSpPr>
+        <p:cNvPr id="1" name=""/>
+        <p:cNvGrpSpPr/>
+        <p:nvPr/>
+      </p:nvGrpSpPr>
+      <p:grpSpPr>
+        <a:xfrm>
+          <a:off x="0" y="0"/>
+          <a:ext cx="0" cy="0"/>
+          <a:chOff x="0" y="0"/>
+          <a:chExt cx="0" cy="0"/>
+        </a:xfrm>
+      </p:grpSpPr>
+      <p:sp>
+        <p:nvSpPr>
+          <p:cNvPr id="2" name="Slide Image Placeholder 1"/>
+          <p:cNvSpPr>
+            <a:spLocks noGrp="1" noRot="1" noChangeAspect="1"/>
+          </p:cNvSpPr>
+          <p:nvPr>
+            <p:ph type="sldImg"/>
+          </p:nvPr>
+        </p:nvSpPr>
+        <p:spPr/>
+      </p:sp>
+      <p:sp>
+        <p:nvSpPr>
+          <p:cNvPr id="3" name="Notes Placeholder 2"/>
+          <p:cNvSpPr>
+            <a:spLocks noGrp="1"/>
+          </p:cNvSpPr>
+          <p:nvPr>
+            <p:ph type="body" idx="1"/>
+          </p:nvPr>
+        </p:nvSpPr>
+        <p:spPr/>
+        <p:txBody>
+          <a:bodyPr/>
+          <a:lstStyle/>
+          <a:p>
+            <a:r>
+              <a:rPr lang="en-US" dirty="0"/>
+              <a:t>24. Thank you · Q&amp;A
+To wrap up: agents shouldn't be limited to what someone wired up in advance. ARD gives them a search layer: a small entry, a permanent domain-anchored name, one REST API, federation across registries, and trust kept separate from relevance. And I've shown you what it took to build that into a real open-source registry.
+Thank you. I'm happy to take questions.</a:t>
+            </a:r>
+            <a:endParaRPr lang="en-US" dirty="0"/>
+          </a:p>
+        </p:txBody>
+      </p:sp>
+      <p:sp>
+        <p:nvSpPr>
+          <p:cNvPr id="4" name="Slide Number Placeholder 3"/>
+          <p:cNvSpPr>
+            <a:spLocks noGrp="1"/>
+          </p:cNvSpPr>
+          <p:nvPr>
+            <p:ph type="sldNum" sz="quarter" idx="10"/>
+          </p:nvPr>
+        </p:nvSpPr>
+        <p:spPr/>
+        <p:txBody>
+          <a:bodyPr/>
+          <a:lstStyle/>
+          <a:p>
+            <a:fld id="{F7021451-1387-4CA6-816F-3879F97B5CBC}" type="slidenum">
+              <a:rPr lang="en-US"/>
+              <a:t>24</a:t>
             </a:fld>
             <a:endParaRPr lang="en-US"/>
           </a:p>
@@ -17269,7 +17364,7 @@
                   <a:schemeClr val="tx1"/>
                 </a:solidFill>
               </a:rPr>
-              <a:t>Try it yourself</a:t>
+              <a:t>What’s next, and try it</a:t>
             </a:r>
             <a:endParaRPr lang="en-US" sz="2000" dirty="0"/>
           </a:p>
@@ -17305,7 +17400,7 @@
                   <a:schemeClr val="accent6"/>
                 </a:solidFill>
               </a:rPr>
-              <a:t>Publish an entry for your own project</a:t>
+              <a:t>ARD SEO, then publishing an entry for your own project</a:t>
             </a:r>
             <a:endParaRPr lang="en-US" sz="1500" dirty="0"/>
           </a:p>
@@ -18947,7 +19042,7 @@
                   <a:schemeClr val="accent2"/>
                 </a:solidFill>
               </a:rPr>
-              <a:t>05  ·  TRY IT YOURSELF</a:t>
+              <a:t>05  ·  WHAT’S NEXT</a:t>
             </a:r>
             <a:endParaRPr lang="en-US" sz="1200" dirty="0"/>
           </a:p>
@@ -18985,7 +19080,7 @@
                   <a:schemeClr val="tx1"/>
                 </a:solidFill>
               </a:rPr>
-              <a:t>Publish an ARD entry for your own project this week</a:t>
+              <a:t>Next: ARD SEO shows authors how to get found</a:t>
             </a:r>
             <a:endParaRPr lang="en-US" sz="3200" dirty="0"/>
           </a:p>
@@ -18993,72 +19088,197 @@
       </p:sp>
       <p:sp>
         <p:nvSpPr>
-          <p:cNvPr id="4" name="Text 2"/>
-          <p:cNvSpPr txBox="1"/>
+          <p:cNvPr id="4" name="Report card"/>
+          <p:cNvSpPr/>
           <p:nvPr/>
         </p:nvSpPr>
         <p:spPr>
           <a:xfrm>
             <a:off x="548640" y="1965960"/>
-            <a:ext cx="6583680" cy="365760"/>
-          </a:xfrm>
-          <a:prstGeom prst="rect">
-            <a:avLst/>
-          </a:prstGeom>
-          <a:noFill/>
-          <a:ln/>
-        </p:spPr>
-        <p:txBody>
-          <a:bodyPr wrap="square" lIns="0" tIns="0" rIns="0" bIns="0" rtlCol="0" anchor="t"/>
-          <a:lstStyle/>
-          <a:p>
-            <a:pPr indent="0" marL="0">
-              <a:buNone/>
-            </a:pPr>
-            <a:r>
-              <a:rPr lang="en-US" sz="1700" b="1" dirty="0">
-                <a:solidFill>
-                  <a:schemeClr val="tx1"/>
-                </a:solidFill>
-              </a:rPr>
-              <a:t>1  Publish  /.well-known/ard.json</a:t>
-            </a:r>
-            <a:endParaRPr lang="en-US" sz="1700" dirty="0"/>
-          </a:p>
-        </p:txBody>
-      </p:sp>
-      <p:sp>
-        <p:nvSpPr>
-          <p:cNvPr id="5" name="ard.json example"/>
-          <p:cNvSpPr/>
-          <p:nvPr/>
-        </p:nvSpPr>
-        <p:spPr>
-          <a:xfrm>
-            <a:off x="548640" y="2423160"/>
-            <a:ext cx="6583680" cy="3657600"/>
+            <a:ext cx="6355080" cy="3474720"/>
           </a:xfrm>
           <a:prstGeom prst="roundRect">
             <a:avLst>
-              <a:gd name="adj" fmla="val 3500"/>
+              <a:gd name="adj" fmla="val 3684"/>
             </a:avLst>
           </a:prstGeom>
           <a:solidFill>
-            <a:schemeClr val="bg2"/>
+            <a:schemeClr val="bg1"/>
           </a:solidFill>
-          <a:ln/>
-        </p:spPr>
-      </p:sp>
-      <p:sp>
-        <p:nvSpPr>
-          <p:cNvPr id="6" name="Text 4"/>
+          <a:ln w="15875">
+            <a:solidFill>
+              <a:srgbClr val="B6B0D0"/>
+            </a:solidFill>
+            <a:prstDash val="solid"/>
+          </a:ln>
+          <a:effectLst>
+            <a:outerShdw sx="100000" sy="100000" kx="0" ky="0" algn="bl" rotWithShape="0" blurRad="127000" dist="38100" dir="5400000">
+              <a:srgbClr val="474552">
+                <a:alpha val="14000"/>
+              </a:srgbClr>
+            </a:outerShdw>
+          </a:effectLst>
+        </p:spPr>
+      </p:sp>
+      <p:sp>
+        <p:nvSpPr>
+          <p:cNvPr id="5" name="Report component circle"/>
+          <p:cNvSpPr/>
+          <p:nvPr/>
+        </p:nvSpPr>
+        <p:spPr>
+          <a:xfrm>
+            <a:off x="777240" y="2148840"/>
+            <a:ext cx="475488" cy="475488"/>
+          </a:xfrm>
+          <a:prstGeom prst="ellipse">
+            <a:avLst/>
+          </a:prstGeom>
+          <a:solidFill>
+            <a:schemeClr val="accent3"/>
+          </a:solidFill>
+          <a:ln/>
+        </p:spPr>
+      </p:sp>
+      <p:pic>
+        <p:nvPicPr>
+          <p:cNvPr id="6" name="Report component icon" descr="preencoded.png">    </p:cNvPr>
+          <p:cNvPicPr>
+            <a:picLocks noChangeAspect="1"/>
+          </p:cNvPicPr>
+          <p:nvPr/>
+        </p:nvPicPr>
+        <p:blipFill>
+          <a:blip r:embed="rId1"/>
+          <a:stretch>
+            <a:fillRect/>
+          </a:stretch>
+        </p:blipFill>
+        <p:spPr>
+          <a:xfrm>
+            <a:off x="896112" y="2267712"/>
+            <a:ext cx="237744" cy="237744"/>
+          </a:xfrm>
+          <a:prstGeom prst="rect">
+            <a:avLst/>
+          </a:prstGeom>
+        </p:spPr>
+      </p:pic>
+      <p:sp>
+        <p:nvSpPr>
+          <p:cNvPr id="7" name="Text 4"/>
           <p:cNvSpPr txBox="1"/>
           <p:nvPr/>
         </p:nvSpPr>
         <p:spPr>
           <a:xfrm>
-            <a:off x="822960" y="2651760"/>
-            <a:ext cx="6126480" cy="3291840"/>
+            <a:off x="1371600" y="2148840"/>
+            <a:ext cx="4206240" cy="475488"/>
+          </a:xfrm>
+          <a:prstGeom prst="rect">
+            <a:avLst/>
+          </a:prstGeom>
+          <a:noFill/>
+          <a:ln/>
+        </p:spPr>
+        <p:txBody>
+          <a:bodyPr wrap="square" lIns="0" tIns="0" rIns="0" bIns="0" rtlCol="0" anchor="ctr"/>
+          <a:lstStyle/>
+          <a:p>
+            <a:pPr indent="0" marL="0">
+              <a:buNone/>
+            </a:pPr>
+            <a:r>
+              <a:rPr lang="en-US" sz="1800" b="1" dirty="0">
+                <a:solidFill>
+                  <a:schemeClr val="tx1"/>
+                </a:solidFill>
+              </a:rPr>
+              <a:t>Security Review</a:t>
+            </a:r>
+            <a:pPr indent="0" marL="0">
+              <a:buNone/>
+            </a:pPr>
+            <a:r>
+              <a:rPr lang="en-US" sz="1300" dirty="0">
+                <a:solidFill>
+                  <a:schemeClr val="accent6"/>
+                </a:solidFill>
+              </a:rPr>
+              <a:t>   skill  ·  author view</a:t>
+            </a:r>
+            <a:endParaRPr lang="en-US" sz="1800" dirty="0"/>
+          </a:p>
+        </p:txBody>
+      </p:sp>
+      <p:sp>
+        <p:nvSpPr>
+          <p:cNvPr id="8" name="Planned chip"/>
+          <p:cNvSpPr/>
+          <p:nvPr/>
+        </p:nvSpPr>
+        <p:spPr>
+          <a:xfrm>
+            <a:off x="5715000" y="2240280"/>
+            <a:ext cx="960120" cy="292608"/>
+          </a:xfrm>
+          <a:prstGeom prst="roundRect">
+            <a:avLst>
+              <a:gd name="adj" fmla="val 50000"/>
+            </a:avLst>
+          </a:prstGeom>
+          <a:solidFill>
+            <a:schemeClr val="accent3"/>
+          </a:solidFill>
+          <a:ln/>
+        </p:spPr>
+      </p:sp>
+      <p:sp>
+        <p:nvSpPr>
+          <p:cNvPr id="9" name="Text 6"/>
+          <p:cNvSpPr txBox="1"/>
+          <p:nvPr/>
+        </p:nvSpPr>
+        <p:spPr>
+          <a:xfrm>
+            <a:off x="5715000" y="2240280"/>
+            <a:ext cx="960120" cy="292608"/>
+          </a:xfrm>
+          <a:prstGeom prst="rect">
+            <a:avLst/>
+          </a:prstGeom>
+          <a:noFill/>
+          <a:ln/>
+        </p:spPr>
+        <p:txBody>
+          <a:bodyPr wrap="square" lIns="0" tIns="0" rIns="0" bIns="0" rtlCol="0" anchor="ctr"/>
+          <a:lstStyle/>
+          <a:p>
+            <a:pPr algn="ctr" indent="0" marL="0">
+              <a:buNone/>
+            </a:pPr>
+            <a:r>
+              <a:rPr lang="en-US" sz="1200" b="1" dirty="0">
+                <a:solidFill>
+                  <a:schemeClr val="tx1"/>
+                </a:solidFill>
+              </a:rPr>
+              <a:t>Planned</a:t>
+            </a:r>
+            <a:endParaRPr lang="en-US" sz="1200" dirty="0"/>
+          </a:p>
+        </p:txBody>
+      </p:sp>
+      <p:sp>
+        <p:nvSpPr>
+          <p:cNvPr id="10" name="Text 7"/>
+          <p:cNvSpPr txBox="1"/>
+          <p:nvPr/>
+        </p:nvSpPr>
+        <p:spPr>
+          <a:xfrm>
+            <a:off x="777240" y="2761488"/>
+            <a:ext cx="3657600" cy="256032"/>
           </a:xfrm>
           <a:prstGeom prst="rect">
             <a:avLst/>
@@ -19071,521 +19291,210 @@
           <a:lstStyle/>
           <a:p>
             <a:pPr indent="0" marL="0">
-              <a:lnSpc>
-                <a:spcPct val="130000"/>
-              </a:lnSpc>
-              <a:buNone/>
-            </a:pPr>
-            <a:r>
-              <a:rPr lang="en-US" sz="1250" dirty="0">
-                <a:solidFill>
-                  <a:srgbClr val="383A42"/>
-                </a:solidFill>
-                <a:latin typeface="Consolas" pitchFamily="34" charset="0"/>
-                <a:ea typeface="Consolas" pitchFamily="34" charset="-122"/>
-                <a:cs typeface="Consolas" pitchFamily="34" charset="-120"/>
-              </a:rPr>
-              <a:t>{ </a:t>
-            </a:r>
-            <a:pPr indent="0" marL="0">
-              <a:lnSpc>
-                <a:spcPct val="130000"/>
-              </a:lnSpc>
-              <a:buNone/>
-            </a:pPr>
-            <a:r>
-              <a:rPr lang="en-US" sz="1250" dirty="0">
-                <a:solidFill>
-                  <a:srgbClr val="5A4FA0"/>
-                </a:solidFill>
-                <a:latin typeface="Consolas" pitchFamily="34" charset="0"/>
-                <a:ea typeface="Consolas" pitchFamily="34" charset="-122"/>
-                <a:cs typeface="Consolas" pitchFamily="34" charset="-120"/>
-              </a:rPr>
-              <a:t>"entries"</a:t>
-            </a:r>
-            <a:pPr indent="0" marL="0">
-              <a:lnSpc>
-                <a:spcPct val="130000"/>
-              </a:lnSpc>
-              <a:buNone/>
-            </a:pPr>
-            <a:r>
-              <a:rPr lang="en-US" sz="1250" dirty="0">
-                <a:solidFill>
-                  <a:srgbClr val="383A42"/>
-                </a:solidFill>
-                <a:latin typeface="Consolas" pitchFamily="34" charset="0"/>
-                <a:ea typeface="Consolas" pitchFamily="34" charset="-122"/>
-                <a:cs typeface="Consolas" pitchFamily="34" charset="-120"/>
-              </a:rPr>
-              <a:t>: [{</a:t>
-            </a:r>
-            <a:endParaRPr lang="en-US" sz="1250" dirty="0"/>
-          </a:p>
-          <a:p>
-            <a:pPr indent="0" marL="0">
-              <a:lnSpc>
-                <a:spcPct val="130000"/>
-              </a:lnSpc>
-              <a:buNone/>
-            </a:pPr>
-            <a:r>
-              <a:rPr lang="en-US" sz="1250" b="1" dirty="0">
-                <a:solidFill>
-                  <a:srgbClr val="C2410C"/>
-                </a:solidFill>
-                <a:latin typeface="Consolas" pitchFamily="34" charset="0"/>
-                <a:ea typeface="Consolas" pitchFamily="34" charset="-122"/>
-                <a:cs typeface="Consolas" pitchFamily="34" charset="-120"/>
-              </a:rPr>
-              <a:t>    "identifier"</a:t>
-            </a:r>
-            <a:pPr indent="0" marL="0">
-              <a:lnSpc>
-                <a:spcPct val="130000"/>
-              </a:lnSpc>
-              <a:buNone/>
-            </a:pPr>
-            <a:r>
-              <a:rPr lang="en-US" sz="1250" dirty="0">
-                <a:solidFill>
-                  <a:srgbClr val="383A42"/>
-                </a:solidFill>
-                <a:latin typeface="Consolas" pitchFamily="34" charset="0"/>
-                <a:ea typeface="Consolas" pitchFamily="34" charset="-122"/>
-                <a:cs typeface="Consolas" pitchFamily="34" charset="-120"/>
-              </a:rPr>
-              <a:t>: </a:t>
-            </a:r>
-            <a:pPr indent="0" marL="0">
-              <a:lnSpc>
-                <a:spcPct val="130000"/>
-              </a:lnSpc>
-              <a:buNone/>
-            </a:pPr>
-            <a:r>
-              <a:rPr lang="en-US" sz="1250" dirty="0">
-                <a:solidFill>
-                  <a:srgbClr val="2D6E3A"/>
-                </a:solidFill>
-                <a:latin typeface="Consolas" pitchFamily="34" charset="0"/>
-                <a:ea typeface="Consolas" pitchFamily="34" charset="-122"/>
-                <a:cs typeface="Consolas" pitchFamily="34" charset="-120"/>
-              </a:rPr>
-              <a:t>"urn:air:yourdomain.dev:mcp:weather"</a:t>
-            </a:r>
-            <a:pPr indent="0" marL="0">
-              <a:lnSpc>
-                <a:spcPct val="130000"/>
-              </a:lnSpc>
-              <a:buNone/>
-            </a:pPr>
-            <a:r>
-              <a:rPr lang="en-US" sz="1250" dirty="0">
-                <a:solidFill>
-                  <a:srgbClr val="383A42"/>
-                </a:solidFill>
-                <a:latin typeface="Consolas" pitchFamily="34" charset="0"/>
-                <a:ea typeface="Consolas" pitchFamily="34" charset="-122"/>
-                <a:cs typeface="Consolas" pitchFamily="34" charset="-120"/>
-              </a:rPr>
-              <a:t>,</a:t>
-            </a:r>
-            <a:endParaRPr lang="en-US" sz="1250" dirty="0"/>
-          </a:p>
-          <a:p>
-            <a:pPr indent="0" marL="0">
-              <a:lnSpc>
-                <a:spcPct val="130000"/>
-              </a:lnSpc>
-              <a:buNone/>
-            </a:pPr>
-            <a:r>
-              <a:rPr lang="en-US" sz="1250" b="1" dirty="0">
-                <a:solidFill>
-                  <a:srgbClr val="C2410C"/>
-                </a:solidFill>
-                <a:latin typeface="Consolas" pitchFamily="34" charset="0"/>
-                <a:ea typeface="Consolas" pitchFamily="34" charset="-122"/>
-                <a:cs typeface="Consolas" pitchFamily="34" charset="-120"/>
-              </a:rPr>
-              <a:t>    "displayName"</a:t>
-            </a:r>
-            <a:pPr indent="0" marL="0">
-              <a:lnSpc>
-                <a:spcPct val="130000"/>
-              </a:lnSpc>
-              <a:buNone/>
-            </a:pPr>
-            <a:r>
-              <a:rPr lang="en-US" sz="1250" dirty="0">
-                <a:solidFill>
-                  <a:srgbClr val="383A42"/>
-                </a:solidFill>
-                <a:latin typeface="Consolas" pitchFamily="34" charset="0"/>
-                <a:ea typeface="Consolas" pitchFamily="34" charset="-122"/>
-                <a:cs typeface="Consolas" pitchFamily="34" charset="-120"/>
-              </a:rPr>
-              <a:t>: </a:t>
-            </a:r>
-            <a:pPr indent="0" marL="0">
-              <a:lnSpc>
-                <a:spcPct val="130000"/>
-              </a:lnSpc>
-              <a:buNone/>
-            </a:pPr>
-            <a:r>
-              <a:rPr lang="en-US" sz="1250" dirty="0">
-                <a:solidFill>
-                  <a:srgbClr val="2D6E3A"/>
-                </a:solidFill>
-                <a:latin typeface="Consolas" pitchFamily="34" charset="0"/>
-                <a:ea typeface="Consolas" pitchFamily="34" charset="-122"/>
-                <a:cs typeface="Consolas" pitchFamily="34" charset="-120"/>
-              </a:rPr>
-              <a:t>"Chennai Weather"</a:t>
-            </a:r>
-            <a:pPr indent="0" marL="0">
-              <a:lnSpc>
-                <a:spcPct val="130000"/>
-              </a:lnSpc>
-              <a:buNone/>
-            </a:pPr>
-            <a:r>
-              <a:rPr lang="en-US" sz="1250" dirty="0">
-                <a:solidFill>
-                  <a:srgbClr val="383A42"/>
-                </a:solidFill>
-                <a:latin typeface="Consolas" pitchFamily="34" charset="0"/>
-                <a:ea typeface="Consolas" pitchFamily="34" charset="-122"/>
-                <a:cs typeface="Consolas" pitchFamily="34" charset="-120"/>
-              </a:rPr>
-              <a:t>,</a:t>
-            </a:r>
-            <a:endParaRPr lang="en-US" sz="1250" dirty="0"/>
-          </a:p>
-          <a:p>
-            <a:pPr indent="0" marL="0">
-              <a:lnSpc>
-                <a:spcPct val="130000"/>
-              </a:lnSpc>
-              <a:buNone/>
-            </a:pPr>
-            <a:r>
-              <a:rPr lang="en-US" sz="1250" b="1" dirty="0">
-                <a:solidFill>
-                  <a:srgbClr val="C2410C"/>
-                </a:solidFill>
-                <a:latin typeface="Consolas" pitchFamily="34" charset="0"/>
-                <a:ea typeface="Consolas" pitchFamily="34" charset="-122"/>
-                <a:cs typeface="Consolas" pitchFamily="34" charset="-120"/>
-              </a:rPr>
-              <a:t>    "type"</a:t>
-            </a:r>
-            <a:pPr indent="0" marL="0">
-              <a:lnSpc>
-                <a:spcPct val="130000"/>
-              </a:lnSpc>
-              <a:buNone/>
-            </a:pPr>
-            <a:r>
-              <a:rPr lang="en-US" sz="1250" dirty="0">
-                <a:solidFill>
-                  <a:srgbClr val="383A42"/>
-                </a:solidFill>
-                <a:latin typeface="Consolas" pitchFamily="34" charset="0"/>
-                <a:ea typeface="Consolas" pitchFamily="34" charset="-122"/>
-                <a:cs typeface="Consolas" pitchFamily="34" charset="-120"/>
-              </a:rPr>
-              <a:t>: </a:t>
-            </a:r>
-            <a:pPr indent="0" marL="0">
-              <a:lnSpc>
-                <a:spcPct val="130000"/>
-              </a:lnSpc>
-              <a:buNone/>
-            </a:pPr>
-            <a:r>
-              <a:rPr lang="en-US" sz="1250" dirty="0">
-                <a:solidFill>
-                  <a:srgbClr val="2D6E3A"/>
-                </a:solidFill>
-                <a:latin typeface="Consolas" pitchFamily="34" charset="0"/>
-                <a:ea typeface="Consolas" pitchFamily="34" charset="-122"/>
-                <a:cs typeface="Consolas" pitchFamily="34" charset="-120"/>
-              </a:rPr>
-              <a:t>"application/mcp-server-card+json"</a:t>
-            </a:r>
-            <a:pPr indent="0" marL="0">
-              <a:lnSpc>
-                <a:spcPct val="130000"/>
-              </a:lnSpc>
-              <a:buNone/>
-            </a:pPr>
-            <a:r>
-              <a:rPr lang="en-US" sz="1250" dirty="0">
-                <a:solidFill>
-                  <a:srgbClr val="383A42"/>
-                </a:solidFill>
-                <a:latin typeface="Consolas" pitchFamily="34" charset="0"/>
-                <a:ea typeface="Consolas" pitchFamily="34" charset="-122"/>
-                <a:cs typeface="Consolas" pitchFamily="34" charset="-120"/>
-              </a:rPr>
-              <a:t>,</a:t>
-            </a:r>
-            <a:endParaRPr lang="en-US" sz="1250" dirty="0"/>
-          </a:p>
-          <a:p>
-            <a:pPr indent="0" marL="0">
-              <a:lnSpc>
-                <a:spcPct val="130000"/>
-              </a:lnSpc>
-              <a:buNone/>
-            </a:pPr>
-            <a:r>
-              <a:rPr lang="en-US" sz="1250" b="1" dirty="0">
-                <a:solidFill>
-                  <a:srgbClr val="C2410C"/>
-                </a:solidFill>
-                <a:latin typeface="Consolas" pitchFamily="34" charset="0"/>
-                <a:ea typeface="Consolas" pitchFamily="34" charset="-122"/>
-                <a:cs typeface="Consolas" pitchFamily="34" charset="-120"/>
-              </a:rPr>
-              <a:t>    "url"</a:t>
-            </a:r>
-            <a:pPr indent="0" marL="0">
-              <a:lnSpc>
-                <a:spcPct val="130000"/>
-              </a:lnSpc>
-              <a:buNone/>
-            </a:pPr>
-            <a:r>
-              <a:rPr lang="en-US" sz="1250" dirty="0">
-                <a:solidFill>
-                  <a:srgbClr val="383A42"/>
-                </a:solidFill>
-                <a:latin typeface="Consolas" pitchFamily="34" charset="0"/>
-                <a:ea typeface="Consolas" pitchFamily="34" charset="-122"/>
-                <a:cs typeface="Consolas" pitchFamily="34" charset="-120"/>
-              </a:rPr>
-              <a:t>: </a:t>
-            </a:r>
-            <a:pPr indent="0" marL="0">
-              <a:lnSpc>
-                <a:spcPct val="130000"/>
-              </a:lnSpc>
-              <a:buNone/>
-            </a:pPr>
-            <a:r>
-              <a:rPr lang="en-US" sz="1250" dirty="0">
-                <a:solidFill>
-                  <a:srgbClr val="2D6E3A"/>
-                </a:solidFill>
-                <a:latin typeface="Consolas" pitchFamily="34" charset="0"/>
-                <a:ea typeface="Consolas" pitchFamily="34" charset="-122"/>
-                <a:cs typeface="Consolas" pitchFamily="34" charset="-120"/>
-              </a:rPr>
-              <a:t>"https://yourdomain.dev/mcp/weather.json"</a:t>
-            </a:r>
-            <a:pPr indent="0" marL="0">
-              <a:lnSpc>
-                <a:spcPct val="130000"/>
-              </a:lnSpc>
-              <a:buNone/>
-            </a:pPr>
-            <a:r>
-              <a:rPr lang="en-US" sz="1250" dirty="0">
-                <a:solidFill>
-                  <a:srgbClr val="383A42"/>
-                </a:solidFill>
-                <a:latin typeface="Consolas" pitchFamily="34" charset="0"/>
-                <a:ea typeface="Consolas" pitchFamily="34" charset="-122"/>
-                <a:cs typeface="Consolas" pitchFamily="34" charset="-120"/>
-              </a:rPr>
-              <a:t>,</a:t>
-            </a:r>
-            <a:endParaRPr lang="en-US" sz="1250" dirty="0"/>
-          </a:p>
-          <a:p>
-            <a:pPr indent="0" marL="0">
-              <a:lnSpc>
-                <a:spcPct val="130000"/>
-              </a:lnSpc>
-              <a:buNone/>
-            </a:pPr>
-            <a:r>
-              <a:rPr lang="en-US" sz="1250" b="1" dirty="0">
-                <a:solidFill>
-                  <a:srgbClr val="5A4FA0"/>
-                </a:solidFill>
-                <a:latin typeface="Consolas" pitchFamily="34" charset="0"/>
-                <a:ea typeface="Consolas" pitchFamily="34" charset="-122"/>
-                <a:cs typeface="Consolas" pitchFamily="34" charset="-120"/>
-              </a:rPr>
-              <a:t>    "representativeQueries"</a:t>
-            </a:r>
-            <a:pPr indent="0" marL="0">
-              <a:lnSpc>
-                <a:spcPct val="130000"/>
-              </a:lnSpc>
-              <a:buNone/>
-            </a:pPr>
-            <a:r>
-              <a:rPr lang="en-US" sz="1250" dirty="0">
-                <a:solidFill>
-                  <a:srgbClr val="383A42"/>
-                </a:solidFill>
-                <a:latin typeface="Consolas" pitchFamily="34" charset="0"/>
-                <a:ea typeface="Consolas" pitchFamily="34" charset="-122"/>
-                <a:cs typeface="Consolas" pitchFamily="34" charset="-120"/>
-              </a:rPr>
-              <a:t>: [</a:t>
-            </a:r>
-            <a:endParaRPr lang="en-US" sz="1250" dirty="0"/>
-          </a:p>
-          <a:p>
-            <a:pPr indent="0" marL="0">
-              <a:lnSpc>
-                <a:spcPct val="130000"/>
-              </a:lnSpc>
-              <a:buNone/>
-            </a:pPr>
-            <a:r>
-              <a:rPr lang="en-US" sz="1250" dirty="0">
-                <a:solidFill>
-                  <a:srgbClr val="2D6E3A"/>
-                </a:solidFill>
-                <a:latin typeface="Consolas" pitchFamily="34" charset="0"/>
-                <a:ea typeface="Consolas" pitchFamily="34" charset="-122"/>
-                <a:cs typeface="Consolas" pitchFamily="34" charset="-120"/>
-              </a:rPr>
-              <a:t>      "will it rain in Chennai tomorrow"</a:t>
-            </a:r>
-            <a:pPr indent="0" marL="0">
-              <a:lnSpc>
-                <a:spcPct val="130000"/>
-              </a:lnSpc>
-              <a:buNone/>
-            </a:pPr>
-            <a:r>
-              <a:rPr lang="en-US" sz="1250" dirty="0">
-                <a:solidFill>
-                  <a:srgbClr val="383A42"/>
-                </a:solidFill>
-                <a:latin typeface="Consolas" pitchFamily="34" charset="0"/>
-                <a:ea typeface="Consolas" pitchFamily="34" charset="-122"/>
-                <a:cs typeface="Consolas" pitchFamily="34" charset="-120"/>
-              </a:rPr>
-              <a:t>,</a:t>
-            </a:r>
-            <a:endParaRPr lang="en-US" sz="1250" dirty="0"/>
-          </a:p>
-          <a:p>
-            <a:pPr indent="0" marL="0">
-              <a:lnSpc>
-                <a:spcPct val="130000"/>
-              </a:lnSpc>
-              <a:buNone/>
-            </a:pPr>
-            <a:r>
-              <a:rPr lang="en-US" sz="1250" dirty="0">
-                <a:solidFill>
-                  <a:srgbClr val="2D6E3A"/>
-                </a:solidFill>
-                <a:latin typeface="Consolas" pitchFamily="34" charset="0"/>
-                <a:ea typeface="Consolas" pitchFamily="34" charset="-122"/>
-                <a:cs typeface="Consolas" pitchFamily="34" charset="-120"/>
-              </a:rPr>
-              <a:t>      "current humidity in Chennai"</a:t>
-            </a:r>
-            <a:pPr indent="0" marL="0">
-              <a:lnSpc>
-                <a:spcPct val="130000"/>
-              </a:lnSpc>
-              <a:buNone/>
-            </a:pPr>
-            <a:r>
-              <a:rPr lang="en-US" sz="1250" dirty="0">
-                <a:solidFill>
-                  <a:srgbClr val="383A42"/>
-                </a:solidFill>
-                <a:latin typeface="Consolas" pitchFamily="34" charset="0"/>
-                <a:ea typeface="Consolas" pitchFamily="34" charset="-122"/>
-                <a:cs typeface="Consolas" pitchFamily="34" charset="-120"/>
-              </a:rPr>
-              <a:t>]</a:t>
-            </a:r>
-            <a:endParaRPr lang="en-US" sz="1250" dirty="0"/>
-          </a:p>
-          <a:p>
-            <a:pPr indent="0" marL="0">
-              <a:lnSpc>
-                <a:spcPct val="130000"/>
-              </a:lnSpc>
-              <a:buNone/>
-            </a:pPr>
-            <a:r>
-              <a:rPr lang="en-US" sz="1250" dirty="0">
-                <a:solidFill>
-                  <a:srgbClr val="383A42"/>
-                </a:solidFill>
-                <a:latin typeface="Consolas" pitchFamily="34" charset="0"/>
-                <a:ea typeface="Consolas" pitchFamily="34" charset="-122"/>
-                <a:cs typeface="Consolas" pitchFamily="34" charset="-120"/>
-              </a:rPr>
-              <a:t>}] }</a:t>
-            </a:r>
-            <a:endParaRPr lang="en-US" sz="1250" dirty="0"/>
-          </a:p>
-        </p:txBody>
-      </p:sp>
-      <p:sp>
-        <p:nvSpPr>
-          <p:cNvPr id="7" name="Text 5"/>
+              <a:buNone/>
+            </a:pPr>
+            <a:r>
+              <a:rPr lang="en-US" sz="1100" b="1" spc="100" kern="0" dirty="0">
+                <a:solidFill>
+                  <a:schemeClr val="accent6"/>
+                </a:solidFill>
+              </a:rPr>
+              <a:t>DISCOVERY CHECKLIST</a:t>
+            </a:r>
+            <a:endParaRPr lang="en-US" sz="1100" dirty="0"/>
+          </a:p>
+        </p:txBody>
+      </p:sp>
+      <p:pic>
+        <p:nvPicPr>
+          <p:cNvPr id="11" name="Check 1 icon" descr="preencoded.png">    </p:cNvPr>
+          <p:cNvPicPr>
+            <a:picLocks noChangeAspect="1"/>
+          </p:cNvPicPr>
+          <p:nvPr/>
+        </p:nvPicPr>
+        <p:blipFill>
+          <a:blip r:embed="rId2"/>
+          <a:stretch>
+            <a:fillRect/>
+          </a:stretch>
+        </p:blipFill>
+        <p:spPr>
+          <a:xfrm>
+            <a:off x="804672" y="3072384"/>
+            <a:ext cx="219456" cy="219456"/>
+          </a:xfrm>
+          <a:prstGeom prst="rect">
+            <a:avLst/>
+          </a:prstGeom>
+        </p:spPr>
+      </p:pic>
+      <p:sp>
+        <p:nvSpPr>
+          <p:cNvPr id="12" name="Text 8"/>
           <p:cNvSpPr txBox="1"/>
           <p:nvPr/>
         </p:nvSpPr>
         <p:spPr>
           <a:xfrm>
-            <a:off x="7498080" y="1965960"/>
-            <a:ext cx="4114800" cy="365760"/>
-          </a:xfrm>
-          <a:prstGeom prst="rect">
-            <a:avLst/>
-          </a:prstGeom>
-          <a:noFill/>
-          <a:ln/>
-        </p:spPr>
-        <p:txBody>
-          <a:bodyPr wrap="square" lIns="0" tIns="0" rIns="0" bIns="0" rtlCol="0" anchor="t"/>
-          <a:lstStyle/>
-          <a:p>
-            <a:pPr indent="0" marL="0">
-              <a:buNone/>
-            </a:pPr>
-            <a:r>
-              <a:rPr lang="en-US" sz="1700" b="1" dirty="0">
+            <a:off x="1143000" y="3035808"/>
+            <a:ext cx="5577840" cy="292608"/>
+          </a:xfrm>
+          <a:prstGeom prst="rect">
+            <a:avLst/>
+          </a:prstGeom>
+          <a:noFill/>
+          <a:ln/>
+        </p:spPr>
+        <p:txBody>
+          <a:bodyPr wrap="square" lIns="0" tIns="0" rIns="0" bIns="0" rtlCol="0" anchor="ctr"/>
+          <a:lstStyle/>
+          <a:p>
+            <a:pPr indent="0" marL="0">
+              <a:buNone/>
+            </a:pPr>
+            <a:r>
+              <a:rPr lang="en-US" sz="1400" dirty="0">
                 <a:solidFill>
                   <a:schemeClr val="tx1"/>
                 </a:solidFill>
               </a:rPr>
-              <a:t>2  Validate it</a:t>
-            </a:r>
-            <a:endParaRPr lang="en-US" sz="1700" dirty="0"/>
-          </a:p>
-        </p:txBody>
-      </p:sp>
-      <p:sp>
-        <p:nvSpPr>
-          <p:cNvPr id="8" name="Validate command"/>
+              <a:t>Approved and visible to your teams</a:t>
+            </a:r>
+            <a:endParaRPr lang="en-US" sz="1400" dirty="0"/>
+          </a:p>
+        </p:txBody>
+      </p:sp>
+      <p:pic>
+        <p:nvPicPr>
+          <p:cNvPr id="13" name="Check 2 icon" descr="preencoded.png">    </p:cNvPr>
+          <p:cNvPicPr>
+            <a:picLocks noChangeAspect="1"/>
+          </p:cNvPicPr>
+          <p:nvPr/>
+        </p:nvPicPr>
+        <p:blipFill>
+          <a:blip r:embed="rId3"/>
+          <a:stretch>
+            <a:fillRect/>
+          </a:stretch>
+        </p:blipFill>
+        <p:spPr>
+          <a:xfrm>
+            <a:off x="804672" y="3383280"/>
+            <a:ext cx="219456" cy="219456"/>
+          </a:xfrm>
+          <a:prstGeom prst="rect">
+            <a:avLst/>
+          </a:prstGeom>
+        </p:spPr>
+      </p:pic>
+      <p:sp>
+        <p:nvSpPr>
+          <p:cNvPr id="14" name="Text 9"/>
+          <p:cNvSpPr txBox="1"/>
+          <p:nvPr/>
+        </p:nvSpPr>
+        <p:spPr>
+          <a:xfrm>
+            <a:off x="1143000" y="3346704"/>
+            <a:ext cx="5577840" cy="292608"/>
+          </a:xfrm>
+          <a:prstGeom prst="rect">
+            <a:avLst/>
+          </a:prstGeom>
+          <a:noFill/>
+          <a:ln/>
+        </p:spPr>
+        <p:txBody>
+          <a:bodyPr wrap="square" lIns="0" tIns="0" rIns="0" bIns="0" rtlCol="0" anchor="ctr"/>
+          <a:lstStyle/>
+          <a:p>
+            <a:pPr indent="0" marL="0">
+              <a:buNone/>
+            </a:pPr>
+            <a:r>
+              <a:rPr lang="en-US" sz="1400" dirty="0">
+                <a:solidFill>
+                  <a:schemeClr val="tx1"/>
+                </a:solidFill>
+              </a:rPr>
+              <a:t>2 example queries; aim for 3–5</a:t>
+            </a:r>
+            <a:endParaRPr lang="en-US" sz="1400" dirty="0"/>
+          </a:p>
+        </p:txBody>
+      </p:sp>
+      <p:pic>
+        <p:nvPicPr>
+          <p:cNvPr id="15" name="Check 3 icon" descr="preencoded.png">    </p:cNvPr>
+          <p:cNvPicPr>
+            <a:picLocks noChangeAspect="1"/>
+          </p:cNvPicPr>
+          <p:nvPr/>
+        </p:nvPicPr>
+        <p:blipFill>
+          <a:blip r:embed="rId4"/>
+          <a:stretch>
+            <a:fillRect/>
+          </a:stretch>
+        </p:blipFill>
+        <p:spPr>
+          <a:xfrm>
+            <a:off x="804672" y="3694176"/>
+            <a:ext cx="219456" cy="219456"/>
+          </a:xfrm>
+          <a:prstGeom prst="rect">
+            <a:avLst/>
+          </a:prstGeom>
+        </p:spPr>
+      </p:pic>
+      <p:sp>
+        <p:nvSpPr>
+          <p:cNvPr id="16" name="Text 10"/>
+          <p:cNvSpPr txBox="1"/>
+          <p:nvPr/>
+        </p:nvSpPr>
+        <p:spPr>
+          <a:xfrm>
+            <a:off x="1143000" y="3657600"/>
+            <a:ext cx="5577840" cy="292608"/>
+          </a:xfrm>
+          <a:prstGeom prst="rect">
+            <a:avLst/>
+          </a:prstGeom>
+          <a:noFill/>
+          <a:ln/>
+        </p:spPr>
+        <p:txBody>
+          <a:bodyPr wrap="square" lIns="0" tIns="0" rIns="0" bIns="0" rtlCol="0" anchor="ctr"/>
+          <a:lstStyle/>
+          <a:p>
+            <a:pPr indent="0" marL="0">
+              <a:buNone/>
+            </a:pPr>
+            <a:r>
+              <a:rPr lang="en-US" sz="1400" dirty="0">
+                <a:solidFill>
+                  <a:schemeClr val="tx1"/>
+                </a:solidFill>
+              </a:rPr>
+              <a:t>No harnesses declared, so harness-filtered searches skip it</a:t>
+            </a:r>
+            <a:endParaRPr lang="en-US" sz="1400" dirty="0"/>
+          </a:p>
+        </p:txBody>
+      </p:sp>
+      <p:sp>
+        <p:nvSpPr>
+          <p:cNvPr id="17" name="Near miss"/>
           <p:cNvSpPr/>
           <p:nvPr/>
         </p:nvSpPr>
         <p:spPr>
           <a:xfrm>
-            <a:off x="7498080" y="2423160"/>
-            <a:ext cx="4142232" cy="1280160"/>
+            <a:off x="777240" y="4023360"/>
+            <a:ext cx="5897880" cy="1280160"/>
           </a:xfrm>
           <a:prstGeom prst="roundRect">
             <a:avLst>
@@ -19593,21 +19502,23 @@
             </a:avLst>
           </a:prstGeom>
           <a:solidFill>
-            <a:schemeClr val="bg2"/>
+            <a:schemeClr val="accent1">
+              <a:alpha val="12000"/>
+            </a:schemeClr>
           </a:solidFill>
           <a:ln/>
         </p:spPr>
       </p:sp>
       <p:sp>
         <p:nvSpPr>
-          <p:cNvPr id="9" name="Text 7"/>
+          <p:cNvPr id="18" name="Text 12"/>
           <p:cNvSpPr txBox="1"/>
           <p:nvPr/>
         </p:nvSpPr>
         <p:spPr>
           <a:xfrm>
-            <a:off x="7726680" y="2606040"/>
-            <a:ext cx="3794760" cy="914400"/>
+            <a:off x="960120" y="4087368"/>
+            <a:ext cx="2743200" cy="237744"/>
           </a:xfrm>
           <a:prstGeom prst="rect">
             <a:avLst/>
@@ -19620,58 +19531,361 @@
           <a:lstStyle/>
           <a:p>
             <a:pPr indent="0" marL="0">
+              <a:buNone/>
+            </a:pPr>
+            <a:r>
+              <a:rPr lang="en-US" sz="1100" b="1" spc="100" kern="0" dirty="0">
+                <a:solidFill>
+                  <a:schemeClr val="accent2"/>
+                </a:solidFill>
+              </a:rPr>
+              <a:t>NEAR MISS</a:t>
+            </a:r>
+            <a:endParaRPr lang="en-US" sz="1100" dirty="0"/>
+          </a:p>
+        </p:txBody>
+      </p:sp>
+      <p:sp>
+        <p:nvSpPr>
+          <p:cNvPr id="19" name="Text 13"/>
+          <p:cNvSpPr txBox="1"/>
+          <p:nvPr/>
+        </p:nvSpPr>
+        <p:spPr>
+          <a:xfrm>
+            <a:off x="960120" y="4325112"/>
+            <a:ext cx="5623560" cy="932688"/>
+          </a:xfrm>
+          <a:prstGeom prst="rect">
+            <a:avLst/>
+          </a:prstGeom>
+          <a:noFill/>
+          <a:ln/>
+        </p:spPr>
+        <p:txBody>
+          <a:bodyPr wrap="square" lIns="0" tIns="0" rIns="0" bIns="0" rtlCol="0" anchor="t"/>
+          <a:lstStyle/>
+          <a:p>
+            <a:pPr indent="0" marL="0">
               <a:lnSpc>
-                <a:spcPct val="130000"/>
+                <a:spcPct val="105000"/>
               </a:lnSpc>
               <a:buNone/>
             </a:pPr>
             <a:r>
+              <a:rPr lang="en-US" sz="1300" i="1" dirty="0">
+                <a:solidFill>
+                  <a:schemeClr val="tx1"/>
+                </a:solidFill>
+              </a:rPr>
+              <a:t>Search: “find an auth bypass in the payments PR”</a:t>
+            </a:r>
+            <a:endParaRPr lang="en-US" sz="1300" dirty="0"/>
+          </a:p>
+          <a:p>
+            <a:pPr indent="0" marL="0">
+              <a:lnSpc>
+                <a:spcPct val="105000"/>
+              </a:lnSpc>
+              <a:buNone/>
+            </a:pPr>
+            <a:r>
+              <a:rPr lang="en-US" sz="1300" dirty="0">
+                <a:solidFill>
+                  <a:schemeClr val="tx1"/>
+                </a:solidFill>
+              </a:rPr>
+              <a:t>You rank #3 (21): two “… Author” skills win because “auth” matches “Author”</a:t>
+            </a:r>
+            <a:endParaRPr lang="en-US" sz="1300" dirty="0"/>
+          </a:p>
+          <a:p>
+            <a:pPr indent="0" marL="0">
+              <a:lnSpc>
+                <a:spcPct val="105000"/>
+              </a:lnSpc>
+              <a:buNone/>
+            </a:pPr>
+            <a:r>
+              <a:rPr lang="en-US" sz="1300" dirty="0">
+                <a:solidFill>
+                  <a:schemeClr val="tx1"/>
+                </a:solidFill>
+              </a:rPr>
+              <a:t>Missing words: bypass, payments</a:t>
+            </a:r>
+            <a:endParaRPr lang="en-US" sz="1300" dirty="0"/>
+          </a:p>
+          <a:p>
+            <a:pPr indent="0" marL="0">
+              <a:lnSpc>
+                <a:spcPct val="105000"/>
+              </a:lnSpc>
+              <a:buNone/>
+            </a:pPr>
+            <a:r>
               <a:rPr lang="en-US" sz="1300" b="1" dirty="0">
                 <a:solidFill>
-                  <a:srgbClr val="C2410C"/>
-                </a:solidFill>
-                <a:latin typeface="Consolas" pitchFamily="34" charset="0"/>
-                <a:ea typeface="Consolas" pitchFamily="34" charset="-122"/>
-                <a:cs typeface="Consolas" pitchFamily="34" charset="-120"/>
-              </a:rPr>
-              <a:t>$ </a:t>
-            </a:r>
-            <a:pPr indent="0" marL="0">
-              <a:lnSpc>
-                <a:spcPct val="130000"/>
-              </a:lnSpc>
+                  <a:schemeClr val="tx1"/>
+                </a:solidFill>
+              </a:rPr>
+              <a:t>Fix: add the query “find an auth bypass in payment code”  →  #1 (80)</a:t>
+            </a:r>
+            <a:endParaRPr lang="en-US" sz="1300" dirty="0"/>
+          </a:p>
+        </p:txBody>
+      </p:sp>
+      <p:sp>
+        <p:nvSpPr>
+          <p:cNvPr id="20" name="SEO item 1"/>
+          <p:cNvSpPr/>
+          <p:nvPr/>
+        </p:nvSpPr>
+        <p:spPr>
+          <a:xfrm>
+            <a:off x="7269480" y="1965960"/>
+            <a:ext cx="457200" cy="457200"/>
+          </a:xfrm>
+          <a:prstGeom prst="ellipse">
+            <a:avLst/>
+          </a:prstGeom>
+          <a:solidFill>
+            <a:schemeClr val="accent5"/>
+          </a:solidFill>
+          <a:ln/>
+        </p:spPr>
+      </p:sp>
+      <p:sp>
+        <p:nvSpPr>
+          <p:cNvPr id="21" name="Text 15"/>
+          <p:cNvSpPr txBox="1"/>
+          <p:nvPr/>
+        </p:nvSpPr>
+        <p:spPr>
+          <a:xfrm>
+            <a:off x="7269480" y="1965960"/>
+            <a:ext cx="457200" cy="457200"/>
+          </a:xfrm>
+          <a:prstGeom prst="rect">
+            <a:avLst/>
+          </a:prstGeom>
+          <a:noFill/>
+          <a:ln/>
+        </p:spPr>
+        <p:txBody>
+          <a:bodyPr wrap="square" lIns="0" tIns="0" rIns="0" bIns="0" rtlCol="0" anchor="ctr"/>
+          <a:lstStyle/>
+          <a:p>
+            <a:pPr algn="ctr" indent="0" marL="0">
+              <a:buNone/>
+            </a:pPr>
+            <a:r>
+              <a:rPr lang="en-US" sz="1400" b="1" dirty="0">
+                <a:solidFill>
+                  <a:schemeClr val="bg1"/>
+                </a:solidFill>
+              </a:rPr>
+              <a:t>1</a:t>
+            </a:r>
+            <a:endParaRPr lang="en-US" sz="1400" dirty="0"/>
+          </a:p>
+        </p:txBody>
+      </p:sp>
+      <p:sp>
+        <p:nvSpPr>
+          <p:cNvPr id="22" name="Text 16"/>
+          <p:cNvSpPr txBox="1"/>
+          <p:nvPr/>
+        </p:nvSpPr>
+        <p:spPr>
+          <a:xfrm>
+            <a:off x="7863840" y="1947672"/>
+            <a:ext cx="3749040" cy="310896"/>
+          </a:xfrm>
+          <a:prstGeom prst="rect">
+            <a:avLst/>
+          </a:prstGeom>
+          <a:noFill/>
+          <a:ln/>
+        </p:spPr>
+        <p:txBody>
+          <a:bodyPr wrap="square" lIns="0" tIns="0" rIns="0" bIns="0" rtlCol="0" anchor="t"/>
+          <a:lstStyle/>
+          <a:p>
+            <a:pPr indent="0" marL="0">
+              <a:buNone/>
+            </a:pPr>
+            <a:r>
+              <a:rPr lang="en-US" sz="1600" b="1" dirty="0">
+                <a:solidFill>
+                  <a:schemeClr val="tx1"/>
+                </a:solidFill>
+              </a:rPr>
+              <a:t>Health check</a:t>
+            </a:r>
+            <a:endParaRPr lang="en-US" sz="1600" dirty="0"/>
+          </a:p>
+        </p:txBody>
+      </p:sp>
+      <p:sp>
+        <p:nvSpPr>
+          <p:cNvPr id="23" name="Text 17"/>
+          <p:cNvSpPr txBox="1"/>
+          <p:nvPr/>
+        </p:nvSpPr>
+        <p:spPr>
+          <a:xfrm>
+            <a:off x="7863840" y="2258568"/>
+            <a:ext cx="3749040" cy="530352"/>
+          </a:xfrm>
+          <a:prstGeom prst="rect">
+            <a:avLst/>
+          </a:prstGeom>
+          <a:noFill/>
+          <a:ln/>
+        </p:spPr>
+        <p:txBody>
+          <a:bodyPr wrap="square" lIns="0" tIns="0" rIns="0" bIns="0" rtlCol="0" anchor="t"/>
+          <a:lstStyle/>
+          <a:p>
+            <a:pPr indent="0" marL="0">
               <a:buNone/>
             </a:pPr>
             <a:r>
               <a:rPr lang="en-US" sz="1300" dirty="0">
                 <a:solidFill>
-                  <a:srgbClr val="383A42"/>
-                </a:solidFill>
-                <a:latin typeface="Consolas" pitchFamily="34" charset="0"/>
-                <a:ea typeface="Consolas" pitchFamily="34" charset="-122"/>
-                <a:cs typeface="Consolas" pitchFamily="34" charset="-120"/>
-              </a:rPr>
-              <a:t>conformance-test \</a:t>
+                  <a:schemeClr val="accent6"/>
+                </a:solidFill>
+              </a:rPr>
+              <a:t>The spec’s discovery signals, checked: example queries, description, capabilities, harnesses</a:t>
             </a:r>
             <a:endParaRPr lang="en-US" sz="1300" dirty="0"/>
           </a:p>
-          <a:p>
-            <a:pPr indent="0" marL="0">
-              <a:lnSpc>
-                <a:spcPct val="130000"/>
-              </a:lnSpc>
+        </p:txBody>
+      </p:sp>
+      <p:sp>
+        <p:nvSpPr>
+          <p:cNvPr id="24" name="SEO item 2"/>
+          <p:cNvSpPr/>
+          <p:nvPr/>
+        </p:nvSpPr>
+        <p:spPr>
+          <a:xfrm>
+            <a:off x="7269480" y="2834640"/>
+            <a:ext cx="457200" cy="457200"/>
+          </a:xfrm>
+          <a:prstGeom prst="ellipse">
+            <a:avLst/>
+          </a:prstGeom>
+          <a:solidFill>
+            <a:schemeClr val="accent5"/>
+          </a:solidFill>
+          <a:ln/>
+        </p:spPr>
+      </p:sp>
+      <p:sp>
+        <p:nvSpPr>
+          <p:cNvPr id="25" name="Text 19"/>
+          <p:cNvSpPr txBox="1"/>
+          <p:nvPr/>
+        </p:nvSpPr>
+        <p:spPr>
+          <a:xfrm>
+            <a:off x="7269480" y="2834640"/>
+            <a:ext cx="457200" cy="457200"/>
+          </a:xfrm>
+          <a:prstGeom prst="rect">
+            <a:avLst/>
+          </a:prstGeom>
+          <a:noFill/>
+          <a:ln/>
+        </p:spPr>
+        <p:txBody>
+          <a:bodyPr wrap="square" lIns="0" tIns="0" rIns="0" bIns="0" rtlCol="0" anchor="ctr"/>
+          <a:lstStyle/>
+          <a:p>
+            <a:pPr algn="ctr" indent="0" marL="0">
+              <a:buNone/>
+            </a:pPr>
+            <a:r>
+              <a:rPr lang="en-US" sz="1400" b="1" dirty="0">
+                <a:solidFill>
+                  <a:schemeClr val="bg1"/>
+                </a:solidFill>
+              </a:rPr>
+              <a:t>2</a:t>
+            </a:r>
+            <a:endParaRPr lang="en-US" sz="1400" dirty="0"/>
+          </a:p>
+        </p:txBody>
+      </p:sp>
+      <p:sp>
+        <p:nvSpPr>
+          <p:cNvPr id="26" name="Text 20"/>
+          <p:cNvSpPr txBox="1"/>
+          <p:nvPr/>
+        </p:nvSpPr>
+        <p:spPr>
+          <a:xfrm>
+            <a:off x="7863840" y="2816352"/>
+            <a:ext cx="3749040" cy="310896"/>
+          </a:xfrm>
+          <a:prstGeom prst="rect">
+            <a:avLst/>
+          </a:prstGeom>
+          <a:noFill/>
+          <a:ln/>
+        </p:spPr>
+        <p:txBody>
+          <a:bodyPr wrap="square" lIns="0" tIns="0" rIns="0" bIns="0" rtlCol="0" anchor="t"/>
+          <a:lstStyle/>
+          <a:p>
+            <a:pPr indent="0" marL="0">
+              <a:buNone/>
+            </a:pPr>
+            <a:r>
+              <a:rPr lang="en-US" sz="1600" b="1" dirty="0">
+                <a:solidFill>
+                  <a:schemeClr val="tx1"/>
+                </a:solidFill>
+              </a:rPr>
+              <a:t>Near misses</a:t>
+            </a:r>
+            <a:endParaRPr lang="en-US" sz="1600" dirty="0"/>
+          </a:p>
+        </p:txBody>
+      </p:sp>
+      <p:sp>
+        <p:nvSpPr>
+          <p:cNvPr id="27" name="Text 21"/>
+          <p:cNvSpPr txBox="1"/>
+          <p:nvPr/>
+        </p:nvSpPr>
+        <p:spPr>
+          <a:xfrm>
+            <a:off x="7863840" y="3127248"/>
+            <a:ext cx="3749040" cy="530352"/>
+          </a:xfrm>
+          <a:prstGeom prst="rect">
+            <a:avLst/>
+          </a:prstGeom>
+          <a:noFill/>
+          <a:ln/>
+        </p:spPr>
+        <p:txBody>
+          <a:bodyPr wrap="square" lIns="0" tIns="0" rIns="0" bIns="0" rtlCol="0" anchor="t"/>
+          <a:lstStyle/>
+          <a:p>
+            <a:pPr indent="0" marL="0">
               <a:buNone/>
             </a:pPr>
             <a:r>
               <a:rPr lang="en-US" sz="1300" dirty="0">
                 <a:solidFill>
-                  <a:srgbClr val="383A42"/>
-                </a:solidFill>
-                <a:latin typeface="Consolas" pitchFamily="34" charset="0"/>
-                <a:ea typeface="Consolas" pitchFamily="34" charset="-122"/>
-                <a:cs typeface="Consolas" pitchFamily="34" charset="-120"/>
-              </a:rPr>
-              <a:t>    publisher yourdomain.dev</a:t>
+                  <a:schemeClr val="accent6"/>
+                </a:solidFill>
+              </a:rPr>
+              <a:t>Real searches you almost won, and the words you were missing</a:t>
             </a:r>
             <a:endParaRPr lang="en-US" sz="1300" dirty="0"/>
           </a:p>
@@ -19679,14 +19893,70 @@
       </p:sp>
       <p:sp>
         <p:nvSpPr>
-          <p:cNvPr id="10" name="Text 8"/>
+          <p:cNvPr id="28" name="SEO item 3"/>
+          <p:cNvSpPr/>
+          <p:nvPr/>
+        </p:nvSpPr>
+        <p:spPr>
+          <a:xfrm>
+            <a:off x="7269480" y="3703320"/>
+            <a:ext cx="457200" cy="457200"/>
+          </a:xfrm>
+          <a:prstGeom prst="ellipse">
+            <a:avLst/>
+          </a:prstGeom>
+          <a:solidFill>
+            <a:schemeClr val="accent5"/>
+          </a:solidFill>
+          <a:ln/>
+        </p:spPr>
+      </p:sp>
+      <p:sp>
+        <p:nvSpPr>
+          <p:cNvPr id="29" name="Text 23"/>
           <p:cNvSpPr txBox="1"/>
           <p:nvPr/>
         </p:nvSpPr>
         <p:spPr>
           <a:xfrm>
-            <a:off x="7498080" y="3767328"/>
-            <a:ext cx="4142232" cy="320040"/>
+            <a:off x="7269480" y="3703320"/>
+            <a:ext cx="457200" cy="457200"/>
+          </a:xfrm>
+          <a:prstGeom prst="rect">
+            <a:avLst/>
+          </a:prstGeom>
+          <a:noFill/>
+          <a:ln/>
+        </p:spPr>
+        <p:txBody>
+          <a:bodyPr wrap="square" lIns="0" tIns="0" rIns="0" bIns="0" rtlCol="0" anchor="ctr"/>
+          <a:lstStyle/>
+          <a:p>
+            <a:pPr algn="ctr" indent="0" marL="0">
+              <a:buNone/>
+            </a:pPr>
+            <a:r>
+              <a:rPr lang="en-US" sz="1400" b="1" dirty="0">
+                <a:solidFill>
+                  <a:schemeClr val="bg1"/>
+                </a:solidFill>
+              </a:rPr>
+              <a:t>3</a:t>
+            </a:r>
+            <a:endParaRPr lang="en-US" sz="1400" dirty="0"/>
+          </a:p>
+        </p:txBody>
+      </p:sp>
+      <p:sp>
+        <p:nvSpPr>
+          <p:cNvPr id="30" name="Text 24"/>
+          <p:cNvSpPr txBox="1"/>
+          <p:nvPr/>
+        </p:nvSpPr>
+        <p:spPr>
+          <a:xfrm>
+            <a:off x="7863840" y="3685032"/>
+            <a:ext cx="3749040" cy="310896"/>
           </a:xfrm>
           <a:prstGeom prst="rect">
             <a:avLst/>
@@ -19702,27 +19972,119 @@
               <a:buNone/>
             </a:pPr>
             <a:r>
-              <a:rPr lang="en-US" sz="1200" dirty="0">
+              <a:rPr lang="en-US" sz="1600" b="1" dirty="0">
+                <a:solidFill>
+                  <a:schemeClr val="tx1"/>
+                </a:solidFill>
+              </a:rPr>
+              <a:t>Why you rank there</a:t>
+            </a:r>
+            <a:endParaRPr lang="en-US" sz="1600" dirty="0"/>
+          </a:p>
+        </p:txBody>
+      </p:sp>
+      <p:sp>
+        <p:nvSpPr>
+          <p:cNvPr id="31" name="Text 25"/>
+          <p:cNvSpPr txBox="1"/>
+          <p:nvPr/>
+        </p:nvSpPr>
+        <p:spPr>
+          <a:xfrm>
+            <a:off x="7863840" y="3995928"/>
+            <a:ext cx="3749040" cy="530352"/>
+          </a:xfrm>
+          <a:prstGeom prst="rect">
+            <a:avLst/>
+          </a:prstGeom>
+          <a:noFill/>
+          <a:ln/>
+        </p:spPr>
+        <p:txBody>
+          <a:bodyPr wrap="square" lIns="0" tIns="0" rIns="0" bIns="0" rtlCol="0" anchor="t"/>
+          <a:lstStyle/>
+          <a:p>
+            <a:pPr indent="0" marL="0">
+              <a:buNone/>
+            </a:pPr>
+            <a:r>
+              <a:rPr lang="en-US" sz="1300" dirty="0">
                 <a:solidFill>
                   <a:schemeClr val="accent6"/>
                 </a:solidFill>
               </a:rPr>
-              <a:t>From the ard-spec repo’s conformance folder</a:t>
-            </a:r>
-            <a:endParaRPr lang="en-US" sz="1200" dirty="0"/>
-          </a:p>
-        </p:txBody>
-      </p:sp>
-      <p:sp>
-        <p:nvSpPr>
-          <p:cNvPr id="11" name="Text 9"/>
+              <a:t>Word by word, against the result just above you</a:t>
+            </a:r>
+            <a:endParaRPr lang="en-US" sz="1300" dirty="0"/>
+          </a:p>
+        </p:txBody>
+      </p:sp>
+      <p:sp>
+        <p:nvSpPr>
+          <p:cNvPr id="32" name="SEO item 4"/>
+          <p:cNvSpPr/>
+          <p:nvPr/>
+        </p:nvSpPr>
+        <p:spPr>
+          <a:xfrm>
+            <a:off x="7269480" y="4572000"/>
+            <a:ext cx="457200" cy="457200"/>
+          </a:xfrm>
+          <a:prstGeom prst="ellipse">
+            <a:avLst/>
+          </a:prstGeom>
+          <a:solidFill>
+            <a:schemeClr val="accent5"/>
+          </a:solidFill>
+          <a:ln/>
+        </p:spPr>
+      </p:sp>
+      <p:sp>
+        <p:nvSpPr>
+          <p:cNvPr id="33" name="Text 27"/>
           <p:cNvSpPr txBox="1"/>
           <p:nvPr/>
         </p:nvSpPr>
         <p:spPr>
           <a:xfrm>
-            <a:off x="7498080" y="4251960"/>
-            <a:ext cx="4114800" cy="365760"/>
+            <a:off x="7269480" y="4572000"/>
+            <a:ext cx="457200" cy="457200"/>
+          </a:xfrm>
+          <a:prstGeom prst="rect">
+            <a:avLst/>
+          </a:prstGeom>
+          <a:noFill/>
+          <a:ln/>
+        </p:spPr>
+        <p:txBody>
+          <a:bodyPr wrap="square" lIns="0" tIns="0" rIns="0" bIns="0" rtlCol="0" anchor="ctr"/>
+          <a:lstStyle/>
+          <a:p>
+            <a:pPr algn="ctr" indent="0" marL="0">
+              <a:buNone/>
+            </a:pPr>
+            <a:r>
+              <a:rPr lang="en-US" sz="1400" b="1" dirty="0">
+                <a:solidFill>
+                  <a:schemeClr val="bg1"/>
+                </a:solidFill>
+              </a:rPr>
+              <a:t>4</a:t>
+            </a:r>
+            <a:endParaRPr lang="en-US" sz="1400" dirty="0"/>
+          </a:p>
+        </p:txBody>
+      </p:sp>
+      <p:sp>
+        <p:nvSpPr>
+          <p:cNvPr id="34" name="Text 28"/>
+          <p:cNvSpPr txBox="1"/>
+          <p:nvPr/>
+        </p:nvSpPr>
+        <p:spPr>
+          <a:xfrm>
+            <a:off x="7863840" y="4553712"/>
+            <a:ext cx="3749040" cy="310896"/>
           </a:xfrm>
           <a:prstGeom prst="rect">
             <a:avLst/>
@@ -19738,31 +20100,67 @@
               <a:buNone/>
             </a:pPr>
             <a:r>
-              <a:rPr lang="en-US" sz="1700" b="1" dirty="0">
+              <a:rPr lang="en-US" sz="1600" b="1" dirty="0">
                 <a:solidFill>
                   <a:schemeClr val="tx1"/>
                 </a:solidFill>
               </a:rPr>
-              <a:t>3  Join in</a:t>
-            </a:r>
-            <a:endParaRPr lang="en-US" sz="1700" dirty="0"/>
-          </a:p>
-        </p:txBody>
-      </p:sp>
-      <p:sp>
-        <p:nvSpPr>
-          <p:cNvPr id="12" name="Join card"/>
+              <a:t>Try before publishing</a:t>
+            </a:r>
+            <a:endParaRPr lang="en-US" sz="1600" dirty="0"/>
+          </a:p>
+        </p:txBody>
+      </p:sp>
+      <p:sp>
+        <p:nvSpPr>
+          <p:cNvPr id="35" name="Text 29"/>
+          <p:cNvSpPr txBox="1"/>
+          <p:nvPr/>
+        </p:nvSpPr>
+        <p:spPr>
+          <a:xfrm>
+            <a:off x="7863840" y="4864608"/>
+            <a:ext cx="3749040" cy="530352"/>
+          </a:xfrm>
+          <a:prstGeom prst="rect">
+            <a:avLst/>
+          </a:prstGeom>
+          <a:noFill/>
+          <a:ln/>
+        </p:spPr>
+        <p:txBody>
+          <a:bodyPr wrap="square" lIns="0" tIns="0" rIns="0" bIns="0" rtlCol="0" anchor="t"/>
+          <a:lstStyle/>
+          <a:p>
+            <a:pPr indent="0" marL="0">
+              <a:buNone/>
+            </a:pPr>
+            <a:r>
+              <a:rPr lang="en-US" sz="1300" dirty="0">
+                <a:solidFill>
+                  <a:schemeClr val="accent6"/>
+                </a:solidFill>
+              </a:rPr>
+              <a:t>Test a query against the live index first</a:t>
+            </a:r>
+            <a:endParaRPr lang="en-US" sz="1300" dirty="0"/>
+          </a:p>
+        </p:txBody>
+      </p:sp>
+      <p:sp>
+        <p:nvSpPr>
+          <p:cNvPr id="36" name="Fairness note"/>
           <p:cNvSpPr/>
           <p:nvPr/>
         </p:nvSpPr>
         <p:spPr>
           <a:xfrm>
-            <a:off x="7498080" y="4709160"/>
-            <a:ext cx="4142232" cy="1371600"/>
+            <a:off x="548640" y="5596128"/>
+            <a:ext cx="11091672" cy="512064"/>
           </a:xfrm>
           <a:prstGeom prst="roundRect">
             <a:avLst>
-              <a:gd name="adj" fmla="val 9333"/>
+              <a:gd name="adj" fmla="val 25000"/>
             </a:avLst>
           </a:prstGeom>
           <a:solidFill>
@@ -19771,43 +20169,50 @@
           <a:ln/>
         </p:spPr>
       </p:sp>
-      <p:sp>
-        <p:nvSpPr>
-          <p:cNvPr id="13" name="Text 11"/>
+      <p:pic>
+        <p:nvPicPr>
+          <p:cNvPr id="37" name="Fairness icon" descr="preencoded.png">    </p:cNvPr>
+          <p:cNvPicPr>
+            <a:picLocks noChangeAspect="1"/>
+          </p:cNvPicPr>
+          <p:nvPr/>
+        </p:nvPicPr>
+        <p:blipFill>
+          <a:blip r:embed="rId5"/>
+          <a:stretch>
+            <a:fillRect/>
+          </a:stretch>
+        </p:blipFill>
+        <p:spPr>
+          <a:xfrm>
+            <a:off x="749808" y="5705856"/>
+            <a:ext cx="292608" cy="292608"/>
+          </a:xfrm>
+          <a:prstGeom prst="rect">
+            <a:avLst/>
+          </a:prstGeom>
+        </p:spPr>
+      </p:pic>
+      <p:sp>
+        <p:nvSpPr>
+          <p:cNvPr id="38" name="Text 31"/>
           <p:cNvSpPr txBox="1"/>
           <p:nvPr/>
         </p:nvSpPr>
         <p:spPr>
           <a:xfrm>
-            <a:off x="7726680" y="4800600"/>
-            <a:ext cx="3794760" cy="1188720"/>
-          </a:xfrm>
-          <a:prstGeom prst="rect">
-            <a:avLst/>
-          </a:prstGeom>
-          <a:noFill/>
-          <a:ln/>
-        </p:spPr>
-        <p:txBody>
-          <a:bodyPr wrap="square" lIns="0" tIns="0" rIns="0" bIns="0" rtlCol="0" anchor="t"/>
-          <a:lstStyle/>
-          <a:p>
-            <a:pPr indent="0" marL="0">
-              <a:buNone/>
-            </a:pPr>
-            <a:r>
-              <a:rPr lang="en-US" sz="1400" b="1" dirty="0">
-                <a:solidFill>
-                  <a:schemeClr val="accent2"/>
-                </a:solidFill>
-                <a:latin typeface="Consolas" pitchFamily="34" charset="0"/>
-                <a:ea typeface="Consolas" pitchFamily="34" charset="-122"/>
-                <a:cs typeface="Consolas" pitchFamily="34" charset="-120"/>
-              </a:rPr>
-              <a:t>github.com/ards-project/ard-spec</a:t>
-            </a:r>
-            <a:endParaRPr lang="en-US" sz="1400" dirty="0"/>
-          </a:p>
+            <a:off x="1188720" y="5596128"/>
+            <a:ext cx="10332720" cy="512064"/>
+          </a:xfrm>
+          <a:prstGeom prst="rect">
+            <a:avLst/>
+          </a:prstGeom>
+          <a:noFill/>
+          <a:ln/>
+        </p:spPr>
+        <p:txBody>
+          <a:bodyPr wrap="square" lIns="0" tIns="0" rIns="0" bIns="0" rtlCol="0" anchor="ctr"/>
+          <a:lstStyle/>
           <a:p>
             <a:pPr indent="0" marL="0">
               <a:buNone/>
@@ -19815,10 +20220,10 @@
             <a:r>
               <a:rPr lang="en-US" sz="1400" dirty="0">
                 <a:solidFill>
-                  <a:schemeClr val="tx2"/>
-                </a:solidFill>
-              </a:rPr>
-              <a:t>Issues for spec changes. PRs welcome for examples, tooling and implementations.</a:t>
+                  <a:schemeClr val="tx1"/>
+                </a:solidFill>
+              </a:rPr>
+              <a:t>Same formula for everyone: scores stay relevance-only, and keyword stuffing doesn’t help.</a:t>
             </a:r>
             <a:endParaRPr lang="en-US" sz="1400" dirty="0"/>
           </a:p>
@@ -19896,45 +20301,79 @@
       </p:grpSpPr>
       <p:sp>
         <p:nvSpPr>
-          <p:cNvPr id="2" name="Lilac accent circle"/>
+          <p:cNvPr id="2" name="Text 0"/>
           <p:cNvSpPr/>
-          <p:nvPr/>
-        </p:nvSpPr>
-        <p:spPr>
-          <a:xfrm>
-            <a:off x="8778240" y="3291840"/>
-            <a:ext cx="4206240" cy="4206240"/>
-          </a:xfrm>
-          <a:prstGeom prst="ellipse">
-            <a:avLst/>
-          </a:prstGeom>
-          <a:solidFill>
-            <a:schemeClr val="accent3">
-              <a:alpha val="55000"/>
-            </a:schemeClr>
-          </a:solidFill>
-          <a:ln/>
-        </p:spPr>
-      </p:sp>
-      <p:sp>
-        <p:nvSpPr>
-          <p:cNvPr id="3" name="Coral accent dot"/>
+          <p:nvPr>
+            <p:ph idx="100" type="body" hasCustomPrompt="1"/>
+          </p:nvPr>
+        </p:nvSpPr>
+        <p:spPr>
+          <a:xfrm>
+            <a:off x="548640" y="384048"/>
+            <a:ext cx="8229600" cy="274320"/>
+          </a:xfrm>
+          <a:prstGeom prst="rect">
+            <a:avLst/>
+          </a:prstGeom>
+          <a:noFill/>
+          <a:ln/>
+        </p:spPr>
+        <p:txBody>
+          <a:bodyPr wrap="square" lIns="0" tIns="0" rIns="0" bIns="0" rtlCol="0" anchor="t"/>
+          <a:lstStyle/>
+          <a:p>
+            <a:pPr indent="0" marL="0">
+              <a:buNone/>
+            </a:pPr>
+            <a:r>
+              <a:rPr lang="en-US" sz="1200" b="1" spc="200" kern="0" dirty="0">
+                <a:solidFill>
+                  <a:schemeClr val="accent2"/>
+                </a:solidFill>
+              </a:rPr>
+              <a:t>05  ·  TRY IT YOURSELF</a:t>
+            </a:r>
+            <a:endParaRPr lang="en-US" sz="1200" dirty="0"/>
+          </a:p>
+        </p:txBody>
+      </p:sp>
+      <p:sp>
+        <p:nvSpPr>
+          <p:cNvPr id="3" name="Text 0"/>
           <p:cNvSpPr/>
-          <p:nvPr/>
-        </p:nvSpPr>
-        <p:spPr>
-          <a:xfrm>
-            <a:off x="10058400" y="640080"/>
-            <a:ext cx="1280160" cy="1280160"/>
-          </a:xfrm>
-          <a:prstGeom prst="ellipse">
-            <a:avLst/>
-          </a:prstGeom>
-          <a:solidFill>
-            <a:schemeClr val="accent1"/>
-          </a:solidFill>
-          <a:ln/>
-        </p:spPr>
+          <p:nvPr>
+            <p:ph idx="101" type="title" hasCustomPrompt="1"/>
+          </p:nvPr>
+        </p:nvSpPr>
+        <p:spPr>
+          <a:xfrm>
+            <a:off x="548640" y="694944"/>
+            <a:ext cx="11091672" cy="1097280"/>
+          </a:xfrm>
+          <a:prstGeom prst="rect">
+            <a:avLst/>
+          </a:prstGeom>
+          <a:noFill/>
+          <a:ln/>
+        </p:spPr>
+        <p:txBody>
+          <a:bodyPr wrap="square" lIns="0" tIns="0" rIns="0" bIns="0" rtlCol="0" anchor="t"/>
+          <a:lstStyle/>
+          <a:p>
+            <a:pPr algn="l" indent="0" marL="0">
+              <a:buNone/>
+            </a:pPr>
+            <a:r>
+              <a:rPr lang="en-US" sz="3200" b="1" dirty="0">
+                <a:solidFill>
+                  <a:schemeClr val="tx1"/>
+                </a:solidFill>
+              </a:rPr>
+              <a:t>Publish an ARD entry for your own project this week</a:t>
+            </a:r>
+            <a:endParaRPr lang="en-US" sz="3200" dirty="0"/>
+          </a:p>
+        </p:txBody>
       </p:sp>
       <p:sp>
         <p:nvSpPr>
@@ -19944,44 +20383,66 @@
         </p:nvSpPr>
         <p:spPr>
           <a:xfrm>
-            <a:off x="822960" y="2331720"/>
-            <a:ext cx="7772400" cy="1097280"/>
-          </a:xfrm>
-          <a:prstGeom prst="rect">
-            <a:avLst/>
-          </a:prstGeom>
-          <a:noFill/>
-          <a:ln/>
-        </p:spPr>
-        <p:txBody>
-          <a:bodyPr wrap="square" lIns="0" tIns="0" rIns="0" bIns="0" rtlCol="0" anchor="ctr"/>
-          <a:lstStyle/>
-          <a:p>
-            <a:pPr indent="0" marL="0">
-              <a:buNone/>
-            </a:pPr>
-            <a:r>
-              <a:rPr lang="en-US" sz="6000" b="1" dirty="0">
+            <a:off x="548640" y="1965960"/>
+            <a:ext cx="6583680" cy="365760"/>
+          </a:xfrm>
+          <a:prstGeom prst="rect">
+            <a:avLst/>
+          </a:prstGeom>
+          <a:noFill/>
+          <a:ln/>
+        </p:spPr>
+        <p:txBody>
+          <a:bodyPr wrap="square" lIns="0" tIns="0" rIns="0" bIns="0" rtlCol="0" anchor="t"/>
+          <a:lstStyle/>
+          <a:p>
+            <a:pPr indent="0" marL="0">
+              <a:buNone/>
+            </a:pPr>
+            <a:r>
+              <a:rPr lang="en-US" sz="1700" b="1" dirty="0">
                 <a:solidFill>
                   <a:schemeClr val="tx1"/>
                 </a:solidFill>
               </a:rPr>
-              <a:t>Thank you!</a:t>
-            </a:r>
-            <a:endParaRPr lang="en-US" sz="6000" dirty="0"/>
-          </a:p>
-        </p:txBody>
-      </p:sp>
-      <p:sp>
-        <p:nvSpPr>
-          <p:cNvPr id="5" name="Text 3"/>
+              <a:t>1  Publish  /.well-known/ard.json</a:t>
+            </a:r>
+            <a:endParaRPr lang="en-US" sz="1700" dirty="0"/>
+          </a:p>
+        </p:txBody>
+      </p:sp>
+      <p:sp>
+        <p:nvSpPr>
+          <p:cNvPr id="5" name="ard.json example"/>
+          <p:cNvSpPr/>
+          <p:nvPr/>
+        </p:nvSpPr>
+        <p:spPr>
+          <a:xfrm>
+            <a:off x="548640" y="2423160"/>
+            <a:ext cx="6583680" cy="3657600"/>
+          </a:xfrm>
+          <a:prstGeom prst="roundRect">
+            <a:avLst>
+              <a:gd name="adj" fmla="val 3500"/>
+            </a:avLst>
+          </a:prstGeom>
+          <a:solidFill>
+            <a:schemeClr val="bg2"/>
+          </a:solidFill>
+          <a:ln/>
+        </p:spPr>
+      </p:sp>
+      <p:sp>
+        <p:nvSpPr>
+          <p:cNvPr id="6" name="Text 4"/>
           <p:cNvSpPr txBox="1"/>
           <p:nvPr/>
         </p:nvSpPr>
         <p:spPr>
           <a:xfrm>
-            <a:off x="822960" y="3703320"/>
-            <a:ext cx="7772400" cy="1097280"/>
+            <a:off x="822960" y="2651760"/>
+            <a:ext cx="6126480" cy="3291840"/>
           </a:xfrm>
           <a:prstGeom prst="rect">
             <a:avLst/>
@@ -19994,66 +20455,543 @@
           <a:lstStyle/>
           <a:p>
             <a:pPr indent="0" marL="0">
-              <a:buNone/>
-            </a:pPr>
-            <a:r>
-              <a:rPr lang="en-US" sz="1800" b="1" dirty="0">
-                <a:solidFill>
-                  <a:schemeClr val="tx1"/>
-                </a:solidFill>
-              </a:rPr>
-              <a:t>Shaan Narendran  ·  github.com/ShaanNarendran</a:t>
-            </a:r>
-            <a:endParaRPr lang="en-US" sz="1800" dirty="0"/>
-          </a:p>
-          <a:p>
-            <a:pPr indent="0" marL="0">
-              <a:buNone/>
-            </a:pPr>
-            <a:r>
-              <a:rPr lang="en-US" sz="1800" dirty="0">
-                <a:solidFill>
-                  <a:schemeClr val="tx2"/>
+              <a:lnSpc>
+                <a:spcPct val="130000"/>
+              </a:lnSpc>
+              <a:buNone/>
+            </a:pPr>
+            <a:r>
+              <a:rPr lang="en-US" sz="1250" dirty="0">
+                <a:solidFill>
+                  <a:srgbClr val="383A42"/>
                 </a:solidFill>
                 <a:latin typeface="Consolas" pitchFamily="34" charset="0"/>
                 <a:ea typeface="Consolas" pitchFamily="34" charset="-122"/>
                 <a:cs typeface="Consolas" pitchFamily="34" charset="-120"/>
               </a:rPr>
-              <a:t>agenticresourcediscovery.org/spec</a:t>
-            </a:r>
-            <a:endParaRPr lang="en-US" sz="1800" dirty="0"/>
-          </a:p>
-          <a:p>
-            <a:pPr indent="0" marL="0">
-              <a:buNone/>
-            </a:pPr>
-            <a:r>
-              <a:rPr lang="en-US" sz="1800" dirty="0">
-                <a:solidFill>
-                  <a:schemeClr val="tx2"/>
+              <a:t>{ </a:t>
+            </a:r>
+            <a:pPr indent="0" marL="0">
+              <a:lnSpc>
+                <a:spcPct val="130000"/>
+              </a:lnSpc>
+              <a:buNone/>
+            </a:pPr>
+            <a:r>
+              <a:rPr lang="en-US" sz="1250" dirty="0">
+                <a:solidFill>
+                  <a:srgbClr val="5A4FA0"/>
                 </a:solidFill>
                 <a:latin typeface="Consolas" pitchFamily="34" charset="0"/>
                 <a:ea typeface="Consolas" pitchFamily="34" charset="-122"/>
                 <a:cs typeface="Consolas" pitchFamily="34" charset="-120"/>
               </a:rPr>
-              <a:t>github.com/Observal/Observal</a:t>
-            </a:r>
-            <a:endParaRPr lang="en-US" sz="1800" dirty="0"/>
-          </a:p>
-        </p:txBody>
-      </p:sp>
-      <p:sp>
-        <p:nvSpPr>
-          <p:cNvPr id="7" name="Text 0"/>
+              <a:t>"entries"</a:t>
+            </a:r>
+            <a:pPr indent="0" marL="0">
+              <a:lnSpc>
+                <a:spcPct val="130000"/>
+              </a:lnSpc>
+              <a:buNone/>
+            </a:pPr>
+            <a:r>
+              <a:rPr lang="en-US" sz="1250" dirty="0">
+                <a:solidFill>
+                  <a:srgbClr val="383A42"/>
+                </a:solidFill>
+                <a:latin typeface="Consolas" pitchFamily="34" charset="0"/>
+                <a:ea typeface="Consolas" pitchFamily="34" charset="-122"/>
+                <a:cs typeface="Consolas" pitchFamily="34" charset="-120"/>
+              </a:rPr>
+              <a:t>: [{</a:t>
+            </a:r>
+            <a:endParaRPr lang="en-US" sz="1250" dirty="0"/>
+          </a:p>
+          <a:p>
+            <a:pPr indent="0" marL="0">
+              <a:lnSpc>
+                <a:spcPct val="130000"/>
+              </a:lnSpc>
+              <a:buNone/>
+            </a:pPr>
+            <a:r>
+              <a:rPr lang="en-US" sz="1250" b="1" dirty="0">
+                <a:solidFill>
+                  <a:srgbClr val="C2410C"/>
+                </a:solidFill>
+                <a:latin typeface="Consolas" pitchFamily="34" charset="0"/>
+                <a:ea typeface="Consolas" pitchFamily="34" charset="-122"/>
+                <a:cs typeface="Consolas" pitchFamily="34" charset="-120"/>
+              </a:rPr>
+              <a:t>    "identifier"</a:t>
+            </a:r>
+            <a:pPr indent="0" marL="0">
+              <a:lnSpc>
+                <a:spcPct val="130000"/>
+              </a:lnSpc>
+              <a:buNone/>
+            </a:pPr>
+            <a:r>
+              <a:rPr lang="en-US" sz="1250" dirty="0">
+                <a:solidFill>
+                  <a:srgbClr val="383A42"/>
+                </a:solidFill>
+                <a:latin typeface="Consolas" pitchFamily="34" charset="0"/>
+                <a:ea typeface="Consolas" pitchFamily="34" charset="-122"/>
+                <a:cs typeface="Consolas" pitchFamily="34" charset="-120"/>
+              </a:rPr>
+              <a:t>: </a:t>
+            </a:r>
+            <a:pPr indent="0" marL="0">
+              <a:lnSpc>
+                <a:spcPct val="130000"/>
+              </a:lnSpc>
+              <a:buNone/>
+            </a:pPr>
+            <a:r>
+              <a:rPr lang="en-US" sz="1250" dirty="0">
+                <a:solidFill>
+                  <a:srgbClr val="2D6E3A"/>
+                </a:solidFill>
+                <a:latin typeface="Consolas" pitchFamily="34" charset="0"/>
+                <a:ea typeface="Consolas" pitchFamily="34" charset="-122"/>
+                <a:cs typeface="Consolas" pitchFamily="34" charset="-120"/>
+              </a:rPr>
+              <a:t>"urn:air:yourdomain.dev:mcp:weather"</a:t>
+            </a:r>
+            <a:pPr indent="0" marL="0">
+              <a:lnSpc>
+                <a:spcPct val="130000"/>
+              </a:lnSpc>
+              <a:buNone/>
+            </a:pPr>
+            <a:r>
+              <a:rPr lang="en-US" sz="1250" dirty="0">
+                <a:solidFill>
+                  <a:srgbClr val="383A42"/>
+                </a:solidFill>
+                <a:latin typeface="Consolas" pitchFamily="34" charset="0"/>
+                <a:ea typeface="Consolas" pitchFamily="34" charset="-122"/>
+                <a:cs typeface="Consolas" pitchFamily="34" charset="-120"/>
+              </a:rPr>
+              <a:t>,</a:t>
+            </a:r>
+            <a:endParaRPr lang="en-US" sz="1250" dirty="0"/>
+          </a:p>
+          <a:p>
+            <a:pPr indent="0" marL="0">
+              <a:lnSpc>
+                <a:spcPct val="130000"/>
+              </a:lnSpc>
+              <a:buNone/>
+            </a:pPr>
+            <a:r>
+              <a:rPr lang="en-US" sz="1250" b="1" dirty="0">
+                <a:solidFill>
+                  <a:srgbClr val="C2410C"/>
+                </a:solidFill>
+                <a:latin typeface="Consolas" pitchFamily="34" charset="0"/>
+                <a:ea typeface="Consolas" pitchFamily="34" charset="-122"/>
+                <a:cs typeface="Consolas" pitchFamily="34" charset="-120"/>
+              </a:rPr>
+              <a:t>    "displayName"</a:t>
+            </a:r>
+            <a:pPr indent="0" marL="0">
+              <a:lnSpc>
+                <a:spcPct val="130000"/>
+              </a:lnSpc>
+              <a:buNone/>
+            </a:pPr>
+            <a:r>
+              <a:rPr lang="en-US" sz="1250" dirty="0">
+                <a:solidFill>
+                  <a:srgbClr val="383A42"/>
+                </a:solidFill>
+                <a:latin typeface="Consolas" pitchFamily="34" charset="0"/>
+                <a:ea typeface="Consolas" pitchFamily="34" charset="-122"/>
+                <a:cs typeface="Consolas" pitchFamily="34" charset="-120"/>
+              </a:rPr>
+              <a:t>: </a:t>
+            </a:r>
+            <a:pPr indent="0" marL="0">
+              <a:lnSpc>
+                <a:spcPct val="130000"/>
+              </a:lnSpc>
+              <a:buNone/>
+            </a:pPr>
+            <a:r>
+              <a:rPr lang="en-US" sz="1250" dirty="0">
+                <a:solidFill>
+                  <a:srgbClr val="2D6E3A"/>
+                </a:solidFill>
+                <a:latin typeface="Consolas" pitchFamily="34" charset="0"/>
+                <a:ea typeface="Consolas" pitchFamily="34" charset="-122"/>
+                <a:cs typeface="Consolas" pitchFamily="34" charset="-120"/>
+              </a:rPr>
+              <a:t>"Chennai Weather"</a:t>
+            </a:r>
+            <a:pPr indent="0" marL="0">
+              <a:lnSpc>
+                <a:spcPct val="130000"/>
+              </a:lnSpc>
+              <a:buNone/>
+            </a:pPr>
+            <a:r>
+              <a:rPr lang="en-US" sz="1250" dirty="0">
+                <a:solidFill>
+                  <a:srgbClr val="383A42"/>
+                </a:solidFill>
+                <a:latin typeface="Consolas" pitchFamily="34" charset="0"/>
+                <a:ea typeface="Consolas" pitchFamily="34" charset="-122"/>
+                <a:cs typeface="Consolas" pitchFamily="34" charset="-120"/>
+              </a:rPr>
+              <a:t>,</a:t>
+            </a:r>
+            <a:endParaRPr lang="en-US" sz="1250" dirty="0"/>
+          </a:p>
+          <a:p>
+            <a:pPr indent="0" marL="0">
+              <a:lnSpc>
+                <a:spcPct val="130000"/>
+              </a:lnSpc>
+              <a:buNone/>
+            </a:pPr>
+            <a:r>
+              <a:rPr lang="en-US" sz="1250" b="1" dirty="0">
+                <a:solidFill>
+                  <a:srgbClr val="C2410C"/>
+                </a:solidFill>
+                <a:latin typeface="Consolas" pitchFamily="34" charset="0"/>
+                <a:ea typeface="Consolas" pitchFamily="34" charset="-122"/>
+                <a:cs typeface="Consolas" pitchFamily="34" charset="-120"/>
+              </a:rPr>
+              <a:t>    "type"</a:t>
+            </a:r>
+            <a:pPr indent="0" marL="0">
+              <a:lnSpc>
+                <a:spcPct val="130000"/>
+              </a:lnSpc>
+              <a:buNone/>
+            </a:pPr>
+            <a:r>
+              <a:rPr lang="en-US" sz="1250" dirty="0">
+                <a:solidFill>
+                  <a:srgbClr val="383A42"/>
+                </a:solidFill>
+                <a:latin typeface="Consolas" pitchFamily="34" charset="0"/>
+                <a:ea typeface="Consolas" pitchFamily="34" charset="-122"/>
+                <a:cs typeface="Consolas" pitchFamily="34" charset="-120"/>
+              </a:rPr>
+              <a:t>: </a:t>
+            </a:r>
+            <a:pPr indent="0" marL="0">
+              <a:lnSpc>
+                <a:spcPct val="130000"/>
+              </a:lnSpc>
+              <a:buNone/>
+            </a:pPr>
+            <a:r>
+              <a:rPr lang="en-US" sz="1250" dirty="0">
+                <a:solidFill>
+                  <a:srgbClr val="2D6E3A"/>
+                </a:solidFill>
+                <a:latin typeface="Consolas" pitchFamily="34" charset="0"/>
+                <a:ea typeface="Consolas" pitchFamily="34" charset="-122"/>
+                <a:cs typeface="Consolas" pitchFamily="34" charset="-120"/>
+              </a:rPr>
+              <a:t>"application/mcp-server-card+json"</a:t>
+            </a:r>
+            <a:pPr indent="0" marL="0">
+              <a:lnSpc>
+                <a:spcPct val="130000"/>
+              </a:lnSpc>
+              <a:buNone/>
+            </a:pPr>
+            <a:r>
+              <a:rPr lang="en-US" sz="1250" dirty="0">
+                <a:solidFill>
+                  <a:srgbClr val="383A42"/>
+                </a:solidFill>
+                <a:latin typeface="Consolas" pitchFamily="34" charset="0"/>
+                <a:ea typeface="Consolas" pitchFamily="34" charset="-122"/>
+                <a:cs typeface="Consolas" pitchFamily="34" charset="-120"/>
+              </a:rPr>
+              <a:t>,</a:t>
+            </a:r>
+            <a:endParaRPr lang="en-US" sz="1250" dirty="0"/>
+          </a:p>
+          <a:p>
+            <a:pPr indent="0" marL="0">
+              <a:lnSpc>
+                <a:spcPct val="130000"/>
+              </a:lnSpc>
+              <a:buNone/>
+            </a:pPr>
+            <a:r>
+              <a:rPr lang="en-US" sz="1250" b="1" dirty="0">
+                <a:solidFill>
+                  <a:srgbClr val="C2410C"/>
+                </a:solidFill>
+                <a:latin typeface="Consolas" pitchFamily="34" charset="0"/>
+                <a:ea typeface="Consolas" pitchFamily="34" charset="-122"/>
+                <a:cs typeface="Consolas" pitchFamily="34" charset="-120"/>
+              </a:rPr>
+              <a:t>    "url"</a:t>
+            </a:r>
+            <a:pPr indent="0" marL="0">
+              <a:lnSpc>
+                <a:spcPct val="130000"/>
+              </a:lnSpc>
+              <a:buNone/>
+            </a:pPr>
+            <a:r>
+              <a:rPr lang="en-US" sz="1250" dirty="0">
+                <a:solidFill>
+                  <a:srgbClr val="383A42"/>
+                </a:solidFill>
+                <a:latin typeface="Consolas" pitchFamily="34" charset="0"/>
+                <a:ea typeface="Consolas" pitchFamily="34" charset="-122"/>
+                <a:cs typeface="Consolas" pitchFamily="34" charset="-120"/>
+              </a:rPr>
+              <a:t>: </a:t>
+            </a:r>
+            <a:pPr indent="0" marL="0">
+              <a:lnSpc>
+                <a:spcPct val="130000"/>
+              </a:lnSpc>
+              <a:buNone/>
+            </a:pPr>
+            <a:r>
+              <a:rPr lang="en-US" sz="1250" dirty="0">
+                <a:solidFill>
+                  <a:srgbClr val="2D6E3A"/>
+                </a:solidFill>
+                <a:latin typeface="Consolas" pitchFamily="34" charset="0"/>
+                <a:ea typeface="Consolas" pitchFamily="34" charset="-122"/>
+                <a:cs typeface="Consolas" pitchFamily="34" charset="-120"/>
+              </a:rPr>
+              <a:t>"https://yourdomain.dev/mcp/weather.json"</a:t>
+            </a:r>
+            <a:pPr indent="0" marL="0">
+              <a:lnSpc>
+                <a:spcPct val="130000"/>
+              </a:lnSpc>
+              <a:buNone/>
+            </a:pPr>
+            <a:r>
+              <a:rPr lang="en-US" sz="1250" dirty="0">
+                <a:solidFill>
+                  <a:srgbClr val="383A42"/>
+                </a:solidFill>
+                <a:latin typeface="Consolas" pitchFamily="34" charset="0"/>
+                <a:ea typeface="Consolas" pitchFamily="34" charset="-122"/>
+                <a:cs typeface="Consolas" pitchFamily="34" charset="-120"/>
+              </a:rPr>
+              <a:t>,</a:t>
+            </a:r>
+            <a:endParaRPr lang="en-US" sz="1250" dirty="0"/>
+          </a:p>
+          <a:p>
+            <a:pPr indent="0" marL="0">
+              <a:lnSpc>
+                <a:spcPct val="130000"/>
+              </a:lnSpc>
+              <a:buNone/>
+            </a:pPr>
+            <a:r>
+              <a:rPr lang="en-US" sz="1250" b="1" dirty="0">
+                <a:solidFill>
+                  <a:srgbClr val="5A4FA0"/>
+                </a:solidFill>
+                <a:latin typeface="Consolas" pitchFamily="34" charset="0"/>
+                <a:ea typeface="Consolas" pitchFamily="34" charset="-122"/>
+                <a:cs typeface="Consolas" pitchFamily="34" charset="-120"/>
+              </a:rPr>
+              <a:t>    "representativeQueries"</a:t>
+            </a:r>
+            <a:pPr indent="0" marL="0">
+              <a:lnSpc>
+                <a:spcPct val="130000"/>
+              </a:lnSpc>
+              <a:buNone/>
+            </a:pPr>
+            <a:r>
+              <a:rPr lang="en-US" sz="1250" dirty="0">
+                <a:solidFill>
+                  <a:srgbClr val="383A42"/>
+                </a:solidFill>
+                <a:latin typeface="Consolas" pitchFamily="34" charset="0"/>
+                <a:ea typeface="Consolas" pitchFamily="34" charset="-122"/>
+                <a:cs typeface="Consolas" pitchFamily="34" charset="-120"/>
+              </a:rPr>
+              <a:t>: [</a:t>
+            </a:r>
+            <a:endParaRPr lang="en-US" sz="1250" dirty="0"/>
+          </a:p>
+          <a:p>
+            <a:pPr indent="0" marL="0">
+              <a:lnSpc>
+                <a:spcPct val="130000"/>
+              </a:lnSpc>
+              <a:buNone/>
+            </a:pPr>
+            <a:r>
+              <a:rPr lang="en-US" sz="1250" dirty="0">
+                <a:solidFill>
+                  <a:srgbClr val="2D6E3A"/>
+                </a:solidFill>
+                <a:latin typeface="Consolas" pitchFamily="34" charset="0"/>
+                <a:ea typeface="Consolas" pitchFamily="34" charset="-122"/>
+                <a:cs typeface="Consolas" pitchFamily="34" charset="-120"/>
+              </a:rPr>
+              <a:t>      "will it rain in Chennai tomorrow"</a:t>
+            </a:r>
+            <a:pPr indent="0" marL="0">
+              <a:lnSpc>
+                <a:spcPct val="130000"/>
+              </a:lnSpc>
+              <a:buNone/>
+            </a:pPr>
+            <a:r>
+              <a:rPr lang="en-US" sz="1250" dirty="0">
+                <a:solidFill>
+                  <a:srgbClr val="383A42"/>
+                </a:solidFill>
+                <a:latin typeface="Consolas" pitchFamily="34" charset="0"/>
+                <a:ea typeface="Consolas" pitchFamily="34" charset="-122"/>
+                <a:cs typeface="Consolas" pitchFamily="34" charset="-120"/>
+              </a:rPr>
+              <a:t>,</a:t>
+            </a:r>
+            <a:endParaRPr lang="en-US" sz="1250" dirty="0"/>
+          </a:p>
+          <a:p>
+            <a:pPr indent="0" marL="0">
+              <a:lnSpc>
+                <a:spcPct val="130000"/>
+              </a:lnSpc>
+              <a:buNone/>
+            </a:pPr>
+            <a:r>
+              <a:rPr lang="en-US" sz="1250" dirty="0">
+                <a:solidFill>
+                  <a:srgbClr val="2D6E3A"/>
+                </a:solidFill>
+                <a:latin typeface="Consolas" pitchFamily="34" charset="0"/>
+                <a:ea typeface="Consolas" pitchFamily="34" charset="-122"/>
+                <a:cs typeface="Consolas" pitchFamily="34" charset="-120"/>
+              </a:rPr>
+              <a:t>      "current humidity in Chennai"</a:t>
+            </a:r>
+            <a:pPr indent="0" marL="0">
+              <a:lnSpc>
+                <a:spcPct val="130000"/>
+              </a:lnSpc>
+              <a:buNone/>
+            </a:pPr>
+            <a:r>
+              <a:rPr lang="en-US" sz="1250" dirty="0">
+                <a:solidFill>
+                  <a:srgbClr val="383A42"/>
+                </a:solidFill>
+                <a:latin typeface="Consolas" pitchFamily="34" charset="0"/>
+                <a:ea typeface="Consolas" pitchFamily="34" charset="-122"/>
+                <a:cs typeface="Consolas" pitchFamily="34" charset="-120"/>
+              </a:rPr>
+              <a:t>]</a:t>
+            </a:r>
+            <a:endParaRPr lang="en-US" sz="1250" dirty="0"/>
+          </a:p>
+          <a:p>
+            <a:pPr indent="0" marL="0">
+              <a:lnSpc>
+                <a:spcPct val="130000"/>
+              </a:lnSpc>
+              <a:buNone/>
+            </a:pPr>
+            <a:r>
+              <a:rPr lang="en-US" sz="1250" dirty="0">
+                <a:solidFill>
+                  <a:srgbClr val="383A42"/>
+                </a:solidFill>
+                <a:latin typeface="Consolas" pitchFamily="34" charset="0"/>
+                <a:ea typeface="Consolas" pitchFamily="34" charset="-122"/>
+                <a:cs typeface="Consolas" pitchFamily="34" charset="-120"/>
+              </a:rPr>
+              <a:t>}] }</a:t>
+            </a:r>
+            <a:endParaRPr lang="en-US" sz="1250" dirty="0"/>
+          </a:p>
+        </p:txBody>
+      </p:sp>
+      <p:sp>
+        <p:nvSpPr>
+          <p:cNvPr id="7" name="Text 5"/>
+          <p:cNvSpPr txBox="1"/>
+          <p:nvPr/>
+        </p:nvSpPr>
+        <p:spPr>
+          <a:xfrm>
+            <a:off x="7498080" y="1965960"/>
+            <a:ext cx="4114800" cy="365760"/>
+          </a:xfrm>
+          <a:prstGeom prst="rect">
+            <a:avLst/>
+          </a:prstGeom>
+          <a:noFill/>
+          <a:ln/>
+        </p:spPr>
+        <p:txBody>
+          <a:bodyPr wrap="square" lIns="0" tIns="0" rIns="0" bIns="0" rtlCol="0" anchor="t"/>
+          <a:lstStyle/>
+          <a:p>
+            <a:pPr indent="0" marL="0">
+              <a:buNone/>
+            </a:pPr>
+            <a:r>
+              <a:rPr lang="en-US" sz="1700" b="1" dirty="0">
+                <a:solidFill>
+                  <a:schemeClr val="tx1"/>
+                </a:solidFill>
+              </a:rPr>
+              <a:t>2  Validate it</a:t>
+            </a:r>
+            <a:endParaRPr lang="en-US" sz="1700" dirty="0"/>
+          </a:p>
+        </p:txBody>
+      </p:sp>
+      <p:sp>
+        <p:nvSpPr>
+          <p:cNvPr id="8" name="Validate command"/>
           <p:cNvSpPr/>
-          <p:nvPr>
-            <p:ph idx="100" type="title" hasCustomPrompt="1"/>
-          </p:nvPr>
-        </p:nvSpPr>
-        <p:spPr>
-          <a:xfrm>
-            <a:off x="822960" y="1828800"/>
-            <a:ext cx="10607040" cy="2103120"/>
+          <p:nvPr/>
+        </p:nvSpPr>
+        <p:spPr>
+          <a:xfrm>
+            <a:off x="7498080" y="2423160"/>
+            <a:ext cx="4142232" cy="1280160"/>
+          </a:xfrm>
+          <a:prstGeom prst="roundRect">
+            <a:avLst>
+              <a:gd name="adj" fmla="val 10000"/>
+            </a:avLst>
+          </a:prstGeom>
+          <a:solidFill>
+            <a:schemeClr val="bg2"/>
+          </a:solidFill>
+          <a:ln/>
+        </p:spPr>
+      </p:sp>
+      <p:sp>
+        <p:nvSpPr>
+          <p:cNvPr id="9" name="Text 7"/>
+          <p:cNvSpPr txBox="1"/>
+          <p:nvPr/>
+        </p:nvSpPr>
+        <p:spPr>
+          <a:xfrm>
+            <a:off x="7726680" y="2606040"/>
+            <a:ext cx="3794760" cy="914400"/>
           </a:xfrm>
           <a:prstGeom prst="rect">
             <a:avLst/>
@@ -20065,25 +21003,168 @@
           <a:bodyPr wrap="square" lIns="0" tIns="0" rIns="0" bIns="0" rtlCol="0" anchor="t"/>
           <a:lstStyle/>
           <a:p>
-            <a:pPr algn="l" indent="0" marL="0">
-              <a:buNone/>
-            </a:pPr>
-            <a:endParaRPr lang="en-US" sz="5400" dirty="0"/>
-          </a:p>
-        </p:txBody>
-      </p:sp>
-      <p:sp>
-        <p:nvSpPr>
-          <p:cNvPr id="8" name="Text 0"/>
+            <a:pPr indent="0" marL="0">
+              <a:lnSpc>
+                <a:spcPct val="130000"/>
+              </a:lnSpc>
+              <a:buNone/>
+            </a:pPr>
+            <a:r>
+              <a:rPr lang="en-US" sz="1300" b="1" dirty="0">
+                <a:solidFill>
+                  <a:srgbClr val="C2410C"/>
+                </a:solidFill>
+                <a:latin typeface="Consolas" pitchFamily="34" charset="0"/>
+                <a:ea typeface="Consolas" pitchFamily="34" charset="-122"/>
+                <a:cs typeface="Consolas" pitchFamily="34" charset="-120"/>
+              </a:rPr>
+              <a:t>$ </a:t>
+            </a:r>
+            <a:pPr indent="0" marL="0">
+              <a:lnSpc>
+                <a:spcPct val="130000"/>
+              </a:lnSpc>
+              <a:buNone/>
+            </a:pPr>
+            <a:r>
+              <a:rPr lang="en-US" sz="1300" dirty="0">
+                <a:solidFill>
+                  <a:srgbClr val="383A42"/>
+                </a:solidFill>
+                <a:latin typeface="Consolas" pitchFamily="34" charset="0"/>
+                <a:ea typeface="Consolas" pitchFamily="34" charset="-122"/>
+                <a:cs typeface="Consolas" pitchFamily="34" charset="-120"/>
+              </a:rPr>
+              <a:t>conformance-test \</a:t>
+            </a:r>
+            <a:endParaRPr lang="en-US" sz="1300" dirty="0"/>
+          </a:p>
+          <a:p>
+            <a:pPr indent="0" marL="0">
+              <a:lnSpc>
+                <a:spcPct val="130000"/>
+              </a:lnSpc>
+              <a:buNone/>
+            </a:pPr>
+            <a:r>
+              <a:rPr lang="en-US" sz="1300" dirty="0">
+                <a:solidFill>
+                  <a:srgbClr val="383A42"/>
+                </a:solidFill>
+                <a:latin typeface="Consolas" pitchFamily="34" charset="0"/>
+                <a:ea typeface="Consolas" pitchFamily="34" charset="-122"/>
+                <a:cs typeface="Consolas" pitchFamily="34" charset="-120"/>
+              </a:rPr>
+              <a:t>    publisher yourdomain.dev</a:t>
+            </a:r>
+            <a:endParaRPr lang="en-US" sz="1300" dirty="0"/>
+          </a:p>
+        </p:txBody>
+      </p:sp>
+      <p:sp>
+        <p:nvSpPr>
+          <p:cNvPr id="10" name="Text 8"/>
+          <p:cNvSpPr txBox="1"/>
+          <p:nvPr/>
+        </p:nvSpPr>
+        <p:spPr>
+          <a:xfrm>
+            <a:off x="7498080" y="3767328"/>
+            <a:ext cx="4142232" cy="320040"/>
+          </a:xfrm>
+          <a:prstGeom prst="rect">
+            <a:avLst/>
+          </a:prstGeom>
+          <a:noFill/>
+          <a:ln/>
+        </p:spPr>
+        <p:txBody>
+          <a:bodyPr wrap="square" lIns="0" tIns="0" rIns="0" bIns="0" rtlCol="0" anchor="t"/>
+          <a:lstStyle/>
+          <a:p>
+            <a:pPr indent="0" marL="0">
+              <a:buNone/>
+            </a:pPr>
+            <a:r>
+              <a:rPr lang="en-US" sz="1200" dirty="0">
+                <a:solidFill>
+                  <a:schemeClr val="accent6"/>
+                </a:solidFill>
+              </a:rPr>
+              <a:t>From the ard-spec repo’s conformance folder</a:t>
+            </a:r>
+            <a:endParaRPr lang="en-US" sz="1200" dirty="0"/>
+          </a:p>
+        </p:txBody>
+      </p:sp>
+      <p:sp>
+        <p:nvSpPr>
+          <p:cNvPr id="11" name="Text 9"/>
+          <p:cNvSpPr txBox="1"/>
+          <p:nvPr/>
+        </p:nvSpPr>
+        <p:spPr>
+          <a:xfrm>
+            <a:off x="7498080" y="4251960"/>
+            <a:ext cx="4114800" cy="365760"/>
+          </a:xfrm>
+          <a:prstGeom prst="rect">
+            <a:avLst/>
+          </a:prstGeom>
+          <a:noFill/>
+          <a:ln/>
+        </p:spPr>
+        <p:txBody>
+          <a:bodyPr wrap="square" lIns="0" tIns="0" rIns="0" bIns="0" rtlCol="0" anchor="t"/>
+          <a:lstStyle/>
+          <a:p>
+            <a:pPr indent="0" marL="0">
+              <a:buNone/>
+            </a:pPr>
+            <a:r>
+              <a:rPr lang="en-US" sz="1700" b="1" dirty="0">
+                <a:solidFill>
+                  <a:schemeClr val="tx1"/>
+                </a:solidFill>
+              </a:rPr>
+              <a:t>3  Join in</a:t>
+            </a:r>
+            <a:endParaRPr lang="en-US" sz="1700" dirty="0"/>
+          </a:p>
+        </p:txBody>
+      </p:sp>
+      <p:sp>
+        <p:nvSpPr>
+          <p:cNvPr id="12" name="Join card"/>
           <p:cNvSpPr/>
-          <p:nvPr>
-            <p:ph idx="101" type="body" hasCustomPrompt="1"/>
-          </p:nvPr>
-        </p:nvSpPr>
-        <p:spPr>
-          <a:xfrm>
-            <a:off x="822960" y="4114800"/>
-            <a:ext cx="9692640" cy="1371600"/>
+          <p:nvPr/>
+        </p:nvSpPr>
+        <p:spPr>
+          <a:xfrm>
+            <a:off x="7498080" y="4709160"/>
+            <a:ext cx="4142232" cy="1371600"/>
+          </a:xfrm>
+          <a:prstGeom prst="roundRect">
+            <a:avLst>
+              <a:gd name="adj" fmla="val 9333"/>
+            </a:avLst>
+          </a:prstGeom>
+          <a:solidFill>
+            <a:schemeClr val="bg2"/>
+          </a:solidFill>
+          <a:ln/>
+        </p:spPr>
+      </p:sp>
+      <p:sp>
+        <p:nvSpPr>
+          <p:cNvPr id="13" name="Text 11"/>
+          <p:cNvSpPr txBox="1"/>
+          <p:nvPr/>
+        </p:nvSpPr>
+        <p:spPr>
+          <a:xfrm>
+            <a:off x="7726680" y="4800600"/>
+            <a:ext cx="3794760" cy="1188720"/>
           </a:xfrm>
           <a:prstGeom prst="rect">
             <a:avLst/>
@@ -20098,7 +21179,32 @@
             <a:pPr indent="0" marL="0">
               <a:buNone/>
             </a:pPr>
-            <a:endParaRPr lang="en-US" sz="1800" dirty="0"/>
+            <a:r>
+              <a:rPr lang="en-US" sz="1400" b="1" dirty="0">
+                <a:solidFill>
+                  <a:schemeClr val="accent2"/>
+                </a:solidFill>
+                <a:latin typeface="Consolas" pitchFamily="34" charset="0"/>
+                <a:ea typeface="Consolas" pitchFamily="34" charset="-122"/>
+                <a:cs typeface="Consolas" pitchFamily="34" charset="-120"/>
+              </a:rPr>
+              <a:t>github.com/ards-project/ard-spec</a:t>
+            </a:r>
+            <a:endParaRPr lang="en-US" sz="1400" dirty="0"/>
+          </a:p>
+          <a:p>
+            <a:pPr indent="0" marL="0">
+              <a:buNone/>
+            </a:pPr>
+            <a:r>
+              <a:rPr lang="en-US" sz="1400" dirty="0">
+                <a:solidFill>
+                  <a:schemeClr val="tx2"/>
+                </a:solidFill>
+              </a:rPr>
+              <a:t>Issues for spec changes. PRs welcome for examples, tooling and implementations.</a:t>
+            </a:r>
+            <a:endParaRPr lang="en-US" sz="1400" dirty="0"/>
           </a:p>
         </p:txBody>
       </p:sp>
@@ -20142,6 +21248,284 @@
             <a:fld id="{F7021451-1387-4CA6-816F-3879F97B5CBC}" type="slidenum">
               <a:rPr b="0" lang="en-US"/>
               <a:t>23</a:t>
+            </a:fld>
+            <a:endParaRPr lang="en-US"/>
+          </a:p>
+        </p:txBody>
+      </p:sp>
+    </p:spTree>
+  </p:cSld>
+  <p:clrMapOvr>
+    <a:masterClrMapping/>
+  </p:clrMapOvr>
+</p:sld>
+</file>
+
+<file path=ppt/slides/slide24.xml><?xml version="1.0" encoding="utf-8"?>
+<p:sld xmlns:a="http://schemas.openxmlformats.org/drawingml/2006/main" xmlns:r="http://schemas.openxmlformats.org/officeDocument/2006/relationships" xmlns:p="http://schemas.openxmlformats.org/presentationml/2006/main">
+  <p:cSld name="Slide 24">
+    <p:spTree>
+      <p:nvGrpSpPr>
+        <p:cNvPr id="1" name=""/>
+        <p:cNvGrpSpPr/>
+        <p:nvPr/>
+      </p:nvGrpSpPr>
+      <p:grpSpPr>
+        <a:xfrm>
+          <a:off x="0" y="0"/>
+          <a:ext cx="0" cy="0"/>
+          <a:chOff x="0" y="0"/>
+          <a:chExt cx="0" cy="0"/>
+        </a:xfrm>
+      </p:grpSpPr>
+      <p:sp>
+        <p:nvSpPr>
+          <p:cNvPr id="2" name="Lilac accent circle"/>
+          <p:cNvSpPr/>
+          <p:nvPr/>
+        </p:nvSpPr>
+        <p:spPr>
+          <a:xfrm>
+            <a:off x="8778240" y="3291840"/>
+            <a:ext cx="4206240" cy="4206240"/>
+          </a:xfrm>
+          <a:prstGeom prst="ellipse">
+            <a:avLst/>
+          </a:prstGeom>
+          <a:solidFill>
+            <a:schemeClr val="accent3">
+              <a:alpha val="55000"/>
+            </a:schemeClr>
+          </a:solidFill>
+          <a:ln/>
+        </p:spPr>
+      </p:sp>
+      <p:sp>
+        <p:nvSpPr>
+          <p:cNvPr id="3" name="Coral accent dot"/>
+          <p:cNvSpPr/>
+          <p:nvPr/>
+        </p:nvSpPr>
+        <p:spPr>
+          <a:xfrm>
+            <a:off x="10058400" y="640080"/>
+            <a:ext cx="1280160" cy="1280160"/>
+          </a:xfrm>
+          <a:prstGeom prst="ellipse">
+            <a:avLst/>
+          </a:prstGeom>
+          <a:solidFill>
+            <a:schemeClr val="accent1"/>
+          </a:solidFill>
+          <a:ln/>
+        </p:spPr>
+      </p:sp>
+      <p:sp>
+        <p:nvSpPr>
+          <p:cNvPr id="4" name="Text 2"/>
+          <p:cNvSpPr txBox="1"/>
+          <p:nvPr/>
+        </p:nvSpPr>
+        <p:spPr>
+          <a:xfrm>
+            <a:off x="822960" y="2331720"/>
+            <a:ext cx="7772400" cy="1097280"/>
+          </a:xfrm>
+          <a:prstGeom prst="rect">
+            <a:avLst/>
+          </a:prstGeom>
+          <a:noFill/>
+          <a:ln/>
+        </p:spPr>
+        <p:txBody>
+          <a:bodyPr wrap="square" lIns="0" tIns="0" rIns="0" bIns="0" rtlCol="0" anchor="ctr"/>
+          <a:lstStyle/>
+          <a:p>
+            <a:pPr indent="0" marL="0">
+              <a:buNone/>
+            </a:pPr>
+            <a:r>
+              <a:rPr lang="en-US" sz="6000" b="1" dirty="0">
+                <a:solidFill>
+                  <a:schemeClr val="tx1"/>
+                </a:solidFill>
+              </a:rPr>
+              <a:t>Thank you!</a:t>
+            </a:r>
+            <a:endParaRPr lang="en-US" sz="6000" dirty="0"/>
+          </a:p>
+        </p:txBody>
+      </p:sp>
+      <p:sp>
+        <p:nvSpPr>
+          <p:cNvPr id="5" name="Text 3"/>
+          <p:cNvSpPr txBox="1"/>
+          <p:nvPr/>
+        </p:nvSpPr>
+        <p:spPr>
+          <a:xfrm>
+            <a:off x="822960" y="3703320"/>
+            <a:ext cx="7772400" cy="1097280"/>
+          </a:xfrm>
+          <a:prstGeom prst="rect">
+            <a:avLst/>
+          </a:prstGeom>
+          <a:noFill/>
+          <a:ln/>
+        </p:spPr>
+        <p:txBody>
+          <a:bodyPr wrap="square" lIns="0" tIns="0" rIns="0" bIns="0" rtlCol="0" anchor="t"/>
+          <a:lstStyle/>
+          <a:p>
+            <a:pPr indent="0" marL="0">
+              <a:buNone/>
+            </a:pPr>
+            <a:r>
+              <a:rPr lang="en-US" sz="1800" b="1" dirty="0">
+                <a:solidFill>
+                  <a:schemeClr val="tx1"/>
+                </a:solidFill>
+              </a:rPr>
+              <a:t>Shaan Narendran  ·  github.com/ShaanNarendran</a:t>
+            </a:r>
+            <a:endParaRPr lang="en-US" sz="1800" dirty="0"/>
+          </a:p>
+          <a:p>
+            <a:pPr indent="0" marL="0">
+              <a:buNone/>
+            </a:pPr>
+            <a:r>
+              <a:rPr lang="en-US" sz="1800" dirty="0">
+                <a:solidFill>
+                  <a:schemeClr val="tx2"/>
+                </a:solidFill>
+                <a:latin typeface="Consolas" pitchFamily="34" charset="0"/>
+                <a:ea typeface="Consolas" pitchFamily="34" charset="-122"/>
+                <a:cs typeface="Consolas" pitchFamily="34" charset="-120"/>
+              </a:rPr>
+              <a:t>agenticresourcediscovery.org/spec</a:t>
+            </a:r>
+            <a:endParaRPr lang="en-US" sz="1800" dirty="0"/>
+          </a:p>
+          <a:p>
+            <a:pPr indent="0" marL="0">
+              <a:buNone/>
+            </a:pPr>
+            <a:r>
+              <a:rPr lang="en-US" sz="1800" dirty="0">
+                <a:solidFill>
+                  <a:schemeClr val="tx2"/>
+                </a:solidFill>
+                <a:latin typeface="Consolas" pitchFamily="34" charset="0"/>
+                <a:ea typeface="Consolas" pitchFamily="34" charset="-122"/>
+                <a:cs typeface="Consolas" pitchFamily="34" charset="-120"/>
+              </a:rPr>
+              <a:t>github.com/Observal/Observal</a:t>
+            </a:r>
+            <a:endParaRPr lang="en-US" sz="1800" dirty="0"/>
+          </a:p>
+        </p:txBody>
+      </p:sp>
+      <p:sp>
+        <p:nvSpPr>
+          <p:cNvPr id="7" name="Text 0"/>
+          <p:cNvSpPr/>
+          <p:nvPr>
+            <p:ph idx="100" type="title" hasCustomPrompt="1"/>
+          </p:nvPr>
+        </p:nvSpPr>
+        <p:spPr>
+          <a:xfrm>
+            <a:off x="822960" y="1828800"/>
+            <a:ext cx="10607040" cy="2103120"/>
+          </a:xfrm>
+          <a:prstGeom prst="rect">
+            <a:avLst/>
+          </a:prstGeom>
+          <a:noFill/>
+          <a:ln/>
+        </p:spPr>
+        <p:txBody>
+          <a:bodyPr wrap="square" lIns="0" tIns="0" rIns="0" bIns="0" rtlCol="0" anchor="t"/>
+          <a:lstStyle/>
+          <a:p>
+            <a:pPr algn="l" indent="0" marL="0">
+              <a:buNone/>
+            </a:pPr>
+            <a:endParaRPr lang="en-US" sz="5400" dirty="0"/>
+          </a:p>
+        </p:txBody>
+      </p:sp>
+      <p:sp>
+        <p:nvSpPr>
+          <p:cNvPr id="8" name="Text 0"/>
+          <p:cNvSpPr/>
+          <p:nvPr>
+            <p:ph idx="101" type="body" hasCustomPrompt="1"/>
+          </p:nvPr>
+        </p:nvSpPr>
+        <p:spPr>
+          <a:xfrm>
+            <a:off x="822960" y="4114800"/>
+            <a:ext cx="9692640" cy="1371600"/>
+          </a:xfrm>
+          <a:prstGeom prst="rect">
+            <a:avLst/>
+          </a:prstGeom>
+          <a:noFill/>
+          <a:ln/>
+        </p:spPr>
+        <p:txBody>
+          <a:bodyPr wrap="square" lIns="0" tIns="0" rIns="0" bIns="0" rtlCol="0" anchor="t"/>
+          <a:lstStyle/>
+          <a:p>
+            <a:pPr indent="0" marL="0">
+              <a:buNone/>
+            </a:pPr>
+            <a:endParaRPr lang="en-US" sz="1800" dirty="0"/>
+          </a:p>
+        </p:txBody>
+      </p:sp>
+      <p:sp>
+        <p:nvSpPr>
+          <p:cNvPr id="25" name="Slide Number Placeholder 0"/>
+          <p:cNvSpPr>
+            <a:spLocks noGrp="1"/>
+          </p:cNvSpPr>
+          <p:nvPr>
+            <p:ph type="sldNum" sz="quarter" idx="4294967295"/>
+          </p:nvPr>
+        </p:nvSpPr>
+        <p:spPr>
+          <a:xfrm>
+            <a:off x="11091672" y="6400800"/>
+            <a:ext cx="548640" cy="274320"/>
+          </a:xfrm>
+          <a:prstGeom prst="rect">
+            <a:avLst/>
+          </a:prstGeom>
+          <a:extLst>
+            <a:ext uri="{C572A759-6A51-4108-AA02-DFA0A04FC94B}">
+              <ma14:wrappingTextBoxFlag xmlns:ma14="http://schemas.microsoft.com/office/mac/drawingml/2011/main" val="0"/>
+            </a:ext>
+          </a:extLst>
+        </p:spPr>
+        <p:txBody>
+          <a:bodyPr/>
+          <a:lstStyle>
+            <a:lvl1pPr>
+              <a:defRPr sz="1000">
+                <a:solidFill>
+                  <a:schemeClr val="accent6"/>
+                </a:solidFill>
+              </a:defRPr>
+            </a:lvl1pPr>
+          </a:lstStyle>
+          <a:p>
+            <a:pPr algn="r"/>
+            <a:fld id="{F7021451-1387-4CA6-816F-3879F97B5CBC}" type="slidenum">
+              <a:rPr b="0" lang="en-US"/>
+              <a:t>24</a:t>
             </a:fld>
             <a:endParaRPr lang="en-US"/>
           </a:p>

</xml_diff>